<commit_message>
Add corrected Board slide 3 as a separate file; fix client-count finding
Board figures are as at 28 Sep and recalculate correctly; only the slide 3
subtitle date was wrong. The one-slide update file keeps the Board layout.
CEO slide 4 and the audit files no longer list the client count as a
conflict, and treat the dashboard figure as AUM rather than deposits.

Co-Authored-By: Claude Opus 5.5 <noreply@anthropic.com>
Claude-Session: https://claude.ai/code/session_01SNf1Edf2HMYqmZpheYf6i6
</commit_message>
<xml_diff>
--- a/emyaa-ceo-deck/output/final-deck/eMYAA-Marketing-Update-01.10.2026-CEO-Redesigned.pptx
+++ b/emyaa-ceo-deck/output/final-deck/eMYAA-Marketing-Update-01.10.2026-CEO-Redesigned.pptx
@@ -1152,7 +1152,7 @@
           <a:p>
             <a:r>
               <a:rPr lang="en-US" dirty="0"/>
-              <a:t>Decision 2 follows from the GA4 campaign export: Arabic has a lower engagement rate (86.9% vs 97.2%) but more key events per session (1.05 vs 0.94). Decision 3 follows from the dashboards: +36 downloads but +3 onboarded in the first six days of paid testing. Open items: deposits $12,206 (Board, verbal from Malek) vs $10,029.69 on the dashboard (relabelled 'Total AUM' from 20 Sep) vs $11,195.88 in the KPI workbook; clients 61 on the Board 'as at 17 Sep' vs 54 on the 17 Sep dashboard and 60 on 27 Sep; no Ignite spend, cost per key event or LinkedIn lead data, and the key event is undefined; no September social exports; the 793% active-user rise (GA card, prior week implied) and LinkedIn +118% / +155% are not traceable to an export; LinkedIn followers 531 vs 586; $5,000 campaign T&amp;Cs sent for approval on 20 Jul with no sign-off on file. Market Pulse: in-app feature in discussion (Exante data access).</a:t>
+              <a:t>Decision 2 follows from the GA4 campaign export: Arabic has a lower engagement rate (86.9% vs 97.2%) but more key events per session (1.05 vs 0.94). Decision 3 follows from the dashboards: +36 downloads but +3 onboarded in the first six days of paid testing. Open items: gross deposits of $12,206 rest on Malek's message of 29 Sep with no written export (the dashboard's $10,029.69 is assets under management, a different measure; the Board shows both); the Board figures (61 clients, $12,206) are as at 28 Sep, and Board slide 3 wrongly says 'as at 17 September', corrected in the separate Board update file; no Ignite spend, cost per key event or LinkedIn lead data, and the key event is undefined; no September social exports; the 793% active-user rise (GA card, prior week implied) and LinkedIn +118% / +155% are not traceable to an export; LinkedIn followers 531 vs 586; $5,000 campaign T&amp;Cs sent for approval on 20 Jul with no sign-off on file. Market Pulse: in-app feature in discussion (Exante data access).</a:t>
             </a:r>
             <a:endParaRPr lang="en-US" dirty="0"/>
           </a:p>
@@ -5213,7 +5213,7 @@
                 <a:ea typeface="Exo 2" pitchFamily="34" charset="-122"/>
                 <a:cs typeface="Exo 2" pitchFamily="34" charset="-120"/>
               </a:rPr>
-              <a:t>Five decisions for today; three open data items must close before 20 October</a:t>
+              <a:t>Five decisions for today; one open data item blocks the 20 October call</a:t>
             </a:r>
             <a:endParaRPr lang="en-US" sz="2000" dirty="0"/>
           </a:p>
@@ -5340,7 +5340,7 @@
                 <a:ea typeface="Exo 2" pitchFamily="34" charset="-122"/>
                 <a:cs typeface="Exo 2" pitchFamily="34" charset="-120"/>
               </a:rPr>
-              <a:t>Decision 4 closes most of the open items. The three marked 'Blocks 20 Oct' must close before the paid-media call.</a:t>
+              <a:t>Ignite must supply spend and lead data before 20 October. Decision 4 closes most of the other open items.</a:t>
             </a:r>
             <a:endParaRPr lang="en-US" sz="1150" dirty="0"/>
           </a:p>
@@ -6770,7 +6770,7 @@
                           <a:ea typeface="Exo 2" pitchFamily="34" charset="-122"/>
                           <a:cs typeface="Exo 2" pitchFamily="34" charset="-120"/>
                         </a:rPr>
-                        <a:t>Deposits: three different figures; Board $12,206 is verbal</a:t>
+                        <a:t>No ad spend, LinkedIn leads or key-event definition</a:t>
                       </a:r>
                       <a:endParaRPr lang="en-US" sz="950" dirty="0">
                         <a:latin typeface="Exo 2" charset="0"/>
@@ -6866,7 +6866,7 @@
                           <a:ea typeface="Exo 2" pitchFamily="34" charset="-122"/>
                           <a:cs typeface="Exo 2" pitchFamily="34" charset="-120"/>
                         </a:rPr>
-                        <a:t>Clients: Board 61 vs dashboard 54 on 17 Sep</a:t>
+                        <a:t>Deposits: $12,206 has no written export yet</a:t>
                       </a:r>
                       <a:endParaRPr lang="en-US" sz="950" dirty="0">
                         <a:latin typeface="Exo 2" charset="0"/>
@@ -6907,13 +6907,13 @@
                       <a:r>
                         <a:rPr lang="en-US" sz="950" b="1" dirty="0">
                           <a:solidFill>
-                            <a:srgbClr val="C53030"/>
-                          </a:solidFill>
-                          <a:latin typeface="Exo 2" pitchFamily="34" charset="0"/>
-                          <a:ea typeface="Exo 2" pitchFamily="34" charset="-122"/>
-                          <a:cs typeface="Exo 2" pitchFamily="34" charset="-120"/>
-                        </a:rPr>
-                        <a:t>Blocks 20 Oct</a:t>
+                            <a:srgbClr val="9A7B1F"/>
+                          </a:solidFill>
+                          <a:latin typeface="Exo 2" pitchFamily="34" charset="0"/>
+                          <a:ea typeface="Exo 2" pitchFamily="34" charset="-122"/>
+                          <a:cs typeface="Exo 2" pitchFamily="34" charset="-120"/>
+                        </a:rPr>
+                        <a:t>Open</a:t>
                       </a:r>
                       <a:endParaRPr lang="en-US" sz="950" dirty="0">
                         <a:latin typeface="Exo 2" charset="0"/>
@@ -6962,7 +6962,7 @@
                           <a:ea typeface="Exo 2" pitchFamily="34" charset="-122"/>
                           <a:cs typeface="Exo 2" pitchFamily="34" charset="-120"/>
                         </a:rPr>
-                        <a:t>No ad spend, LinkedIn leads or key-event definition</a:t>
+                        <a:t>No September exports for social channels</a:t>
                       </a:r>
                       <a:endParaRPr lang="en-US" sz="950" dirty="0">
                         <a:latin typeface="Exo 2" charset="0"/>
@@ -7003,13 +7003,13 @@
                       <a:r>
                         <a:rPr lang="en-US" sz="950" b="1" dirty="0">
                           <a:solidFill>
-                            <a:srgbClr val="C53030"/>
-                          </a:solidFill>
-                          <a:latin typeface="Exo 2" pitchFamily="34" charset="0"/>
-                          <a:ea typeface="Exo 2" pitchFamily="34" charset="-122"/>
-                          <a:cs typeface="Exo 2" pitchFamily="34" charset="-120"/>
-                        </a:rPr>
-                        <a:t>Blocks 20 Oct</a:t>
+                            <a:srgbClr val="9A7B1F"/>
+                          </a:solidFill>
+                          <a:latin typeface="Exo 2" pitchFamily="34" charset="0"/>
+                          <a:ea typeface="Exo 2" pitchFamily="34" charset="-122"/>
+                          <a:cs typeface="Exo 2" pitchFamily="34" charset="-120"/>
+                        </a:rPr>
+                        <a:t>Open</a:t>
                       </a:r>
                       <a:endParaRPr lang="en-US" sz="950" dirty="0">
                         <a:latin typeface="Exo 2" charset="0"/>
@@ -7058,7 +7058,7 @@
                           <a:ea typeface="Exo 2" pitchFamily="34" charset="-122"/>
                           <a:cs typeface="Exo 2" pitchFamily="34" charset="-120"/>
                         </a:rPr>
-                        <a:t>No September exports for social channels</a:t>
+                        <a:t>793% and LinkedIn +118% / +155% not exported</a:t>
                       </a:r>
                       <a:endParaRPr lang="en-US" sz="950" dirty="0">
                         <a:latin typeface="Exo 2" charset="0"/>
@@ -7154,7 +7154,7 @@
                           <a:ea typeface="Exo 2" pitchFamily="34" charset="-122"/>
                           <a:cs typeface="Exo 2" pitchFamily="34" charset="-120"/>
                         </a:rPr>
-                        <a:t>793% and LinkedIn +118% / +155% not exported</a:t>
+                        <a:t>LinkedIn followers: 531 vs 586</a:t>
                       </a:r>
                       <a:endParaRPr lang="en-US" sz="950" dirty="0">
                         <a:latin typeface="Exo 2" charset="0"/>
@@ -7250,7 +7250,7 @@
                           <a:ea typeface="Exo 2" pitchFamily="34" charset="-122"/>
                           <a:cs typeface="Exo 2" pitchFamily="34" charset="-120"/>
                         </a:rPr>
-                        <a:t>LinkedIn followers: 531 vs 586</a:t>
+                        <a:t>$5,000 campaign T&amp;C sign-off not on file</a:t>
                       </a:r>
                       <a:endParaRPr lang="en-US" sz="950" dirty="0">
                         <a:latin typeface="Exo 2" charset="0"/>
@@ -7346,7 +7346,7 @@
                           <a:ea typeface="Exo 2" pitchFamily="34" charset="-122"/>
                           <a:cs typeface="Exo 2" pitchFamily="34" charset="-120"/>
                         </a:rPr>
-                        <a:t>$5,000 campaign T&amp;C sign-off not on file</a:t>
+                        <a:t>Board slide 3 date: 17 Sep should read 28 Sep</a:t>
                       </a:r>
                       <a:endParaRPr lang="en-US" sz="950" dirty="0">
                         <a:latin typeface="Exo 2" charset="0"/>
@@ -7387,13 +7387,13 @@
                       <a:r>
                         <a:rPr lang="en-US" sz="950" b="1" dirty="0">
                           <a:solidFill>
-                            <a:srgbClr val="9A7B1F"/>
-                          </a:solidFill>
-                          <a:latin typeface="Exo 2" pitchFamily="34" charset="0"/>
-                          <a:ea typeface="Exo 2" pitchFamily="34" charset="-122"/>
-                          <a:cs typeface="Exo 2" pitchFamily="34" charset="-120"/>
-                        </a:rPr>
-                        <a:t>Open</a:t>
+                            <a:srgbClr val="1BA97C"/>
+                          </a:solidFill>
+                          <a:latin typeface="Exo 2" pitchFamily="34" charset="0"/>
+                          <a:ea typeface="Exo 2" pitchFamily="34" charset="-122"/>
+                          <a:cs typeface="Exo 2" pitchFamily="34" charset="-120"/>
+                        </a:rPr>
+                        <a:t>Fixed</a:t>
                       </a:r>
                       <a:endParaRPr lang="en-US" sz="950" dirty="0">
                         <a:latin typeface="Exo 2" charset="0"/>

</xml_diff>

<commit_message>
Add Google Ads and installs slide and English vs Arabic slide (6 slides)
Slide 4: daily cumulative installs with the 22 Sep launch marked and an
ad-to-account funnel that shows the install tracking gap. Slide 5: English
vs Arabic campaign cards and a diverging chart of nine GA4 measures.
Percentage audit and docs updated.

Co-Authored-By: Claude Opus 5.5 <noreply@anthropic.com>
Claude-Session: https://claude.ai/code/session_01SNf1Edf2HMYqmZpheYf6i6
</commit_message>
<xml_diff>
--- a/emyaa-ceo-deck/output/final-deck/eMYAA-Marketing-Update-01.10.2026-CEO-Redesigned.pptx
+++ b/emyaa-ceo-deck/output/final-deck/eMYAA-Marketing-Update-01.10.2026-CEO-Redesigned.pptx
@@ -9,19 +9,21 @@
     <p:sldId id="257" r:id="rId3"/>
     <p:sldId id="258" r:id="rId4"/>
     <p:sldId id="259" r:id="rId5"/>
+    <p:sldId id="260" r:id="rId6"/>
+    <p:sldId id="261" r:id="rId7"/>
   </p:sldIdLst>
   <p:notesMasterIdLst>
-    <p:notesMasterId r:id="rId6"/>
+    <p:notesMasterId r:id="rId8"/>
   </p:notesMasterIdLst>
   <p:sldSz cx="12192000" cy="6858000"/>
   <p:notesSz cx="6858000" cy="12192000"/>
   <p:embeddedFontLst>
     <p:embeddedFont>
       <p:font typeface="Exo 2" charset="0"/>
-      <p:regular r:id="rId11"/>
-      <p:bold r:id="rId12"/>
-      <p:italic r:id="rId13"/>
-      <p:boldItalic r:id="rId14"/>
+      <p:regular r:id="rId13"/>
+      <p:bold r:id="rId14"/>
+      <p:italic r:id="rId15"/>
+      <p:boldItalic r:id="rId16"/>
     </p:embeddedFont>
   </p:embeddedFontLst>
   <p:defaultTextStyle>
@@ -493,6 +495,816 @@
 </c:chartSpace>
 </file>
 
+<file path=ppt/charts/chart2.xml><?xml version="1.0" encoding="utf-8"?>
+<c:chartSpace xmlns:c="http://schemas.openxmlformats.org/drawingml/2006/chart" xmlns:a="http://schemas.openxmlformats.org/drawingml/2006/main" xmlns:r="http://schemas.openxmlformats.org/officeDocument/2006/relationships">
+  <c:date1904 val="0"/>
+  <c:roundedCorners val="1"/>
+  <c:chart>
+    <c:title>
+      <c:tx>
+        <c:rich>
+          <a:bodyPr/>
+          <a:lstStyle/>
+          <a:p>
+            <a:pPr>
+              <a:defRPr sz="1100" b="0" i="0" u="none" strike="noStrike">
+                <a:solidFill>
+                  <a:srgbClr val="132257"/>
+                </a:solidFill>
+                <a:latin typeface="Exo 2"/>
+              </a:defRPr>
+            </a:pPr>
+            <a:r>
+              <a:rPr sz="1100" b="0" i="0" u="none" strike="noStrike">
+                <a:solidFill>
+                  <a:srgbClr val="132257"/>
+                </a:solidFill>
+                <a:latin typeface="Exo 2"/>
+              </a:rPr>
+              <a:t>App installs, cumulative (Android + iOS), by dashboard report date</a:t>
+            </a:r>
+          </a:p>
+        </c:rich>
+      </c:tx>
+      <c:layout/>
+      <c:overlay val="0"/>
+    </c:title>
+    <c:autoTitleDeleted val="0"/>
+    <c:plotArea>
+      <c:layout/>
+      <c:lineChart>
+        <c:varyColors val="0"/>
+        <c:ser>
+          <c:idx val="0"/>
+          <c:order val="0"/>
+          <c:tx>
+            <c:strRef>
+              <c:f>Sheet1!$B$1</c:f>
+              <c:strCache>
+                <c:ptCount val="1"/>
+                <c:pt idx="0">
+                  <c:v>App installs, cumulative</c:v>
+                </c:pt>
+              </c:strCache>
+            </c:strRef>
+          </c:tx>
+          <c:spPr>
+            <a:solidFill>
+              <a:srgbClr val="132257"/>
+            </a:solidFill>
+            <a:ln w="31750" cap="flat">
+              <a:solidFill>
+                <a:srgbClr val="132257"/>
+              </a:solidFill>
+              <a:prstDash val="solid"/>
+              <a:round/>
+            </a:ln>
+            <a:effectLst/>
+          </c:spPr>
+          <c:invertIfNegative val="0"/>
+          <c:dLbls>
+            <c:numFmt formatCode="#,##0" sourceLinked="0"/>
+            <c:txPr>
+              <a:bodyPr/>
+              <a:lstStyle/>
+              <a:p>
+                <a:pPr>
+                  <a:defRPr b="0" i="0" strike="noStrike" sz="1000" u="none">
+                    <a:solidFill>
+                      <a:srgbClr val="132257"/>
+                    </a:solidFill>
+                    <a:latin typeface="Exo 2"/>
+                  </a:defRPr>
+                </a:pPr>
+              </a:p>
+            </c:txPr>
+            <c:showLegendKey val="0"/>
+            <c:showVal val="0"/>
+            <c:showCatName val="0"/>
+            <c:showSerName val="0"/>
+            <c:showPercent val="0"/>
+            <c:showBubbleSize val="0"/>
+            <c:showLeaderLines val="0"/>
+          </c:dLbls>
+          <c:marker>
+            <c:symbol val="circle"/>
+            <c:size val="6"/>
+            <c:spPr>
+              <a:solidFill>
+                <a:srgbClr val="132257"/>
+              </a:solidFill>
+              <a:ln w="9525" cap="flat">
+                <a:solidFill>
+                  <a:srgbClr val="132257"/>
+                </a:solidFill>
+                <a:prstDash val="solid"/>
+                <a:round/>
+              </a:ln>
+              <a:effectLst/>
+            </c:spPr>
+          </c:marker>
+          <c:cat>
+            <c:multiLvlStrRef>
+              <c:f>Sheet1!$A$2:$A$17</c:f>
+              <c:multiLvlStrCache>
+                <c:ptCount val="16"/>
+                <c:lvl>
+                  <c:pt idx="0">
+                    <c:v>1 Sep</c:v>
+                  </c:pt>
+                  <c:pt idx="1">
+                    <c:v>2</c:v>
+                  </c:pt>
+                  <c:pt idx="2">
+                    <c:v>3</c:v>
+                  </c:pt>
+                  <c:pt idx="3">
+                    <c:v>8</c:v>
+                  </c:pt>
+                  <c:pt idx="4">
+                    <c:v>9</c:v>
+                  </c:pt>
+                  <c:pt idx="5">
+                    <c:v>10</c:v>
+                  </c:pt>
+                  <c:pt idx="6">
+                    <c:v>13</c:v>
+                  </c:pt>
+                  <c:pt idx="7">
+                    <c:v>14</c:v>
+                  </c:pt>
+                  <c:pt idx="8">
+                    <c:v>16</c:v>
+                  </c:pt>
+                  <c:pt idx="9">
+                    <c:v>17</c:v>
+                  </c:pt>
+                  <c:pt idx="10">
+                    <c:v>20</c:v>
+                  </c:pt>
+                  <c:pt idx="11">
+                    <c:v>21</c:v>
+                  </c:pt>
+                  <c:pt idx="12">
+                    <c:v>22 Sep: ads live</c:v>
+                  </c:pt>
+                  <c:pt idx="13">
+                    <c:v>23</c:v>
+                  </c:pt>
+                  <c:pt idx="14">
+                    <c:v>24</c:v>
+                  </c:pt>
+                  <c:pt idx="15">
+                    <c:v>27 Sep</c:v>
+                  </c:pt>
+                </c:lvl>
+              </c:multiLvlStrCache>
+            </c:multiLvlStrRef>
+          </c:cat>
+          <c:val>
+            <c:numRef>
+              <c:f>Sheet1!$B$2:$B$17</c:f>
+              <c:numCache>
+                <c:formatCode>General</c:formatCode>
+                <c:ptCount val="16"/>
+                <c:pt idx="0">
+                  <c:v>373</c:v>
+                </c:pt>
+                <c:pt idx="1">
+                  <c:v>389</c:v>
+                </c:pt>
+                <c:pt idx="2">
+                  <c:v>395</c:v>
+                </c:pt>
+                <c:pt idx="3">
+                  <c:v>403</c:v>
+                </c:pt>
+                <c:pt idx="4">
+                  <c:v>410</c:v>
+                </c:pt>
+                <c:pt idx="5">
+                  <c:v>414</c:v>
+                </c:pt>
+                <c:pt idx="6">
+                  <c:v>419</c:v>
+                </c:pt>
+                <c:pt idx="7">
+                  <c:v>423</c:v>
+                </c:pt>
+                <c:pt idx="8">
+                  <c:v>430</c:v>
+                </c:pt>
+                <c:pt idx="9">
+                  <c:v>432</c:v>
+                </c:pt>
+                <c:pt idx="10">
+                  <c:v>437</c:v>
+                </c:pt>
+                <c:pt idx="11">
+                  <c:v>437</c:v>
+                </c:pt>
+                <c:pt idx="12">
+                  <c:v>452</c:v>
+                </c:pt>
+                <c:pt idx="13">
+                  <c:v>454</c:v>
+                </c:pt>
+                <c:pt idx="14">
+                  <c:v>455</c:v>
+                </c:pt>
+                <c:pt idx="15">
+                  <c:v>473</c:v>
+                </c:pt>
+              </c:numCache>
+            </c:numRef>
+          </c:val>
+          <c:smooth val="0"/>
+        </c:ser>
+        <c:dLbls>
+          <c:numFmt formatCode="#,##0" sourceLinked="0"/>
+          <c:txPr>
+            <a:bodyPr/>
+            <a:lstStyle/>
+            <a:p>
+              <a:pPr>
+                <a:defRPr b="0" i="0" strike="noStrike" sz="1000" u="none">
+                  <a:solidFill>
+                    <a:srgbClr val="132257"/>
+                  </a:solidFill>
+                  <a:latin typeface="Exo 2"/>
+                </a:defRPr>
+              </a:pPr>
+            </a:p>
+          </c:txPr>
+          <c:showLegendKey val="0"/>
+          <c:showVal val="0"/>
+          <c:showCatName val="0"/>
+          <c:showSerName val="0"/>
+          <c:showPercent val="0"/>
+          <c:showBubbleSize val="0"/>
+          <c:showLeaderLines val="0"/>
+        </c:dLbls>
+        <c:marker val="1"/>
+        <c:axId val="2094734554"/>
+        <c:axId val="2094734552"/>
+        <c:axId val="2094734556"/>
+      </c:lineChart>
+      <c:catAx>
+        <c:axId val="2094734554"/>
+        <c:scaling>
+          <c:orientation val="minMax"/>
+        </c:scaling>
+        <c:delete val="0"/>
+        <c:axPos val="b"/>
+        <c:numFmt formatCode="General" sourceLinked="1"/>
+        <c:majorTickMark val="out"/>
+        <c:minorTickMark val="none"/>
+        <c:tickLblPos val="low"/>
+        <c:spPr>
+          <a:ln w="12700" cap="flat">
+            <a:solidFill>
+              <a:srgbClr val="888888"/>
+            </a:solidFill>
+            <a:prstDash val="solid"/>
+            <a:round/>
+          </a:ln>
+        </c:spPr>
+        <c:txPr>
+          <a:bodyPr/>
+          <a:lstStyle/>
+          <a:p>
+            <a:pPr>
+              <a:defRPr sz="850" b="0" i="0" u="none" strike="noStrike">
+                <a:solidFill>
+                  <a:srgbClr val="7A849C"/>
+                </a:solidFill>
+                <a:latin typeface="Exo 2"/>
+              </a:defRPr>
+            </a:pPr>
+            <a:endParaRPr lang="en-US"/>
+          </a:p>
+        </c:txPr>
+        <c:crossAx val="2094734552"/>
+        <c:crosses val="autoZero"/>
+        <c:auto val="1"/>
+        <c:lblAlgn val="ctr"/>
+        <c:noMultiLvlLbl val="1"/>
+      </c:catAx>
+      <c:valAx>
+        <c:axId val="2094734552"/>
+        <c:scaling>
+          <c:orientation val="minMax"/>
+          <c:max val="480"/>
+          <c:min val="360"/>
+        </c:scaling>
+        <c:delete val="0"/>
+        <c:axPos val="l"/>
+        <c:majorGridlines>
+          <c:spPr>
+            <a:ln w="6350" cap="flat">
+              <a:solidFill>
+                <a:srgbClr val="E6EAF2"/>
+              </a:solidFill>
+              <a:prstDash val="solid"/>
+              <a:round/>
+            </a:ln>
+          </c:spPr>
+        </c:majorGridlines>
+        <c:numFmt formatCode="General" sourceLinked="0"/>
+        <c:majorTickMark val="out"/>
+        <c:minorTickMark val="none"/>
+        <c:tickLblPos val="nextTo"/>
+        <c:spPr>
+          <a:ln w="12700" cap="flat">
+            <a:solidFill>
+              <a:srgbClr val="888888"/>
+            </a:solidFill>
+            <a:prstDash val="solid"/>
+            <a:round/>
+          </a:ln>
+        </c:spPr>
+        <c:txPr>
+          <a:bodyPr/>
+          <a:lstStyle/>
+          <a:p>
+            <a:pPr>
+              <a:defRPr sz="900" b="0" i="0" u="none" strike="noStrike">
+                <a:solidFill>
+                  <a:srgbClr val="7A849C"/>
+                </a:solidFill>
+                <a:latin typeface="Exo 2"/>
+              </a:defRPr>
+            </a:pPr>
+            <a:endParaRPr lang="en-US"/>
+          </a:p>
+        </c:txPr>
+        <c:crossAx val="2094734554"/>
+        <c:crosses val="autoZero"/>
+        <c:crossBetween val="between"/>
+        <c:majorUnit val="30"/>
+      </c:valAx>
+      <c:spPr>
+        <a:noFill/>
+        <a:ln>
+          <a:noFill/>
+        </a:ln>
+        <a:effectLst/>
+      </c:spPr>
+    </c:plotArea>
+    <c:plotVisOnly val="1"/>
+    <c:dispBlanksAs val="span"/>
+  </c:chart>
+  <c:spPr>
+    <a:noFill/>
+    <a:ln>
+      <a:noFill/>
+    </a:ln>
+    <a:effectLst/>
+  </c:spPr>
+  <c:externalData r:id="rId1">
+    <c:autoUpdate val="0"/>
+  </c:externalData>
+</c:chartSpace>
+</file>
+
+<file path=ppt/charts/chart3.xml><?xml version="1.0" encoding="utf-8"?>
+<c:chartSpace xmlns:c="http://schemas.openxmlformats.org/drawingml/2006/chart" xmlns:a="http://schemas.openxmlformats.org/drawingml/2006/main" xmlns:r="http://schemas.openxmlformats.org/officeDocument/2006/relationships">
+  <c:date1904 val="0"/>
+  <c:roundedCorners val="1"/>
+  <c:chart>
+    <c:title>
+      <c:tx>
+        <c:rich>
+          <a:bodyPr/>
+          <a:lstStyle/>
+          <a:p>
+            <a:pPr>
+              <a:defRPr sz="1100" b="0" i="0" u="none" strike="noStrike">
+                <a:solidFill>
+                  <a:srgbClr val="132257"/>
+                </a:solidFill>
+                <a:latin typeface="Exo 2"/>
+              </a:defRPr>
+            </a:pPr>
+            <a:r>
+              <a:rPr sz="1100" b="0" i="0" u="none" strike="noStrike">
+                <a:solidFill>
+                  <a:srgbClr val="132257"/>
+                </a:solidFill>
+                <a:latin typeface="Exo 2"/>
+              </a:rPr>
+              <a:t>English relative to Arabic, % difference, 1-28 Sep</a:t>
+            </a:r>
+          </a:p>
+        </c:rich>
+      </c:tx>
+      <c:layout/>
+      <c:overlay val="0"/>
+    </c:title>
+    <c:autoTitleDeleted val="0"/>
+    <c:plotArea>
+      <c:layout/>
+      <c:barChart>
+        <c:barDir val="bar"/>
+        <c:grouping val="stacked"/>
+        <c:varyColors val="0"/>
+        <c:ser>
+          <c:idx val="0"/>
+          <c:order val="0"/>
+          <c:tx>
+            <c:strRef>
+              <c:f>Sheet1!$B$1</c:f>
+              <c:strCache>
+                <c:ptCount val="1"/>
+                <c:pt idx="0">
+                  <c:v>English ahead</c:v>
+                </c:pt>
+              </c:strCache>
+            </c:strRef>
+          </c:tx>
+          <c:spPr>
+            <a:solidFill>
+              <a:srgbClr val="132257"/>
+            </a:solidFill>
+            <a:effectLst/>
+          </c:spPr>
+          <c:invertIfNegative val="0"/>
+          <c:dLbls>
+            <c:numFmt formatCode="+0.0&quot;%&quot;;-0.0&quot;%&quot;;;" sourceLinked="0"/>
+            <c:txPr>
+              <a:bodyPr/>
+              <a:lstStyle/>
+              <a:p>
+                <a:pPr>
+                  <a:defRPr b="1" i="0" strike="noStrike" sz="1000" u="none">
+                    <a:solidFill>
+                      <a:srgbClr val="FFFFFF"/>
+                    </a:solidFill>
+                    <a:latin typeface="Exo 2"/>
+                  </a:defRPr>
+                </a:pPr>
+              </a:p>
+            </c:txPr>
+            <c:dLblPos val="inEnd"/>
+            <c:showLegendKey val="0"/>
+            <c:showVal val="1"/>
+            <c:showCatName val="0"/>
+            <c:showSerName val="0"/>
+            <c:showPercent val="0"/>
+            <c:showBubbleSize val="0"/>
+            <c:showLeaderLines val="0"/>
+          </c:dLbls>
+          <c:cat>
+            <c:multiLvlStrRef>
+              <c:f>Sheet1!$A$2:$A$10</c:f>
+              <c:multiLvlStrCache>
+                <c:ptCount val="9"/>
+                <c:lvl>
+                  <c:pt idx="0">
+                    <c:v>Sessions</c:v>
+                  </c:pt>
+                  <c:pt idx="1">
+                    <c:v>Active users</c:v>
+                  </c:pt>
+                  <c:pt idx="2">
+                    <c:v>Engaged sessions</c:v>
+                  </c:pt>
+                  <c:pt idx="3">
+                    <c:v>Engagement rate</c:v>
+                  </c:pt>
+                  <c:pt idx="4">
+                    <c:v>Time per session</c:v>
+                  </c:pt>
+                  <c:pt idx="5">
+                    <c:v>Events per session</c:v>
+                  </c:pt>
+                  <c:pt idx="6">
+                    <c:v>Total events</c:v>
+                  </c:pt>
+                  <c:pt idx="7">
+                    <c:v>Key events</c:v>
+                  </c:pt>
+                  <c:pt idx="8">
+                    <c:v>Key events per session</c:v>
+                  </c:pt>
+                </c:lvl>
+              </c:multiLvlStrCache>
+            </c:multiLvlStrRef>
+          </c:cat>
+          <c:val>
+            <c:numRef>
+              <c:f>Sheet1!$B$2:$B$10</c:f>
+              <c:numCache>
+                <c:formatCode>General</c:formatCode>
+                <c:ptCount val="9"/>
+                <c:pt idx="0">
+                  <c:v>20.5</c:v>
+                </c:pt>
+                <c:pt idx="1">
+                  <c:v>18.9</c:v>
+                </c:pt>
+                <c:pt idx="2">
+                  <c:v>34.6</c:v>
+                </c:pt>
+                <c:pt idx="3">
+                  <c:v>11.8</c:v>
+                </c:pt>
+                <c:pt idx="4">
+                  <c:v>24.2</c:v>
+                </c:pt>
+                <c:pt idx="5">
+                  <c:v>19.2</c:v>
+                </c:pt>
+                <c:pt idx="6">
+                  <c:v>43.6</c:v>
+                </c:pt>
+                <c:pt idx="7">
+                  <c:v>8.1</c:v>
+                </c:pt>
+                <c:pt idx="8">
+                  <c:v>0</c:v>
+                </c:pt>
+              </c:numCache>
+            </c:numRef>
+          </c:val>
+        </c:ser>
+        <c:ser>
+          <c:idx val="1"/>
+          <c:order val="1"/>
+          <c:tx>
+            <c:strRef>
+              <c:f>Sheet1!$C$1</c:f>
+              <c:strCache>
+                <c:ptCount val="1"/>
+                <c:pt idx="0">
+                  <c:v>Arabic ahead</c:v>
+                </c:pt>
+              </c:strCache>
+            </c:strRef>
+          </c:tx>
+          <c:spPr>
+            <a:solidFill>
+              <a:srgbClr val="D4AF37"/>
+            </a:solidFill>
+            <a:effectLst/>
+          </c:spPr>
+          <c:invertIfNegative val="0"/>
+          <c:dLbls>
+            <c:numFmt formatCode="+0.0&quot;%&quot;;-0.0&quot;%&quot;;;" sourceLinked="0"/>
+            <c:txPr>
+              <a:bodyPr/>
+              <a:lstStyle/>
+              <a:p>
+                <a:pPr>
+                  <a:defRPr b="1" i="0" strike="noStrike" sz="1000" u="none">
+                    <a:solidFill>
+                      <a:srgbClr val="FFFFFF"/>
+                    </a:solidFill>
+                    <a:latin typeface="Exo 2"/>
+                  </a:defRPr>
+                </a:pPr>
+              </a:p>
+            </c:txPr>
+            <c:dLblPos val="inEnd"/>
+            <c:showLegendKey val="0"/>
+            <c:showVal val="1"/>
+            <c:showCatName val="0"/>
+            <c:showSerName val="0"/>
+            <c:showPercent val="0"/>
+            <c:showBubbleSize val="0"/>
+            <c:showLeaderLines val="0"/>
+          </c:dLbls>
+          <c:cat>
+            <c:multiLvlStrRef>
+              <c:f>Sheet1!$A$2:$A$10</c:f>
+              <c:multiLvlStrCache>
+                <c:ptCount val="9"/>
+                <c:lvl>
+                  <c:pt idx="0">
+                    <c:v>Sessions</c:v>
+                  </c:pt>
+                  <c:pt idx="1">
+                    <c:v>Active users</c:v>
+                  </c:pt>
+                  <c:pt idx="2">
+                    <c:v>Engaged sessions</c:v>
+                  </c:pt>
+                  <c:pt idx="3">
+                    <c:v>Engagement rate</c:v>
+                  </c:pt>
+                  <c:pt idx="4">
+                    <c:v>Time per session</c:v>
+                  </c:pt>
+                  <c:pt idx="5">
+                    <c:v>Events per session</c:v>
+                  </c:pt>
+                  <c:pt idx="6">
+                    <c:v>Total events</c:v>
+                  </c:pt>
+                  <c:pt idx="7">
+                    <c:v>Key events</c:v>
+                  </c:pt>
+                  <c:pt idx="8">
+                    <c:v>Key events per session</c:v>
+                  </c:pt>
+                </c:lvl>
+              </c:multiLvlStrCache>
+            </c:multiLvlStrRef>
+          </c:cat>
+          <c:val>
+            <c:numRef>
+              <c:f>Sheet1!$C$2:$C$10</c:f>
+              <c:numCache>
+                <c:formatCode>General</c:formatCode>
+                <c:ptCount val="9"/>
+                <c:pt idx="0">
+                  <c:v>0</c:v>
+                </c:pt>
+                <c:pt idx="1">
+                  <c:v>0</c:v>
+                </c:pt>
+                <c:pt idx="2">
+                  <c:v>0</c:v>
+                </c:pt>
+                <c:pt idx="3">
+                  <c:v>0</c:v>
+                </c:pt>
+                <c:pt idx="4">
+                  <c:v>0</c:v>
+                </c:pt>
+                <c:pt idx="5">
+                  <c:v>0</c:v>
+                </c:pt>
+                <c:pt idx="6">
+                  <c:v>0</c:v>
+                </c:pt>
+                <c:pt idx="7">
+                  <c:v>0</c:v>
+                </c:pt>
+                <c:pt idx="8">
+                  <c:v>-10.2</c:v>
+                </c:pt>
+              </c:numCache>
+            </c:numRef>
+          </c:val>
+        </c:ser>
+        <c:dLbls>
+          <c:numFmt formatCode="+0.0&quot;%&quot;;-0.0&quot;%&quot;;;" sourceLinked="0"/>
+          <c:txPr>
+            <a:bodyPr/>
+            <a:lstStyle/>
+            <a:p>
+              <a:pPr>
+                <a:defRPr b="1" i="0" strike="noStrike" sz="1000" u="none">
+                  <a:solidFill>
+                    <a:srgbClr val="FFFFFF"/>
+                  </a:solidFill>
+                  <a:latin typeface="Exo 2"/>
+                </a:defRPr>
+              </a:pPr>
+            </a:p>
+          </c:txPr>
+          <c:dLblPos val="inEnd"/>
+          <c:showLegendKey val="0"/>
+          <c:showVal val="1"/>
+          <c:showCatName val="0"/>
+          <c:showSerName val="0"/>
+          <c:showPercent val="0"/>
+          <c:showBubbleSize val="0"/>
+          <c:showLeaderLines val="0"/>
+        </c:dLbls>
+        <c:gapWidth val="40"/>
+        <c:overlap val="100"/>
+        <c:axId val="2094734554"/>
+        <c:axId val="2094734552"/>
+        <c:axId val="2094734556"/>
+      </c:barChart>
+      <c:catAx>
+        <c:axId val="2094734554"/>
+        <c:scaling>
+          <c:orientation val="maxMin"/>
+        </c:scaling>
+        <c:delete val="0"/>
+        <c:axPos val="l"/>
+        <c:numFmt formatCode="General" sourceLinked="1"/>
+        <c:majorTickMark val="out"/>
+        <c:minorTickMark val="none"/>
+        <c:tickLblPos val="low"/>
+        <c:spPr>
+          <a:ln w="12700" cap="flat">
+            <a:solidFill>
+              <a:srgbClr val="888888"/>
+            </a:solidFill>
+            <a:prstDash val="solid"/>
+            <a:round/>
+          </a:ln>
+        </c:spPr>
+        <c:txPr>
+          <a:bodyPr/>
+          <a:lstStyle/>
+          <a:p>
+            <a:pPr>
+              <a:defRPr sz="1000" b="0" i="0" u="none" strike="noStrike">
+                <a:solidFill>
+                  <a:srgbClr val="1F2A44"/>
+                </a:solidFill>
+                <a:latin typeface="Exo 2"/>
+              </a:defRPr>
+            </a:pPr>
+            <a:endParaRPr lang="en-US"/>
+          </a:p>
+        </c:txPr>
+        <c:crossAx val="2094734552"/>
+        <c:crosses val="autoZero"/>
+        <c:auto val="1"/>
+        <c:lblAlgn val="ctr"/>
+        <c:noMultiLvlLbl val="1"/>
+      </c:catAx>
+      <c:valAx>
+        <c:axId val="2094734552"/>
+        <c:scaling>
+          <c:orientation val="minMax"/>
+          <c:max val="50"/>
+          <c:min val="-20"/>
+        </c:scaling>
+        <c:delete val="1"/>
+        <c:axPos val="b"/>
+        <c:numFmt formatCode="General" sourceLinked="0"/>
+        <c:majorTickMark val="out"/>
+        <c:minorTickMark val="none"/>
+        <c:tickLblPos val="low"/>
+        <c:spPr>
+          <a:ln w="12700" cap="flat">
+            <a:solidFill>
+              <a:srgbClr val="888888"/>
+            </a:solidFill>
+            <a:prstDash val="solid"/>
+            <a:round/>
+          </a:ln>
+        </c:spPr>
+        <c:txPr>
+          <a:bodyPr/>
+          <a:lstStyle/>
+          <a:p>
+            <a:pPr>
+              <a:defRPr sz="1200" b="0" i="0" u="none" strike="noStrike">
+                <a:solidFill>
+                  <a:srgbClr val="000000"/>
+                </a:solidFill>
+                <a:latin typeface="Arial"/>
+              </a:defRPr>
+            </a:pPr>
+            <a:endParaRPr lang="en-US"/>
+          </a:p>
+        </c:txPr>
+        <c:crossAx val="2094734554"/>
+        <c:crosses val="autoZero"/>
+        <c:crossBetween val="between"/>
+      </c:valAx>
+      <c:spPr>
+        <a:noFill/>
+        <a:ln>
+          <a:noFill/>
+        </a:ln>
+        <a:effectLst/>
+      </c:spPr>
+    </c:plotArea>
+    <c:legend>
+      <c:legendPos val="b"/>
+      <c:overlay val="0"/>
+      <c:txPr>
+        <a:bodyPr/>
+        <a:lstStyle/>
+        <a:p>
+          <a:pPr>
+            <a:defRPr sz="1000">
+              <a:solidFill>
+                <a:srgbClr val="1F2A44"/>
+              </a:solidFill>
+              <a:latin typeface="Exo 2"/>
+              <a:cs typeface="Exo 2"/>
+            </a:defRPr>
+          </a:pPr>
+          <a:endParaRPr lang="en-US"/>
+        </a:p>
+      </c:txPr>
+    </c:legend>
+    <c:plotVisOnly val="1"/>
+    <c:dispBlanksAs val="span"/>
+  </c:chart>
+  <c:spPr>
+    <a:noFill/>
+    <a:ln>
+      <a:noFill/>
+    </a:ln>
+    <a:effectLst/>
+  </c:spPr>
+  <c:externalData r:id="rId1">
+    <c:autoUpdate val="0"/>
+  </c:externalData>
+</c:chartSpace>
+</file>
+
 <file path=ppt/notesMasters/notesMaster1.xml><?xml version="1.0" encoding="utf-8"?>
 <p:notesMaster xmlns:a="http://schemas.openxmlformats.org/drawingml/2006/main" xmlns:r="http://schemas.openxmlformats.org/officeDocument/2006/relationships" xmlns:p="http://schemas.openxmlformats.org/presentationml/2006/main">
   <p:cSld>
@@ -1152,7 +1964,7 @@
           <a:p>
             <a:r>
               <a:rPr lang="en-US" dirty="0"/>
-              <a:t>Decision 2 follows from the GA4 campaign export: Arabic has a lower engagement rate (86.9% vs 97.2%) but more key events per session (1.05 vs 0.94). Decision 3 follows from the dashboards: +36 downloads but +3 onboarded in the first six days of paid testing. Open items: gross deposits of $12,206 rest on Malek's message of 29 Sep with no written export (the dashboard's $10,029.69 is assets under management, a different measure; the Board shows both); the Board figures (61 clients, $12,206) are as at 28 Sep, and Board slide 3 wrongly says 'as at 17 September', corrected in the separate Board update file; no Ignite spend, cost per key event or LinkedIn lead data, and the key event is undefined; no September social exports; the 793% active-user rise (GA card, prior week implied) and LinkedIn +118% / +155% are not traceable to an export; LinkedIn followers 531 vs 586; $5,000 campaign T&amp;Cs sent for approval on 20 Jul with no sign-off on file. Market Pulse: in-app feature in discussion (Exante data access).</a:t>
+              <a:t>Installs (Android + iOS, cumulative) on dashboard report dates: 1 Sep 373, 2 Sep 389, 3 Sep 395, 8 Sep 403, 9 Sep 410, 10 Sep 414, 13 Sep 419, 14 Sep 423, 16 Sep 430, 17 Sep 432, 20 Sep 437, 21 Sep 437, 22 Sep 452, 23 Sep 454, 24 Sep 455, 27 Sep 473. Report dates are irregular, so the line is spaced by report, not by calendar day. Pace: +36 in the six days 21-27 Sep (6 a day) vs +30 in 1-8 Sep (4.3 a day, when the Ali Sabeel video and baseline sponsor ads were running) and +14 in 14-21 Sep. Split 21-27 Sep: Android +17, iOS +19. Funnel: 409 google / cpc sessions and 400 key events in GA4 (1-28 Sep); the key event is not defined in the export. Installs and onboarding come from the platform dashboard and cover all sources; there is no link yet from an ad click to an install. The app link (onelink.to/gpbwrg) already exists and can carry campaign tags. Onboarded users 57 to 60 over 21-27 Sep.</a:t>
             </a:r>
             <a:endParaRPr lang="en-US" dirty="0"/>
           </a:p>
@@ -1176,6 +1988,182 @@
             <a:fld id="{F7021451-1387-4CA6-816F-3879F97B5CBC}" type="slidenum">
               <a:rPr lang="en-US"/>
               <a:t>4</a:t>
+            </a:fld>
+            <a:endParaRPr lang="en-US"/>
+          </a:p>
+        </p:txBody>
+      </p:sp>
+    </p:spTree>
+    <p:extLst>
+      <p:ext uri="{BB962C8B-B14F-4D97-AF65-F5344CB8AC3E}">
+        <p14:creationId xmlns:p14="http://schemas.microsoft.com/office/powerpoint/2010/main" val="1024086991"/>
+      </p:ext>
+    </p:extLst>
+  </p:cSld>
+  <p:clrMapOvr>
+    <a:masterClrMapping/>
+  </p:clrMapOvr>
+</p:notes>
+</file>
+
+<file path=ppt/notesSlides/notesSlide5.xml><?xml version="1.0" encoding="utf-8"?>
+<p:notes xmlns:a="http://schemas.openxmlformats.org/drawingml/2006/main" xmlns:r="http://schemas.openxmlformats.org/officeDocument/2006/relationships" xmlns:p="http://schemas.openxmlformats.org/presentationml/2006/main">
+  <p:cSld>
+    <p:spTree>
+      <p:nvGrpSpPr>
+        <p:cNvPr id="1" name=""/>
+        <p:cNvGrpSpPr/>
+        <p:nvPr/>
+      </p:nvGrpSpPr>
+      <p:grpSpPr>
+        <a:xfrm>
+          <a:off x="0" y="0"/>
+          <a:ext cx="0" cy="0"/>
+          <a:chOff x="0" y="0"/>
+          <a:chExt cx="0" cy="0"/>
+        </a:xfrm>
+      </p:grpSpPr>
+      <p:sp>
+        <p:nvSpPr>
+          <p:cNvPr id="2" name="Slide Image Placeholder 1"/>
+          <p:cNvSpPr>
+            <a:spLocks noGrp="1" noRot="1" noChangeAspect="1"/>
+          </p:cNvSpPr>
+          <p:nvPr>
+            <p:ph type="sldImg"/>
+          </p:nvPr>
+        </p:nvSpPr>
+        <p:spPr/>
+      </p:sp>
+      <p:sp>
+        <p:nvSpPr>
+          <p:cNvPr id="3" name="Notes Placeholder 2"/>
+          <p:cNvSpPr>
+            <a:spLocks noGrp="1"/>
+          </p:cNvSpPr>
+          <p:nvPr>
+            <p:ph type="body" idx="1"/>
+          </p:nvPr>
+        </p:nvSpPr>
+        <p:spPr/>
+        <p:txBody>
+          <a:bodyPr/>
+          <a:lstStyle/>
+          <a:p>
+            <a:r>
+              <a:rPr lang="en-US" dirty="0"/>
+              <a:t>English vs Arabic, 1-28 Sep: sessions 212 vs 176 (+20.5%); active users 208 vs 175 (+18.9%); engaged sessions 206 vs 153 (+34.6%); engagement rate 97.2% vs 86.9% (+10.2 points, +11.8% relative); average engagement time per session 19.9s vs 16.0s (+24.2%); events per session 6.49 vs 5.44 (+19.2%); event count 1,376 vs 958 (+43.6%); key events 200 vs 185 (+8.1%); key events per session 0.94 vs 1.05 (Arabic ahead by 10.2%). Early data from about one week of spend, and spend per campaign is not in the export, so this compares engagement, not cost efficiency. The previous draft's claim that English leads 'on every measured metric' is not correct.</a:t>
+            </a:r>
+            <a:endParaRPr lang="en-US" dirty="0"/>
+          </a:p>
+        </p:txBody>
+      </p:sp>
+      <p:sp>
+        <p:nvSpPr>
+          <p:cNvPr id="4" name="Slide Number Placeholder 3"/>
+          <p:cNvSpPr>
+            <a:spLocks noGrp="1"/>
+          </p:cNvSpPr>
+          <p:nvPr>
+            <p:ph type="sldNum" sz="quarter" idx="10"/>
+          </p:nvPr>
+        </p:nvSpPr>
+        <p:spPr/>
+        <p:txBody>
+          <a:bodyPr/>
+          <a:lstStyle/>
+          <a:p>
+            <a:fld id="{F7021451-1387-4CA6-816F-3879F97B5CBC}" type="slidenum">
+              <a:rPr lang="en-US"/>
+              <a:t>5</a:t>
+            </a:fld>
+            <a:endParaRPr lang="en-US"/>
+          </a:p>
+        </p:txBody>
+      </p:sp>
+    </p:spTree>
+    <p:extLst>
+      <p:ext uri="{BB962C8B-B14F-4D97-AF65-F5344CB8AC3E}">
+        <p14:creationId xmlns:p14="http://schemas.microsoft.com/office/powerpoint/2010/main" val="1024086991"/>
+      </p:ext>
+    </p:extLst>
+  </p:cSld>
+  <p:clrMapOvr>
+    <a:masterClrMapping/>
+  </p:clrMapOvr>
+</p:notes>
+</file>
+
+<file path=ppt/notesSlides/notesSlide6.xml><?xml version="1.0" encoding="utf-8"?>
+<p:notes xmlns:a="http://schemas.openxmlformats.org/drawingml/2006/main" xmlns:r="http://schemas.openxmlformats.org/officeDocument/2006/relationships" xmlns:p="http://schemas.openxmlformats.org/presentationml/2006/main">
+  <p:cSld>
+    <p:spTree>
+      <p:nvGrpSpPr>
+        <p:cNvPr id="1" name=""/>
+        <p:cNvGrpSpPr/>
+        <p:nvPr/>
+      </p:nvGrpSpPr>
+      <p:grpSpPr>
+        <a:xfrm>
+          <a:off x="0" y="0"/>
+          <a:ext cx="0" cy="0"/>
+          <a:chOff x="0" y="0"/>
+          <a:chExt cx="0" cy="0"/>
+        </a:xfrm>
+      </p:grpSpPr>
+      <p:sp>
+        <p:nvSpPr>
+          <p:cNvPr id="2" name="Slide Image Placeholder 1"/>
+          <p:cNvSpPr>
+            <a:spLocks noGrp="1" noRot="1" noChangeAspect="1"/>
+          </p:cNvSpPr>
+          <p:nvPr>
+            <p:ph type="sldImg"/>
+          </p:nvPr>
+        </p:nvSpPr>
+        <p:spPr/>
+      </p:sp>
+      <p:sp>
+        <p:nvSpPr>
+          <p:cNvPr id="3" name="Notes Placeholder 2"/>
+          <p:cNvSpPr>
+            <a:spLocks noGrp="1"/>
+          </p:cNvSpPr>
+          <p:nvPr>
+            <p:ph type="body" idx="1"/>
+          </p:nvPr>
+        </p:nvSpPr>
+        <p:spPr/>
+        <p:txBody>
+          <a:bodyPr/>
+          <a:lstStyle/>
+          <a:p>
+            <a:r>
+              <a:rPr lang="en-US" dirty="0"/>
+              <a:t>Decision 2 follows from the GA4 campaign export: Arabic has a lower engagement rate (86.9% vs 97.2%) but more key events per session (1.05 vs 0.94). Decision 3 follows from the dashboards: +36 downloads but +3 onboarded in the first six days of paid testing. Open items: gross deposits of $12,206 rest on Malek's message of 29 Sep with no written export (the dashboard's $10,029.69 is assets under management, a different measure; the Board shows both); the Board figures (61 clients, $12,206) are as at 28 Sep, and Board slide 3 wrongly says 'as at 17 September', corrected in the separate Board update file; no Ignite spend, cost per key event or LinkedIn lead data, and the key event is undefined; no September social exports; the 793% active-user rise (GA card, prior week implied) and LinkedIn +118% / +155% are not traceable to an export; LinkedIn followers 531 vs 586; $5,000 campaign T&amp;Cs sent for approval on 20 Jul with no sign-off on file. Market Pulse: in-app feature in discussion (Exante data access).</a:t>
+            </a:r>
+            <a:endParaRPr lang="en-US" dirty="0"/>
+          </a:p>
+        </p:txBody>
+      </p:sp>
+      <p:sp>
+        <p:nvSpPr>
+          <p:cNvPr id="4" name="Slide Number Placeholder 3"/>
+          <p:cNvSpPr>
+            <a:spLocks noGrp="1"/>
+          </p:cNvSpPr>
+          <p:nvPr>
+            <p:ph type="sldNum" sz="quarter" idx="10"/>
+          </p:nvPr>
+        </p:nvSpPr>
+        <p:spPr/>
+        <p:txBody>
+          <a:bodyPr/>
+          <a:lstStyle/>
+          <a:p>
+            <a:fld id="{F7021451-1387-4CA6-816F-3879F97B5CBC}" type="slidenum">
+              <a:rPr lang="en-US"/>
+              <a:t>6</a:t>
             </a:fld>
             <a:endParaRPr lang="en-US"/>
           </a:p>
@@ -5174,6 +6162,2387 @@
                 <a:ea typeface="Exo 2" pitchFamily="34" charset="-122"/>
                 <a:cs typeface="Exo 2" pitchFamily="34" charset="-120"/>
               </a:rPr>
+              <a:t>GOOGLE ADS AND INSTALLS</a:t>
+            </a:r>
+            <a:endParaRPr lang="en-US" sz="900" dirty="0"/>
+          </a:p>
+        </p:txBody>
+      </p:sp>
+      <p:sp>
+        <p:nvSpPr>
+          <p:cNvPr id="5" name="Text 2"/>
+          <p:cNvSpPr txBox="1"/>
+          <p:nvPr/>
+        </p:nvSpPr>
+        <p:spPr>
+          <a:xfrm>
+            <a:off x="566928" y="475488"/>
+            <a:ext cx="9326880" cy="749808"/>
+          </a:xfrm>
+          <a:prstGeom prst="rect">
+            <a:avLst/>
+          </a:prstGeom>
+          <a:noFill/>
+          <a:ln/>
+        </p:spPr>
+        <p:txBody>
+          <a:bodyPr wrap="square" lIns="0" tIns="0" rIns="0" bIns="0" rtlCol="0" anchor="ctr"/>
+          <a:lstStyle/>
+          <a:p>
+            <a:pPr indent="0" marL="0">
+              <a:buNone/>
+            </a:pPr>
+            <a:r>
+              <a:rPr lang="en-US" sz="2000" b="1" dirty="0">
+                <a:solidFill>
+                  <a:srgbClr val="FFFFFF"/>
+                </a:solidFill>
+                <a:latin typeface="Exo 2" pitchFamily="34" charset="0"/>
+                <a:ea typeface="Exo 2" pitchFamily="34" charset="-122"/>
+                <a:cs typeface="Exo 2" pitchFamily="34" charset="-120"/>
+              </a:rPr>
+              <a:t>Google Ads went live on 22 September; installs then grew at their fastest weekly pace of the month</a:t>
+            </a:r>
+            <a:endParaRPr lang="en-US" sz="2000" dirty="0"/>
+          </a:p>
+        </p:txBody>
+      </p:sp>
+      <p:pic>
+        <p:nvPicPr>
+          <p:cNvPr id="6" name="Image 1" descr="/home/user/HatemIsa_202508993_IT9002_NLP_Project/emyaa-ceo-deck/working/charts/ajyad_white.png">    </p:cNvPr>
+          <p:cNvPicPr>
+            <a:picLocks noChangeAspect="1"/>
+          </p:cNvPicPr>
+          <p:nvPr/>
+        </p:nvPicPr>
+        <p:blipFill>
+          <a:blip r:embed="rId2"/>
+          <a:stretch>
+            <a:fillRect/>
+          </a:stretch>
+        </p:blipFill>
+        <p:spPr>
+          <a:xfrm>
+            <a:off x="10305288" y="457200"/>
+            <a:ext cx="1325880" cy="384048"/>
+          </a:xfrm>
+          <a:prstGeom prst="rect">
+            <a:avLst/>
+          </a:prstGeom>
+        </p:spPr>
+      </p:pic>
+      <p:sp>
+        <p:nvSpPr>
+          <p:cNvPr id="7" name="Shape 3"/>
+          <p:cNvSpPr/>
+          <p:nvPr/>
+        </p:nvSpPr>
+        <p:spPr>
+          <a:xfrm>
+            <a:off x="566928" y="5669280"/>
+            <a:ext cx="11064240" cy="457200"/>
+          </a:xfrm>
+          <a:prstGeom prst="rect">
+            <a:avLst/>
+          </a:prstGeom>
+          <a:solidFill>
+            <a:srgbClr val="E3E8F2"/>
+          </a:solidFill>
+          <a:ln w="12700">
+            <a:solidFill>
+              <a:srgbClr val="E3E8F2"/>
+            </a:solidFill>
+            <a:prstDash val="solid"/>
+          </a:ln>
+        </p:spPr>
+      </p:sp>
+      <p:sp>
+        <p:nvSpPr>
+          <p:cNvPr id="8" name="Shape 4"/>
+          <p:cNvSpPr/>
+          <p:nvPr/>
+        </p:nvSpPr>
+        <p:spPr>
+          <a:xfrm>
+            <a:off x="566928" y="5669280"/>
+            <a:ext cx="45720" cy="457200"/>
+          </a:xfrm>
+          <a:prstGeom prst="rect">
+            <a:avLst/>
+          </a:prstGeom>
+          <a:solidFill>
+            <a:srgbClr val="D4AF37"/>
+          </a:solidFill>
+          <a:ln w="12700">
+            <a:solidFill>
+              <a:srgbClr val="D4AF37"/>
+            </a:solidFill>
+            <a:prstDash val="solid"/>
+          </a:ln>
+        </p:spPr>
+      </p:sp>
+      <p:sp>
+        <p:nvSpPr>
+          <p:cNvPr id="9" name="Text 5"/>
+          <p:cNvSpPr txBox="1"/>
+          <p:nvPr/>
+        </p:nvSpPr>
+        <p:spPr>
+          <a:xfrm>
+            <a:off x="777240" y="5669280"/>
+            <a:ext cx="10744200" cy="457200"/>
+          </a:xfrm>
+          <a:prstGeom prst="rect">
+            <a:avLst/>
+          </a:prstGeom>
+          <a:noFill/>
+          <a:ln/>
+        </p:spPr>
+        <p:txBody>
+          <a:bodyPr wrap="square" lIns="0" tIns="0" rIns="0" bIns="0" rtlCol="0" anchor="ctr"/>
+          <a:lstStyle/>
+          <a:p>
+            <a:pPr indent="0" marL="0">
+              <a:buNone/>
+            </a:pPr>
+            <a:r>
+              <a:rPr lang="en-US" sz="1150" b="1" dirty="0">
+                <a:solidFill>
+                  <a:srgbClr val="132257"/>
+                </a:solidFill>
+                <a:latin typeface="Exo 2" pitchFamily="34" charset="0"/>
+                <a:ea typeface="Exo 2" pitchFamily="34" charset="-122"/>
+                <a:cs typeface="Exo 2" pitchFamily="34" charset="-120"/>
+              </a:rPr>
+              <a:t>Takeaway   </a:t>
+            </a:r>
+            <a:pPr indent="0" marL="0">
+              <a:buNone/>
+            </a:pPr>
+            <a:r>
+              <a:rPr lang="en-US" sz="1150" dirty="0">
+                <a:solidFill>
+                  <a:srgbClr val="1F2A44"/>
+                </a:solidFill>
+                <a:latin typeface="Exo 2" pitchFamily="34" charset="0"/>
+                <a:ea typeface="Exo 2" pitchFamily="34" charset="-122"/>
+                <a:cs typeface="Exo 2" pitchFamily="34" charset="-120"/>
+              </a:rPr>
+              <a:t>Paid search is moving installs, but installs are not yet tracked back to the ads. Connect ad clicks to the app link so cost per install can be reported.</a:t>
+            </a:r>
+            <a:endParaRPr lang="en-US" sz="1150" dirty="0"/>
+          </a:p>
+        </p:txBody>
+      </p:sp>
+      <p:sp>
+        <p:nvSpPr>
+          <p:cNvPr id="10" name="Text 6"/>
+          <p:cNvSpPr txBox="1"/>
+          <p:nvPr/>
+        </p:nvSpPr>
+        <p:spPr>
+          <a:xfrm>
+            <a:off x="566928" y="6199632"/>
+            <a:ext cx="9692640" cy="274320"/>
+          </a:xfrm>
+          <a:prstGeom prst="rect">
+            <a:avLst/>
+          </a:prstGeom>
+          <a:noFill/>
+          <a:ln/>
+        </p:spPr>
+        <p:txBody>
+          <a:bodyPr wrap="square" lIns="0" tIns="0" rIns="0" bIns="0" rtlCol="0" anchor="t"/>
+          <a:lstStyle/>
+          <a:p>
+            <a:pPr indent="0" marL="0">
+              <a:buNone/>
+            </a:pPr>
+            <a:r>
+              <a:rPr lang="en-US" sz="800" dirty="0">
+                <a:solidFill>
+                  <a:srgbClr val="7A849C"/>
+                </a:solidFill>
+                <a:latin typeface="Exo 2" pitchFamily="34" charset="0"/>
+                <a:ea typeface="Exo 2" pitchFamily="34" charset="-122"/>
+                <a:cs typeface="Exo 2" pitchFamily="34" charset="-120"/>
+              </a:rPr>
+              <a:t>Source: App installs: eMYAA Daily Performance Dashboards (Android + iOS, cumulative, on report dates 1-27 Sep 2026). Ads: GA4 Reports snapshot and Google Ads campaigns exports, 1-28 Sep 2026.</a:t>
+            </a:r>
+            <a:endParaRPr lang="en-US" sz="800" dirty="0"/>
+          </a:p>
+        </p:txBody>
+      </p:sp>
+      <p:sp>
+        <p:nvSpPr>
+          <p:cNvPr id="11" name="Text 7"/>
+          <p:cNvSpPr txBox="1"/>
+          <p:nvPr/>
+        </p:nvSpPr>
+        <p:spPr>
+          <a:xfrm>
+            <a:off x="566928" y="6510528"/>
+            <a:ext cx="5486400" cy="201168"/>
+          </a:xfrm>
+          <a:prstGeom prst="rect">
+            <a:avLst/>
+          </a:prstGeom>
+          <a:noFill/>
+          <a:ln/>
+        </p:spPr>
+        <p:txBody>
+          <a:bodyPr wrap="square" lIns="0" tIns="0" rIns="0" bIns="0" rtlCol="0" anchor="t"/>
+          <a:lstStyle/>
+          <a:p>
+            <a:pPr indent="0" marL="0">
+              <a:buNone/>
+            </a:pPr>
+            <a:r>
+              <a:rPr lang="en-US" sz="800" dirty="0">
+                <a:solidFill>
+                  <a:srgbClr val="8A93A8"/>
+                </a:solidFill>
+                <a:latin typeface="Exo 2" pitchFamily="34" charset="0"/>
+                <a:ea typeface="Exo 2" pitchFamily="34" charset="-122"/>
+                <a:cs typeface="Exo 2" pitchFamily="34" charset="-120"/>
+              </a:rPr>
+              <a:t>eMYAA Trading Platform  |  CEO Marketing Update</a:t>
+            </a:r>
+            <a:endParaRPr lang="en-US" sz="800" dirty="0"/>
+          </a:p>
+        </p:txBody>
+      </p:sp>
+      <p:sp>
+        <p:nvSpPr>
+          <p:cNvPr id="12" name="Text 8"/>
+          <p:cNvSpPr txBox="1"/>
+          <p:nvPr/>
+        </p:nvSpPr>
+        <p:spPr>
+          <a:xfrm>
+            <a:off x="9802368" y="6510528"/>
+            <a:ext cx="457200" cy="201168"/>
+          </a:xfrm>
+          <a:prstGeom prst="rect">
+            <a:avLst/>
+          </a:prstGeom>
+          <a:noFill/>
+          <a:ln/>
+        </p:spPr>
+        <p:txBody>
+          <a:bodyPr wrap="square" lIns="0" tIns="0" rIns="0" bIns="0" rtlCol="0" anchor="t"/>
+          <a:lstStyle/>
+          <a:p>
+            <a:pPr algn="r" indent="0" marL="0">
+              <a:buNone/>
+            </a:pPr>
+            <a:r>
+              <a:rPr lang="en-US" sz="800" dirty="0">
+                <a:solidFill>
+                  <a:srgbClr val="8A93A8"/>
+                </a:solidFill>
+                <a:latin typeface="Exo 2" pitchFamily="34" charset="0"/>
+                <a:ea typeface="Exo 2" pitchFamily="34" charset="-122"/>
+                <a:cs typeface="Exo 2" pitchFamily="34" charset="-120"/>
+              </a:rPr>
+              <a:t>4</a:t>
+            </a:r>
+            <a:endParaRPr lang="en-US" sz="800" dirty="0"/>
+          </a:p>
+        </p:txBody>
+      </p:sp>
+      <p:pic>
+        <p:nvPicPr>
+          <p:cNvPr id="13" name="Image 2" descr="/home/user/HatemIsa_202508993_IT9002_NLP_Project/emyaa-ceo-deck/working/charts/emyaa_navy.png">    </p:cNvPr>
+          <p:cNvPicPr>
+            <a:picLocks noChangeAspect="1"/>
+          </p:cNvPicPr>
+          <p:nvPr/>
+        </p:nvPicPr>
+        <p:blipFill>
+          <a:blip r:embed="rId3"/>
+          <a:stretch>
+            <a:fillRect/>
+          </a:stretch>
+        </p:blipFill>
+        <p:spPr>
+          <a:xfrm>
+            <a:off x="10607040" y="6336792"/>
+            <a:ext cx="1024128" cy="365760"/>
+          </a:xfrm>
+          <a:prstGeom prst="rect">
+            <a:avLst/>
+          </a:prstGeom>
+        </p:spPr>
+      </p:pic>
+      <p:graphicFrame>
+        <p:nvGraphicFramePr>
+          <p:cNvPr id="15" name="Chart 0" descr=""/>
+          <p:cNvGraphicFramePr/>
+          <p:nvPr/>
+        </p:nvGraphicFramePr>
+        <p:xfrm>
+          <a:off x="566928" y="1508760"/>
+          <a:ext cx="6720840" cy="4069080"/>
+        </p:xfrm>
+        <a:graphic xmlns:a="http://schemas.openxmlformats.org/drawingml/2006/main">
+          <a:graphicData uri="http://schemas.openxmlformats.org/drawingml/2006/chart">
+            <c:chart xmlns:c="http://schemas.openxmlformats.org/drawingml/2006/chart" r:id="rId4"/>
+          </a:graphicData>
+        </a:graphic>
+      </p:graphicFrame>
+      <p:sp>
+        <p:nvSpPr>
+          <p:cNvPr id="16" name="Text 9"/>
+          <p:cNvSpPr txBox="1"/>
+          <p:nvPr/>
+        </p:nvSpPr>
+        <p:spPr>
+          <a:xfrm>
+            <a:off x="4892040" y="2011680"/>
+            <a:ext cx="2194560" cy="457200"/>
+          </a:xfrm>
+          <a:prstGeom prst="rect">
+            <a:avLst/>
+          </a:prstGeom>
+          <a:noFill/>
+          <a:ln/>
+        </p:spPr>
+        <p:txBody>
+          <a:bodyPr wrap="square" lIns="0" tIns="0" rIns="0" bIns="0" rtlCol="0" anchor="t"/>
+          <a:lstStyle/>
+          <a:p>
+            <a:pPr indent="0" marL="0">
+              <a:buNone/>
+            </a:pPr>
+            <a:r>
+              <a:rPr lang="en-US" sz="1050" b="1" dirty="0">
+                <a:solidFill>
+                  <a:srgbClr val="1BA97C"/>
+                </a:solidFill>
+                <a:latin typeface="Exo 2" pitchFamily="34" charset="0"/>
+                <a:ea typeface="Exo 2" pitchFamily="34" charset="-122"/>
+                <a:cs typeface="Exo 2" pitchFamily="34" charset="-120"/>
+              </a:rPr>
+              <a:t>+36 in 6 days</a:t>
+            </a:r>
+            <a:endParaRPr lang="en-US" sz="1050" dirty="0"/>
+          </a:p>
+          <a:p>
+            <a:pPr indent="0" marL="0">
+              <a:buNone/>
+            </a:pPr>
+            <a:r>
+              <a:rPr lang="en-US" sz="1050" dirty="0">
+                <a:solidFill>
+                  <a:srgbClr val="7A849C"/>
+                </a:solidFill>
+                <a:latin typeface="Exo 2" pitchFamily="34" charset="0"/>
+                <a:ea typeface="Exo 2" pitchFamily="34" charset="-122"/>
+                <a:cs typeface="Exo 2" pitchFamily="34" charset="-120"/>
+              </a:rPr>
+              <a:t>21-27 Sep, after launch</a:t>
+            </a:r>
+            <a:endParaRPr lang="en-US" sz="1050" dirty="0"/>
+          </a:p>
+        </p:txBody>
+      </p:sp>
+      <p:sp>
+        <p:nvSpPr>
+          <p:cNvPr id="17" name="Text 10"/>
+          <p:cNvSpPr txBox="1"/>
+          <p:nvPr/>
+        </p:nvSpPr>
+        <p:spPr>
+          <a:xfrm>
+            <a:off x="4069080" y="3703320"/>
+            <a:ext cx="2103120" cy="457200"/>
+          </a:xfrm>
+          <a:prstGeom prst="rect">
+            <a:avLst/>
+          </a:prstGeom>
+          <a:noFill/>
+          <a:ln/>
+        </p:spPr>
+        <p:txBody>
+          <a:bodyPr wrap="square" lIns="0" tIns="0" rIns="0" bIns="0" rtlCol="0" anchor="t"/>
+          <a:lstStyle/>
+          <a:p>
+            <a:pPr indent="0" marL="0">
+              <a:buNone/>
+            </a:pPr>
+            <a:r>
+              <a:rPr lang="en-US" sz="1050" b="1" dirty="0">
+                <a:solidFill>
+                  <a:srgbClr val="132257"/>
+                </a:solidFill>
+                <a:latin typeface="Exo 2" pitchFamily="34" charset="0"/>
+                <a:ea typeface="Exo 2" pitchFamily="34" charset="-122"/>
+                <a:cs typeface="Exo 2" pitchFamily="34" charset="-120"/>
+              </a:rPr>
+              <a:t>+14 in 7 days</a:t>
+            </a:r>
+            <a:endParaRPr lang="en-US" sz="1050" dirty="0"/>
+          </a:p>
+          <a:p>
+            <a:pPr indent="0" marL="0">
+              <a:buNone/>
+            </a:pPr>
+            <a:r>
+              <a:rPr lang="en-US" sz="1050" dirty="0">
+                <a:solidFill>
+                  <a:srgbClr val="7A849C"/>
+                </a:solidFill>
+                <a:latin typeface="Exo 2" pitchFamily="34" charset="0"/>
+                <a:ea typeface="Exo 2" pitchFamily="34" charset="-122"/>
+                <a:cs typeface="Exo 2" pitchFamily="34" charset="-120"/>
+              </a:rPr>
+              <a:t>14-21 Sep, before launch</a:t>
+            </a:r>
+            <a:endParaRPr lang="en-US" sz="1050" dirty="0"/>
+          </a:p>
+        </p:txBody>
+      </p:sp>
+      <p:sp>
+        <p:nvSpPr>
+          <p:cNvPr id="18" name="Text 11"/>
+          <p:cNvSpPr txBox="1"/>
+          <p:nvPr/>
+        </p:nvSpPr>
+        <p:spPr>
+          <a:xfrm>
+            <a:off x="7589520" y="1481328"/>
+            <a:ext cx="4041648" cy="228600"/>
+          </a:xfrm>
+          <a:prstGeom prst="rect">
+            <a:avLst/>
+          </a:prstGeom>
+          <a:noFill/>
+          <a:ln/>
+        </p:spPr>
+        <p:txBody>
+          <a:bodyPr wrap="square" lIns="0" tIns="0" rIns="0" bIns="0" rtlCol="0" anchor="t"/>
+          <a:lstStyle/>
+          <a:p>
+            <a:pPr indent="0" marL="0">
+              <a:buNone/>
+            </a:pPr>
+            <a:r>
+              <a:rPr lang="en-US" sz="900" b="1" spc="200" kern="0" dirty="0">
+                <a:solidFill>
+                  <a:srgbClr val="9A7B1F"/>
+                </a:solidFill>
+                <a:latin typeface="Exo 2" pitchFamily="34" charset="0"/>
+                <a:ea typeface="Exo 2" pitchFamily="34" charset="-122"/>
+                <a:cs typeface="Exo 2" pitchFamily="34" charset="-120"/>
+              </a:rPr>
+              <a:t>FROM AD TO ACCOUNT</a:t>
+            </a:r>
+            <a:endParaRPr lang="en-US" sz="900" dirty="0"/>
+          </a:p>
+        </p:txBody>
+      </p:sp>
+      <p:sp>
+        <p:nvSpPr>
+          <p:cNvPr id="19" name="Shape 12"/>
+          <p:cNvSpPr/>
+          <p:nvPr/>
+        </p:nvSpPr>
+        <p:spPr>
+          <a:xfrm>
+            <a:off x="7589520" y="1810512"/>
+            <a:ext cx="4041648" cy="713232"/>
+          </a:xfrm>
+          <a:prstGeom prst="rect">
+            <a:avLst/>
+          </a:prstGeom>
+          <a:solidFill>
+            <a:srgbClr val="132257"/>
+          </a:solidFill>
+          <a:ln w="19050">
+            <a:solidFill>
+              <a:srgbClr val="132257"/>
+            </a:solidFill>
+            <a:prstDash val="solid"/>
+          </a:ln>
+        </p:spPr>
+      </p:sp>
+      <p:sp>
+        <p:nvSpPr>
+          <p:cNvPr id="20" name="Text 13"/>
+          <p:cNvSpPr txBox="1"/>
+          <p:nvPr/>
+        </p:nvSpPr>
+        <p:spPr>
+          <a:xfrm>
+            <a:off x="7726680" y="1810512"/>
+            <a:ext cx="868680" cy="713232"/>
+          </a:xfrm>
+          <a:prstGeom prst="rect">
+            <a:avLst/>
+          </a:prstGeom>
+          <a:noFill/>
+          <a:ln/>
+        </p:spPr>
+        <p:txBody>
+          <a:bodyPr wrap="square" lIns="0" tIns="0" rIns="0" bIns="0" rtlCol="0" anchor="ctr"/>
+          <a:lstStyle/>
+          <a:p>
+            <a:pPr indent="0" marL="0">
+              <a:buNone/>
+            </a:pPr>
+            <a:r>
+              <a:rPr lang="en-US" sz="2200" b="1" dirty="0">
+                <a:solidFill>
+                  <a:srgbClr val="FFFFFF"/>
+                </a:solidFill>
+                <a:latin typeface="Exo 2" pitchFamily="34" charset="0"/>
+                <a:ea typeface="Exo 2" pitchFamily="34" charset="-122"/>
+                <a:cs typeface="Exo 2" pitchFamily="34" charset="-120"/>
+              </a:rPr>
+              <a:t>409</a:t>
+            </a:r>
+            <a:endParaRPr lang="en-US" sz="2200" dirty="0"/>
+          </a:p>
+        </p:txBody>
+      </p:sp>
+      <p:sp>
+        <p:nvSpPr>
+          <p:cNvPr id="21" name="Text 14"/>
+          <p:cNvSpPr txBox="1"/>
+          <p:nvPr/>
+        </p:nvSpPr>
+        <p:spPr>
+          <a:xfrm>
+            <a:off x="8595360" y="1810512"/>
+            <a:ext cx="2944368" cy="713232"/>
+          </a:xfrm>
+          <a:prstGeom prst="rect">
+            <a:avLst/>
+          </a:prstGeom>
+          <a:noFill/>
+          <a:ln/>
+        </p:spPr>
+        <p:txBody>
+          <a:bodyPr wrap="square" lIns="0" tIns="0" rIns="0" bIns="0" rtlCol="0" anchor="ctr"/>
+          <a:lstStyle/>
+          <a:p>
+            <a:pPr indent="0" marL="0">
+              <a:buNone/>
+            </a:pPr>
+            <a:r>
+              <a:rPr lang="en-US" sz="1000" b="1" dirty="0">
+                <a:solidFill>
+                  <a:srgbClr val="FFFFFF"/>
+                </a:solidFill>
+                <a:latin typeface="Exo 2" pitchFamily="34" charset="0"/>
+                <a:ea typeface="Exo 2" pitchFamily="34" charset="-122"/>
+                <a:cs typeface="Exo 2" pitchFamily="34" charset="-120"/>
+              </a:rPr>
+              <a:t>Google Ads sessions</a:t>
+            </a:r>
+            <a:endParaRPr lang="en-US" sz="1000" dirty="0"/>
+          </a:p>
+          <a:p>
+            <a:pPr indent="0" marL="0">
+              <a:buNone/>
+            </a:pPr>
+            <a:r>
+              <a:rPr lang="en-US" sz="850" dirty="0">
+                <a:solidFill>
+                  <a:srgbClr val="FFFFFF"/>
+                </a:solidFill>
+                <a:latin typeface="Exo 2" pitchFamily="34" charset="0"/>
+                <a:ea typeface="Exo 2" pitchFamily="34" charset="-122"/>
+                <a:cs typeface="Exo 2" pitchFamily="34" charset="-120"/>
+              </a:rPr>
+              <a:t>GA4, 1-28 Sep</a:t>
+            </a:r>
+            <a:endParaRPr lang="en-US" sz="1000" dirty="0"/>
+          </a:p>
+        </p:txBody>
+      </p:sp>
+      <p:sp>
+        <p:nvSpPr>
+          <p:cNvPr id="22" name="Shape 15"/>
+          <p:cNvSpPr/>
+          <p:nvPr/>
+        </p:nvSpPr>
+        <p:spPr>
+          <a:xfrm>
+            <a:off x="7827264" y="2706624"/>
+            <a:ext cx="3566160" cy="713232"/>
+          </a:xfrm>
+          <a:prstGeom prst="rect">
+            <a:avLst/>
+          </a:prstGeom>
+          <a:solidFill>
+            <a:srgbClr val="132257"/>
+          </a:solidFill>
+          <a:ln w="19050">
+            <a:solidFill>
+              <a:srgbClr val="132257"/>
+            </a:solidFill>
+            <a:prstDash val="solid"/>
+          </a:ln>
+        </p:spPr>
+      </p:sp>
+      <p:sp>
+        <p:nvSpPr>
+          <p:cNvPr id="23" name="Text 16"/>
+          <p:cNvSpPr txBox="1"/>
+          <p:nvPr/>
+        </p:nvSpPr>
+        <p:spPr>
+          <a:xfrm>
+            <a:off x="7964424" y="2706624"/>
+            <a:ext cx="868680" cy="713232"/>
+          </a:xfrm>
+          <a:prstGeom prst="rect">
+            <a:avLst/>
+          </a:prstGeom>
+          <a:noFill/>
+          <a:ln/>
+        </p:spPr>
+        <p:txBody>
+          <a:bodyPr wrap="square" lIns="0" tIns="0" rIns="0" bIns="0" rtlCol="0" anchor="ctr"/>
+          <a:lstStyle/>
+          <a:p>
+            <a:pPr indent="0" marL="0">
+              <a:buNone/>
+            </a:pPr>
+            <a:r>
+              <a:rPr lang="en-US" sz="2200" b="1" dirty="0">
+                <a:solidFill>
+                  <a:srgbClr val="FFFFFF"/>
+                </a:solidFill>
+                <a:latin typeface="Exo 2" pitchFamily="34" charset="0"/>
+                <a:ea typeface="Exo 2" pitchFamily="34" charset="-122"/>
+                <a:cs typeface="Exo 2" pitchFamily="34" charset="-120"/>
+              </a:rPr>
+              <a:t>400</a:t>
+            </a:r>
+            <a:endParaRPr lang="en-US" sz="2200" dirty="0"/>
+          </a:p>
+        </p:txBody>
+      </p:sp>
+      <p:sp>
+        <p:nvSpPr>
+          <p:cNvPr id="24" name="Text 17"/>
+          <p:cNvSpPr txBox="1"/>
+          <p:nvPr/>
+        </p:nvSpPr>
+        <p:spPr>
+          <a:xfrm>
+            <a:off x="8833104" y="2706624"/>
+            <a:ext cx="2468880" cy="713232"/>
+          </a:xfrm>
+          <a:prstGeom prst="rect">
+            <a:avLst/>
+          </a:prstGeom>
+          <a:noFill/>
+          <a:ln/>
+        </p:spPr>
+        <p:txBody>
+          <a:bodyPr wrap="square" lIns="0" tIns="0" rIns="0" bIns="0" rtlCol="0" anchor="ctr"/>
+          <a:lstStyle/>
+          <a:p>
+            <a:pPr indent="0" marL="0">
+              <a:buNone/>
+            </a:pPr>
+            <a:r>
+              <a:rPr lang="en-US" sz="1000" b="1" dirty="0">
+                <a:solidFill>
+                  <a:srgbClr val="FFFFFF"/>
+                </a:solidFill>
+                <a:latin typeface="Exo 2" pitchFamily="34" charset="0"/>
+                <a:ea typeface="Exo 2" pitchFamily="34" charset="-122"/>
+                <a:cs typeface="Exo 2" pitchFamily="34" charset="-120"/>
+              </a:rPr>
+              <a:t>key events on those sessions</a:t>
+            </a:r>
+            <a:endParaRPr lang="en-US" sz="1000" dirty="0"/>
+          </a:p>
+          <a:p>
+            <a:pPr indent="0" marL="0">
+              <a:buNone/>
+            </a:pPr>
+            <a:r>
+              <a:rPr lang="en-US" sz="850" dirty="0">
+                <a:solidFill>
+                  <a:srgbClr val="FFFFFF"/>
+                </a:solidFill>
+                <a:latin typeface="Exo 2" pitchFamily="34" charset="0"/>
+                <a:ea typeface="Exo 2" pitchFamily="34" charset="-122"/>
+                <a:cs typeface="Exo 2" pitchFamily="34" charset="-120"/>
+              </a:rPr>
+              <a:t>event not yet defined</a:t>
+            </a:r>
+            <a:endParaRPr lang="en-US" sz="1000" dirty="0"/>
+          </a:p>
+        </p:txBody>
+      </p:sp>
+      <p:sp>
+        <p:nvSpPr>
+          <p:cNvPr id="25" name="Shape 18"/>
+          <p:cNvSpPr/>
+          <p:nvPr/>
+        </p:nvSpPr>
+        <p:spPr>
+          <a:xfrm>
+            <a:off x="8065008" y="3803904"/>
+            <a:ext cx="3090672" cy="713232"/>
+          </a:xfrm>
+          <a:prstGeom prst="rect">
+            <a:avLst/>
+          </a:prstGeom>
+          <a:solidFill>
+            <a:srgbClr val="FFFFFF"/>
+          </a:solidFill>
+          <a:ln w="19050">
+            <a:solidFill>
+              <a:srgbClr val="D4AF37"/>
+            </a:solidFill>
+            <a:prstDash val="solid"/>
+          </a:ln>
+        </p:spPr>
+      </p:sp>
+      <p:sp>
+        <p:nvSpPr>
+          <p:cNvPr id="26" name="Text 19"/>
+          <p:cNvSpPr txBox="1"/>
+          <p:nvPr/>
+        </p:nvSpPr>
+        <p:spPr>
+          <a:xfrm>
+            <a:off x="8202168" y="3803904"/>
+            <a:ext cx="868680" cy="713232"/>
+          </a:xfrm>
+          <a:prstGeom prst="rect">
+            <a:avLst/>
+          </a:prstGeom>
+          <a:noFill/>
+          <a:ln/>
+        </p:spPr>
+        <p:txBody>
+          <a:bodyPr wrap="square" lIns="0" tIns="0" rIns="0" bIns="0" rtlCol="0" anchor="ctr"/>
+          <a:lstStyle/>
+          <a:p>
+            <a:pPr indent="0" marL="0">
+              <a:buNone/>
+            </a:pPr>
+            <a:r>
+              <a:rPr lang="en-US" sz="2200" b="1" dirty="0">
+                <a:solidFill>
+                  <a:srgbClr val="D4AF37"/>
+                </a:solidFill>
+                <a:latin typeface="Exo 2" pitchFamily="34" charset="0"/>
+                <a:ea typeface="Exo 2" pitchFamily="34" charset="-122"/>
+                <a:cs typeface="Exo 2" pitchFamily="34" charset="-120"/>
+              </a:rPr>
+              <a:t>+36</a:t>
+            </a:r>
+            <a:endParaRPr lang="en-US" sz="2200" dirty="0"/>
+          </a:p>
+        </p:txBody>
+      </p:sp>
+      <p:sp>
+        <p:nvSpPr>
+          <p:cNvPr id="27" name="Text 20"/>
+          <p:cNvSpPr txBox="1"/>
+          <p:nvPr/>
+        </p:nvSpPr>
+        <p:spPr>
+          <a:xfrm>
+            <a:off x="9070848" y="3803904"/>
+            <a:ext cx="1993392" cy="713232"/>
+          </a:xfrm>
+          <a:prstGeom prst="rect">
+            <a:avLst/>
+          </a:prstGeom>
+          <a:noFill/>
+          <a:ln/>
+        </p:spPr>
+        <p:txBody>
+          <a:bodyPr wrap="square" lIns="0" tIns="0" rIns="0" bIns="0" rtlCol="0" anchor="ctr"/>
+          <a:lstStyle/>
+          <a:p>
+            <a:pPr indent="0" marL="0">
+              <a:buNone/>
+            </a:pPr>
+            <a:r>
+              <a:rPr lang="en-US" sz="1000" b="1" dirty="0">
+                <a:solidFill>
+                  <a:srgbClr val="132257"/>
+                </a:solidFill>
+                <a:latin typeface="Exo 2" pitchFamily="34" charset="0"/>
+                <a:ea typeface="Exo 2" pitchFamily="34" charset="-122"/>
+                <a:cs typeface="Exo 2" pitchFamily="34" charset="-120"/>
+              </a:rPr>
+              <a:t>app installs, 21-27 Sep</a:t>
+            </a:r>
+            <a:endParaRPr lang="en-US" sz="1000" dirty="0"/>
+          </a:p>
+          <a:p>
+            <a:pPr indent="0" marL="0">
+              <a:buNone/>
+            </a:pPr>
+            <a:r>
+              <a:rPr lang="en-US" sz="850" dirty="0">
+                <a:solidFill>
+                  <a:srgbClr val="132257"/>
+                </a:solidFill>
+                <a:latin typeface="Exo 2" pitchFamily="34" charset="0"/>
+                <a:ea typeface="Exo 2" pitchFamily="34" charset="-122"/>
+                <a:cs typeface="Exo 2" pitchFamily="34" charset="-120"/>
+              </a:rPr>
+              <a:t>all sources</a:t>
+            </a:r>
+            <a:endParaRPr lang="en-US" sz="1000" dirty="0"/>
+          </a:p>
+        </p:txBody>
+      </p:sp>
+      <p:sp>
+        <p:nvSpPr>
+          <p:cNvPr id="28" name="Shape 21"/>
+          <p:cNvSpPr/>
+          <p:nvPr/>
+        </p:nvSpPr>
+        <p:spPr>
+          <a:xfrm>
+            <a:off x="8302752" y="4700016"/>
+            <a:ext cx="2615184" cy="713232"/>
+          </a:xfrm>
+          <a:prstGeom prst="rect">
+            <a:avLst/>
+          </a:prstGeom>
+          <a:solidFill>
+            <a:srgbClr val="FFFFFF"/>
+          </a:solidFill>
+          <a:ln w="19050">
+            <a:solidFill>
+              <a:srgbClr val="C53030"/>
+            </a:solidFill>
+            <a:prstDash val="solid"/>
+          </a:ln>
+        </p:spPr>
+      </p:sp>
+      <p:sp>
+        <p:nvSpPr>
+          <p:cNvPr id="29" name="Text 22"/>
+          <p:cNvSpPr txBox="1"/>
+          <p:nvPr/>
+        </p:nvSpPr>
+        <p:spPr>
+          <a:xfrm>
+            <a:off x="8439912" y="4700016"/>
+            <a:ext cx="868680" cy="713232"/>
+          </a:xfrm>
+          <a:prstGeom prst="rect">
+            <a:avLst/>
+          </a:prstGeom>
+          <a:noFill/>
+          <a:ln/>
+        </p:spPr>
+        <p:txBody>
+          <a:bodyPr wrap="square" lIns="0" tIns="0" rIns="0" bIns="0" rtlCol="0" anchor="ctr"/>
+          <a:lstStyle/>
+          <a:p>
+            <a:pPr indent="0" marL="0">
+              <a:buNone/>
+            </a:pPr>
+            <a:r>
+              <a:rPr lang="en-US" sz="2200" b="1" dirty="0">
+                <a:solidFill>
+                  <a:srgbClr val="C53030"/>
+                </a:solidFill>
+                <a:latin typeface="Exo 2" pitchFamily="34" charset="0"/>
+                <a:ea typeface="Exo 2" pitchFamily="34" charset="-122"/>
+                <a:cs typeface="Exo 2" pitchFamily="34" charset="-120"/>
+              </a:rPr>
+              <a:t>+3</a:t>
+            </a:r>
+            <a:endParaRPr lang="en-US" sz="2200" dirty="0"/>
+          </a:p>
+        </p:txBody>
+      </p:sp>
+      <p:sp>
+        <p:nvSpPr>
+          <p:cNvPr id="30" name="Text 23"/>
+          <p:cNvSpPr txBox="1"/>
+          <p:nvPr/>
+        </p:nvSpPr>
+        <p:spPr>
+          <a:xfrm>
+            <a:off x="9308592" y="4700016"/>
+            <a:ext cx="1517904" cy="713232"/>
+          </a:xfrm>
+          <a:prstGeom prst="rect">
+            <a:avLst/>
+          </a:prstGeom>
+          <a:noFill/>
+          <a:ln/>
+        </p:spPr>
+        <p:txBody>
+          <a:bodyPr wrap="square" lIns="0" tIns="0" rIns="0" bIns="0" rtlCol="0" anchor="ctr"/>
+          <a:lstStyle/>
+          <a:p>
+            <a:pPr indent="0" marL="0">
+              <a:buNone/>
+            </a:pPr>
+            <a:r>
+              <a:rPr lang="en-US" sz="1000" b="1" dirty="0">
+                <a:solidFill>
+                  <a:srgbClr val="132257"/>
+                </a:solidFill>
+                <a:latin typeface="Exo 2" pitchFamily="34" charset="0"/>
+                <a:ea typeface="Exo 2" pitchFamily="34" charset="-122"/>
+                <a:cs typeface="Exo 2" pitchFamily="34" charset="-120"/>
+              </a:rPr>
+              <a:t>onboarded, 21-27 Sep</a:t>
+            </a:r>
+            <a:endParaRPr lang="en-US" sz="1000" dirty="0"/>
+          </a:p>
+          <a:p>
+            <a:pPr indent="0" marL="0">
+              <a:buNone/>
+            </a:pPr>
+            <a:r>
+              <a:rPr lang="en-US" sz="850" dirty="0">
+                <a:solidFill>
+                  <a:srgbClr val="132257"/>
+                </a:solidFill>
+                <a:latin typeface="Exo 2" pitchFamily="34" charset="0"/>
+                <a:ea typeface="Exo 2" pitchFamily="34" charset="-122"/>
+                <a:cs typeface="Exo 2" pitchFamily="34" charset="-120"/>
+              </a:rPr>
+              <a:t>all sources</a:t>
+            </a:r>
+            <a:endParaRPr lang="en-US" sz="1000" dirty="0"/>
+          </a:p>
+        </p:txBody>
+      </p:sp>
+      <p:sp>
+        <p:nvSpPr>
+          <p:cNvPr id="31" name="Shape 24"/>
+          <p:cNvSpPr/>
+          <p:nvPr/>
+        </p:nvSpPr>
+        <p:spPr>
+          <a:xfrm>
+            <a:off x="7589520" y="3630168"/>
+            <a:ext cx="4041648" cy="0"/>
+          </a:xfrm>
+          <a:prstGeom prst="line">
+            <a:avLst/>
+          </a:prstGeom>
+          <a:noFill/>
+          <a:ln w="12700">
+            <a:solidFill>
+              <a:srgbClr val="C53030"/>
+            </a:solidFill>
+            <a:prstDash val="dash"/>
+          </a:ln>
+        </p:spPr>
+      </p:sp>
+      <p:sp>
+        <p:nvSpPr>
+          <p:cNvPr id="32" name="Text 25"/>
+          <p:cNvSpPr txBox="1"/>
+          <p:nvPr/>
+        </p:nvSpPr>
+        <p:spPr>
+          <a:xfrm>
+            <a:off x="7589520" y="3648456"/>
+            <a:ext cx="4041648" cy="182880"/>
+          </a:xfrm>
+          <a:prstGeom prst="rect">
+            <a:avLst/>
+          </a:prstGeom>
+          <a:noFill/>
+          <a:ln/>
+        </p:spPr>
+        <p:txBody>
+          <a:bodyPr wrap="square" lIns="0" tIns="0" rIns="0" bIns="0" rtlCol="0" anchor="t"/>
+          <a:lstStyle/>
+          <a:p>
+            <a:pPr algn="ctr" indent="0" marL="0">
+              <a:buNone/>
+            </a:pPr>
+            <a:r>
+              <a:rPr lang="en-US" sz="850" b="1" dirty="0">
+                <a:solidFill>
+                  <a:srgbClr val="C53030"/>
+                </a:solidFill>
+                <a:latin typeface="Exo 2" pitchFamily="34" charset="0"/>
+                <a:ea typeface="Exo 2" pitchFamily="34" charset="-122"/>
+                <a:cs typeface="Exo 2" pitchFamily="34" charset="-120"/>
+              </a:rPr>
+              <a:t>Tracking gap: installs not yet linked to ad clicks</a:t>
+            </a:r>
+            <a:endParaRPr lang="en-US" sz="850" dirty="0"/>
+          </a:p>
+        </p:txBody>
+      </p:sp>
+    </p:spTree>
+  </p:cSld>
+  <p:clrMapOvr>
+    <a:masterClrMapping/>
+  </p:clrMapOvr>
+</p:sld>
+</file>
+
+<file path=ppt/slides/slide5.xml><?xml version="1.0" encoding="utf-8"?>
+<p:sld xmlns:a="http://schemas.openxmlformats.org/drawingml/2006/main" xmlns:r="http://schemas.openxmlformats.org/officeDocument/2006/relationships" xmlns:p="http://schemas.openxmlformats.org/presentationml/2006/main">
+  <p:cSld name="Slide 5">
+    <p:bg>
+      <p:bgPr>
+        <a:solidFill>
+          <a:srgbClr val="FFFFFF"/>
+        </a:solidFill>
+      </p:bgPr>
+    </p:bg>
+    <p:spTree>
+      <p:nvGrpSpPr>
+        <p:cNvPr id="1" name=""/>
+        <p:cNvGrpSpPr/>
+        <p:nvPr/>
+      </p:nvGrpSpPr>
+      <p:grpSpPr>
+        <a:xfrm>
+          <a:off x="0" y="0"/>
+          <a:ext cx="0" cy="0"/>
+          <a:chOff x="0" y="0"/>
+          <a:chExt cx="0" cy="0"/>
+        </a:xfrm>
+      </p:grpSpPr>
+      <p:pic>
+        <p:nvPicPr>
+          <p:cNvPr id="2" name="Image 0" descr="/home/user/HatemIsa_202508993_IT9002_NLP_Project/emyaa-ceo-deck/working/charts/board_header.png">    </p:cNvPr>
+          <p:cNvPicPr>
+            <a:picLocks noChangeAspect="1"/>
+          </p:cNvPicPr>
+          <p:nvPr/>
+        </p:nvPicPr>
+        <p:blipFill>
+          <a:blip r:embed="rId1"/>
+          <a:stretch>
+            <a:fillRect/>
+          </a:stretch>
+        </p:blipFill>
+        <p:spPr>
+          <a:xfrm>
+            <a:off x="0" y="0"/>
+            <a:ext cx="12191695" cy="1298448"/>
+          </a:xfrm>
+          <a:prstGeom prst="rect">
+            <a:avLst/>
+          </a:prstGeom>
+        </p:spPr>
+      </p:pic>
+      <p:sp>
+        <p:nvSpPr>
+          <p:cNvPr id="3" name="Shape 0"/>
+          <p:cNvSpPr/>
+          <p:nvPr/>
+        </p:nvSpPr>
+        <p:spPr>
+          <a:xfrm>
+            <a:off x="0" y="1298448"/>
+            <a:ext cx="12191695" cy="24689"/>
+          </a:xfrm>
+          <a:prstGeom prst="rect">
+            <a:avLst/>
+          </a:prstGeom>
+          <a:solidFill>
+            <a:srgbClr val="D4AF37"/>
+          </a:solidFill>
+          <a:ln w="12700">
+            <a:solidFill>
+              <a:srgbClr val="D4AF37"/>
+            </a:solidFill>
+            <a:prstDash val="solid"/>
+          </a:ln>
+        </p:spPr>
+      </p:sp>
+      <p:sp>
+        <p:nvSpPr>
+          <p:cNvPr id="4" name="Text 1"/>
+          <p:cNvSpPr txBox="1"/>
+          <p:nvPr/>
+        </p:nvSpPr>
+        <p:spPr>
+          <a:xfrm>
+            <a:off x="566928" y="274320"/>
+            <a:ext cx="9144000" cy="182880"/>
+          </a:xfrm>
+          <a:prstGeom prst="rect">
+            <a:avLst/>
+          </a:prstGeom>
+          <a:noFill/>
+          <a:ln/>
+        </p:spPr>
+        <p:txBody>
+          <a:bodyPr wrap="square" lIns="0" tIns="0" rIns="0" bIns="0" rtlCol="0" anchor="t"/>
+          <a:lstStyle/>
+          <a:p>
+            <a:pPr indent="0" marL="0">
+              <a:buNone/>
+            </a:pPr>
+            <a:r>
+              <a:rPr lang="en-US" sz="900" b="1" spc="200" kern="0" dirty="0">
+                <a:solidFill>
+                  <a:srgbClr val="D4AF37"/>
+                </a:solidFill>
+                <a:latin typeface="Exo 2" pitchFamily="34" charset="0"/>
+                <a:ea typeface="Exo 2" pitchFamily="34" charset="-122"/>
+                <a:cs typeface="Exo 2" pitchFamily="34" charset="-120"/>
+              </a:rPr>
+              <a:t>ENGLISH VS ARABIC</a:t>
+            </a:r>
+            <a:endParaRPr lang="en-US" sz="900" dirty="0"/>
+          </a:p>
+        </p:txBody>
+      </p:sp>
+      <p:sp>
+        <p:nvSpPr>
+          <p:cNvPr id="5" name="Text 2"/>
+          <p:cNvSpPr txBox="1"/>
+          <p:nvPr/>
+        </p:nvSpPr>
+        <p:spPr>
+          <a:xfrm>
+            <a:off x="566928" y="475488"/>
+            <a:ext cx="9326880" cy="749808"/>
+          </a:xfrm>
+          <a:prstGeom prst="rect">
+            <a:avLst/>
+          </a:prstGeom>
+          <a:noFill/>
+          <a:ln/>
+        </p:spPr>
+        <p:txBody>
+          <a:bodyPr wrap="square" lIns="0" tIns="0" rIns="0" bIns="0" rtlCol="0" anchor="ctr"/>
+          <a:lstStyle/>
+          <a:p>
+            <a:pPr indent="0" marL="0">
+              <a:buNone/>
+            </a:pPr>
+            <a:r>
+              <a:rPr lang="en-US" sz="2000" b="1" dirty="0">
+                <a:solidFill>
+                  <a:srgbClr val="FFFFFF"/>
+                </a:solidFill>
+                <a:latin typeface="Exo 2" pitchFamily="34" charset="0"/>
+                <a:ea typeface="Exo 2" pitchFamily="34" charset="-122"/>
+                <a:cs typeface="Exo 2" pitchFamily="34" charset="-120"/>
+              </a:rPr>
+              <a:t>English ads lead Arabic on traffic and engagement; Arabic still logs more key events per session</a:t>
+            </a:r>
+            <a:endParaRPr lang="en-US" sz="2000" dirty="0"/>
+          </a:p>
+        </p:txBody>
+      </p:sp>
+      <p:pic>
+        <p:nvPicPr>
+          <p:cNvPr id="6" name="Image 1" descr="/home/user/HatemIsa_202508993_IT9002_NLP_Project/emyaa-ceo-deck/working/charts/ajyad_white.png">    </p:cNvPr>
+          <p:cNvPicPr>
+            <a:picLocks noChangeAspect="1"/>
+          </p:cNvPicPr>
+          <p:nvPr/>
+        </p:nvPicPr>
+        <p:blipFill>
+          <a:blip r:embed="rId2"/>
+          <a:stretch>
+            <a:fillRect/>
+          </a:stretch>
+        </p:blipFill>
+        <p:spPr>
+          <a:xfrm>
+            <a:off x="10305288" y="457200"/>
+            <a:ext cx="1325880" cy="384048"/>
+          </a:xfrm>
+          <a:prstGeom prst="rect">
+            <a:avLst/>
+          </a:prstGeom>
+        </p:spPr>
+      </p:pic>
+      <p:sp>
+        <p:nvSpPr>
+          <p:cNvPr id="7" name="Shape 3"/>
+          <p:cNvSpPr/>
+          <p:nvPr/>
+        </p:nvSpPr>
+        <p:spPr>
+          <a:xfrm>
+            <a:off x="566928" y="5669280"/>
+            <a:ext cx="11064240" cy="457200"/>
+          </a:xfrm>
+          <a:prstGeom prst="rect">
+            <a:avLst/>
+          </a:prstGeom>
+          <a:solidFill>
+            <a:srgbClr val="E3E8F2"/>
+          </a:solidFill>
+          <a:ln w="12700">
+            <a:solidFill>
+              <a:srgbClr val="E3E8F2"/>
+            </a:solidFill>
+            <a:prstDash val="solid"/>
+          </a:ln>
+        </p:spPr>
+      </p:sp>
+      <p:sp>
+        <p:nvSpPr>
+          <p:cNvPr id="8" name="Shape 4"/>
+          <p:cNvSpPr/>
+          <p:nvPr/>
+        </p:nvSpPr>
+        <p:spPr>
+          <a:xfrm>
+            <a:off x="566928" y="5669280"/>
+            <a:ext cx="45720" cy="457200"/>
+          </a:xfrm>
+          <a:prstGeom prst="rect">
+            <a:avLst/>
+          </a:prstGeom>
+          <a:solidFill>
+            <a:srgbClr val="D4AF37"/>
+          </a:solidFill>
+          <a:ln w="12700">
+            <a:solidFill>
+              <a:srgbClr val="D4AF37"/>
+            </a:solidFill>
+            <a:prstDash val="solid"/>
+          </a:ln>
+        </p:spPr>
+      </p:sp>
+      <p:sp>
+        <p:nvSpPr>
+          <p:cNvPr id="9" name="Text 5"/>
+          <p:cNvSpPr txBox="1"/>
+          <p:nvPr/>
+        </p:nvSpPr>
+        <p:spPr>
+          <a:xfrm>
+            <a:off x="777240" y="5669280"/>
+            <a:ext cx="10744200" cy="457200"/>
+          </a:xfrm>
+          <a:prstGeom prst="rect">
+            <a:avLst/>
+          </a:prstGeom>
+          <a:noFill/>
+          <a:ln/>
+        </p:spPr>
+        <p:txBody>
+          <a:bodyPr wrap="square" lIns="0" tIns="0" rIns="0" bIns="0" rtlCol="0" anchor="ctr"/>
+          <a:lstStyle/>
+          <a:p>
+            <a:pPr indent="0" marL="0">
+              <a:buNone/>
+            </a:pPr>
+            <a:r>
+              <a:rPr lang="en-US" sz="1150" b="1" dirty="0">
+                <a:solidFill>
+                  <a:srgbClr val="132257"/>
+                </a:solidFill>
+                <a:latin typeface="Exo 2" pitchFamily="34" charset="0"/>
+                <a:ea typeface="Exo 2" pitchFamily="34" charset="-122"/>
+                <a:cs typeface="Exo 2" pitchFamily="34" charset="-120"/>
+              </a:rPr>
+              <a:t>Takeaway   </a:t>
+            </a:r>
+            <a:pPr indent="0" marL="0">
+              <a:buNone/>
+            </a:pPr>
+            <a:r>
+              <a:rPr lang="en-US" sz="1150" dirty="0">
+                <a:solidFill>
+                  <a:srgbClr val="1F2A44"/>
+                </a:solidFill>
+                <a:latin typeface="Exo 2" pitchFamily="34" charset="0"/>
+                <a:ea typeface="Exo 2" pitchFamily="34" charset="-122"/>
+                <a:cs typeface="Exo 2" pitchFamily="34" charset="-120"/>
+              </a:rPr>
+              <a:t>English is ahead on 8 of 9 measures. Refresh the Arabic creative to lift engagement, but keep it live: it converts slightly better per session.</a:t>
+            </a:r>
+            <a:endParaRPr lang="en-US" sz="1150" dirty="0"/>
+          </a:p>
+        </p:txBody>
+      </p:sp>
+      <p:sp>
+        <p:nvSpPr>
+          <p:cNvPr id="10" name="Text 6"/>
+          <p:cNvSpPr txBox="1"/>
+          <p:nvPr/>
+        </p:nvSpPr>
+        <p:spPr>
+          <a:xfrm>
+            <a:off x="566928" y="6199632"/>
+            <a:ext cx="9692640" cy="274320"/>
+          </a:xfrm>
+          <a:prstGeom prst="rect">
+            <a:avLst/>
+          </a:prstGeom>
+          <a:noFill/>
+          <a:ln/>
+        </p:spPr>
+        <p:txBody>
+          <a:bodyPr wrap="square" lIns="0" tIns="0" rIns="0" bIns="0" rtlCol="0" anchor="t"/>
+          <a:lstStyle/>
+          <a:p>
+            <a:pPr indent="0" marL="0">
+              <a:buNone/>
+            </a:pPr>
+            <a:r>
+              <a:rPr lang="en-US" sz="800" dirty="0">
+                <a:solidFill>
+                  <a:srgbClr val="7A849C"/>
+                </a:solidFill>
+                <a:latin typeface="Exo 2" pitchFamily="34" charset="0"/>
+                <a:ea typeface="Exo 2" pitchFamily="34" charset="-122"/>
+                <a:cs typeface="Exo 2" pitchFamily="34" charset="-120"/>
+              </a:rPr>
+              <a:t>Source: GA4 Google Ads campaigns export, 1-28 Sep 2026: 'Website conversion - Saudi - English' vs '... - Arabic'. Campaigns live from 22 Sep. Key event not defined in the export.</a:t>
+            </a:r>
+            <a:endParaRPr lang="en-US" sz="800" dirty="0"/>
+          </a:p>
+        </p:txBody>
+      </p:sp>
+      <p:sp>
+        <p:nvSpPr>
+          <p:cNvPr id="11" name="Text 7"/>
+          <p:cNvSpPr txBox="1"/>
+          <p:nvPr/>
+        </p:nvSpPr>
+        <p:spPr>
+          <a:xfrm>
+            <a:off x="566928" y="6510528"/>
+            <a:ext cx="5486400" cy="201168"/>
+          </a:xfrm>
+          <a:prstGeom prst="rect">
+            <a:avLst/>
+          </a:prstGeom>
+          <a:noFill/>
+          <a:ln/>
+        </p:spPr>
+        <p:txBody>
+          <a:bodyPr wrap="square" lIns="0" tIns="0" rIns="0" bIns="0" rtlCol="0" anchor="t"/>
+          <a:lstStyle/>
+          <a:p>
+            <a:pPr indent="0" marL="0">
+              <a:buNone/>
+            </a:pPr>
+            <a:r>
+              <a:rPr lang="en-US" sz="800" dirty="0">
+                <a:solidFill>
+                  <a:srgbClr val="8A93A8"/>
+                </a:solidFill>
+                <a:latin typeface="Exo 2" pitchFamily="34" charset="0"/>
+                <a:ea typeface="Exo 2" pitchFamily="34" charset="-122"/>
+                <a:cs typeface="Exo 2" pitchFamily="34" charset="-120"/>
+              </a:rPr>
+              <a:t>eMYAA Trading Platform  |  CEO Marketing Update</a:t>
+            </a:r>
+            <a:endParaRPr lang="en-US" sz="800" dirty="0"/>
+          </a:p>
+        </p:txBody>
+      </p:sp>
+      <p:sp>
+        <p:nvSpPr>
+          <p:cNvPr id="12" name="Text 8"/>
+          <p:cNvSpPr txBox="1"/>
+          <p:nvPr/>
+        </p:nvSpPr>
+        <p:spPr>
+          <a:xfrm>
+            <a:off x="9802368" y="6510528"/>
+            <a:ext cx="457200" cy="201168"/>
+          </a:xfrm>
+          <a:prstGeom prst="rect">
+            <a:avLst/>
+          </a:prstGeom>
+          <a:noFill/>
+          <a:ln/>
+        </p:spPr>
+        <p:txBody>
+          <a:bodyPr wrap="square" lIns="0" tIns="0" rIns="0" bIns="0" rtlCol="0" anchor="t"/>
+          <a:lstStyle/>
+          <a:p>
+            <a:pPr algn="r" indent="0" marL="0">
+              <a:buNone/>
+            </a:pPr>
+            <a:r>
+              <a:rPr lang="en-US" sz="800" dirty="0">
+                <a:solidFill>
+                  <a:srgbClr val="8A93A8"/>
+                </a:solidFill>
+                <a:latin typeface="Exo 2" pitchFamily="34" charset="0"/>
+                <a:ea typeface="Exo 2" pitchFamily="34" charset="-122"/>
+                <a:cs typeface="Exo 2" pitchFamily="34" charset="-120"/>
+              </a:rPr>
+              <a:t>5</a:t>
+            </a:r>
+            <a:endParaRPr lang="en-US" sz="800" dirty="0"/>
+          </a:p>
+        </p:txBody>
+      </p:sp>
+      <p:pic>
+        <p:nvPicPr>
+          <p:cNvPr id="13" name="Image 2" descr="/home/user/HatemIsa_202508993_IT9002_NLP_Project/emyaa-ceo-deck/working/charts/emyaa_navy.png">    </p:cNvPr>
+          <p:cNvPicPr>
+            <a:picLocks noChangeAspect="1"/>
+          </p:cNvPicPr>
+          <p:nvPr/>
+        </p:nvPicPr>
+        <p:blipFill>
+          <a:blip r:embed="rId3"/>
+          <a:stretch>
+            <a:fillRect/>
+          </a:stretch>
+        </p:blipFill>
+        <p:spPr>
+          <a:xfrm>
+            <a:off x="10607040" y="6336792"/>
+            <a:ext cx="1024128" cy="365760"/>
+          </a:xfrm>
+          <a:prstGeom prst="rect">
+            <a:avLst/>
+          </a:prstGeom>
+        </p:spPr>
+      </p:pic>
+      <p:sp>
+        <p:nvSpPr>
+          <p:cNvPr id="15" name="Shape 9"/>
+          <p:cNvSpPr/>
+          <p:nvPr/>
+        </p:nvSpPr>
+        <p:spPr>
+          <a:xfrm>
+            <a:off x="566928" y="1572768"/>
+            <a:ext cx="4206240" cy="1828800"/>
+          </a:xfrm>
+          <a:prstGeom prst="rect">
+            <a:avLst/>
+          </a:prstGeom>
+          <a:solidFill>
+            <a:srgbClr val="FFFFFF"/>
+          </a:solidFill>
+          <a:ln w="9525">
+            <a:solidFill>
+              <a:srgbClr val="D9DFEA"/>
+            </a:solidFill>
+            <a:prstDash val="solid"/>
+          </a:ln>
+        </p:spPr>
+      </p:sp>
+      <p:sp>
+        <p:nvSpPr>
+          <p:cNvPr id="16" name="Shape 10"/>
+          <p:cNvSpPr/>
+          <p:nvPr/>
+        </p:nvSpPr>
+        <p:spPr>
+          <a:xfrm>
+            <a:off x="566928" y="1572768"/>
+            <a:ext cx="4206240" cy="32004"/>
+          </a:xfrm>
+          <a:prstGeom prst="rect">
+            <a:avLst/>
+          </a:prstGeom>
+          <a:solidFill>
+            <a:srgbClr val="132257"/>
+          </a:solidFill>
+          <a:ln w="12700">
+            <a:solidFill>
+              <a:srgbClr val="132257"/>
+            </a:solidFill>
+            <a:prstDash val="solid"/>
+          </a:ln>
+        </p:spPr>
+      </p:sp>
+      <p:sp>
+        <p:nvSpPr>
+          <p:cNvPr id="17" name="Text 11"/>
+          <p:cNvSpPr txBox="1"/>
+          <p:nvPr/>
+        </p:nvSpPr>
+        <p:spPr>
+          <a:xfrm>
+            <a:off x="795528" y="1755648"/>
+            <a:ext cx="2743200" cy="228600"/>
+          </a:xfrm>
+          <a:prstGeom prst="rect">
+            <a:avLst/>
+          </a:prstGeom>
+          <a:noFill/>
+          <a:ln/>
+        </p:spPr>
+        <p:txBody>
+          <a:bodyPr wrap="square" lIns="0" tIns="0" rIns="0" bIns="0" rtlCol="0" anchor="t"/>
+          <a:lstStyle/>
+          <a:p>
+            <a:pPr indent="0" marL="0">
+              <a:buNone/>
+            </a:pPr>
+            <a:r>
+              <a:rPr lang="en-US" sz="900" b="1" spc="200" kern="0" dirty="0">
+                <a:solidFill>
+                  <a:srgbClr val="9A7B1F"/>
+                </a:solidFill>
+                <a:latin typeface="Exo 2" pitchFamily="34" charset="0"/>
+                <a:ea typeface="Exo 2" pitchFamily="34" charset="-122"/>
+                <a:cs typeface="Exo 2" pitchFamily="34" charset="-120"/>
+              </a:rPr>
+              <a:t>ENGLISH CAMPAIGN</a:t>
+            </a:r>
+            <a:endParaRPr lang="en-US" sz="900" dirty="0"/>
+          </a:p>
+        </p:txBody>
+      </p:sp>
+      <p:sp>
+        <p:nvSpPr>
+          <p:cNvPr id="18" name="Text 12"/>
+          <p:cNvSpPr txBox="1"/>
+          <p:nvPr/>
+        </p:nvSpPr>
+        <p:spPr>
+          <a:xfrm>
+            <a:off x="795528" y="2075688"/>
+            <a:ext cx="1920240" cy="347472"/>
+          </a:xfrm>
+          <a:prstGeom prst="rect">
+            <a:avLst/>
+          </a:prstGeom>
+          <a:noFill/>
+          <a:ln/>
+        </p:spPr>
+        <p:txBody>
+          <a:bodyPr wrap="square" lIns="0" tIns="0" rIns="0" bIns="0" rtlCol="0" anchor="t"/>
+          <a:lstStyle/>
+          <a:p>
+            <a:pPr indent="0" marL="0">
+              <a:buNone/>
+            </a:pPr>
+            <a:r>
+              <a:rPr lang="en-US" sz="2000" b="1" dirty="0">
+                <a:solidFill>
+                  <a:srgbClr val="1BA97C"/>
+                </a:solidFill>
+                <a:latin typeface="Exo 2" pitchFamily="34" charset="0"/>
+                <a:ea typeface="Exo 2" pitchFamily="34" charset="-122"/>
+                <a:cs typeface="Exo 2" pitchFamily="34" charset="-120"/>
+              </a:rPr>
+              <a:t>212</a:t>
+            </a:r>
+            <a:endParaRPr lang="en-US" sz="2000" dirty="0"/>
+          </a:p>
+        </p:txBody>
+      </p:sp>
+      <p:sp>
+        <p:nvSpPr>
+          <p:cNvPr id="19" name="Text 13"/>
+          <p:cNvSpPr txBox="1"/>
+          <p:nvPr/>
+        </p:nvSpPr>
+        <p:spPr>
+          <a:xfrm>
+            <a:off x="795528" y="2404872"/>
+            <a:ext cx="1920240" cy="228600"/>
+          </a:xfrm>
+          <a:prstGeom prst="rect">
+            <a:avLst/>
+          </a:prstGeom>
+          <a:noFill/>
+          <a:ln/>
+        </p:spPr>
+        <p:txBody>
+          <a:bodyPr wrap="square" lIns="0" tIns="0" rIns="0" bIns="0" rtlCol="0" anchor="t"/>
+          <a:lstStyle/>
+          <a:p>
+            <a:pPr indent="0" marL="0">
+              <a:buNone/>
+            </a:pPr>
+            <a:r>
+              <a:rPr lang="en-US" sz="900" dirty="0">
+                <a:solidFill>
+                  <a:srgbClr val="7A849C"/>
+                </a:solidFill>
+                <a:latin typeface="Exo 2" pitchFamily="34" charset="0"/>
+                <a:ea typeface="Exo 2" pitchFamily="34" charset="-122"/>
+                <a:cs typeface="Exo 2" pitchFamily="34" charset="-120"/>
+              </a:rPr>
+              <a:t>sessions</a:t>
+            </a:r>
+            <a:endParaRPr lang="en-US" sz="900" dirty="0"/>
+          </a:p>
+        </p:txBody>
+      </p:sp>
+      <p:sp>
+        <p:nvSpPr>
+          <p:cNvPr id="20" name="Text 14"/>
+          <p:cNvSpPr txBox="1"/>
+          <p:nvPr/>
+        </p:nvSpPr>
+        <p:spPr>
+          <a:xfrm>
+            <a:off x="2807208" y="2075688"/>
+            <a:ext cx="1920240" cy="347472"/>
+          </a:xfrm>
+          <a:prstGeom prst="rect">
+            <a:avLst/>
+          </a:prstGeom>
+          <a:noFill/>
+          <a:ln/>
+        </p:spPr>
+        <p:txBody>
+          <a:bodyPr wrap="square" lIns="0" tIns="0" rIns="0" bIns="0" rtlCol="0" anchor="t"/>
+          <a:lstStyle/>
+          <a:p>
+            <a:pPr indent="0" marL="0">
+              <a:buNone/>
+            </a:pPr>
+            <a:r>
+              <a:rPr lang="en-US" sz="2000" b="1" dirty="0">
+                <a:solidFill>
+                  <a:srgbClr val="1BA97C"/>
+                </a:solidFill>
+                <a:latin typeface="Exo 2" pitchFamily="34" charset="0"/>
+                <a:ea typeface="Exo 2" pitchFamily="34" charset="-122"/>
+                <a:cs typeface="Exo 2" pitchFamily="34" charset="-120"/>
+              </a:rPr>
+              <a:t>97.2%</a:t>
+            </a:r>
+            <a:endParaRPr lang="en-US" sz="2000" dirty="0"/>
+          </a:p>
+        </p:txBody>
+      </p:sp>
+      <p:sp>
+        <p:nvSpPr>
+          <p:cNvPr id="21" name="Text 15"/>
+          <p:cNvSpPr txBox="1"/>
+          <p:nvPr/>
+        </p:nvSpPr>
+        <p:spPr>
+          <a:xfrm>
+            <a:off x="2807208" y="2404872"/>
+            <a:ext cx="1920240" cy="228600"/>
+          </a:xfrm>
+          <a:prstGeom prst="rect">
+            <a:avLst/>
+          </a:prstGeom>
+          <a:noFill/>
+          <a:ln/>
+        </p:spPr>
+        <p:txBody>
+          <a:bodyPr wrap="square" lIns="0" tIns="0" rIns="0" bIns="0" rtlCol="0" anchor="t"/>
+          <a:lstStyle/>
+          <a:p>
+            <a:pPr indent="0" marL="0">
+              <a:buNone/>
+            </a:pPr>
+            <a:r>
+              <a:rPr lang="en-US" sz="900" dirty="0">
+                <a:solidFill>
+                  <a:srgbClr val="7A849C"/>
+                </a:solidFill>
+                <a:latin typeface="Exo 2" pitchFamily="34" charset="0"/>
+                <a:ea typeface="Exo 2" pitchFamily="34" charset="-122"/>
+                <a:cs typeface="Exo 2" pitchFamily="34" charset="-120"/>
+              </a:rPr>
+              <a:t>engagement rate</a:t>
+            </a:r>
+            <a:endParaRPr lang="en-US" sz="900" dirty="0"/>
+          </a:p>
+        </p:txBody>
+      </p:sp>
+      <p:sp>
+        <p:nvSpPr>
+          <p:cNvPr id="22" name="Text 16"/>
+          <p:cNvSpPr txBox="1"/>
+          <p:nvPr/>
+        </p:nvSpPr>
+        <p:spPr>
+          <a:xfrm>
+            <a:off x="795528" y="2715768"/>
+            <a:ext cx="1920240" cy="347472"/>
+          </a:xfrm>
+          <a:prstGeom prst="rect">
+            <a:avLst/>
+          </a:prstGeom>
+          <a:noFill/>
+          <a:ln/>
+        </p:spPr>
+        <p:txBody>
+          <a:bodyPr wrap="square" lIns="0" tIns="0" rIns="0" bIns="0" rtlCol="0" anchor="t"/>
+          <a:lstStyle/>
+          <a:p>
+            <a:pPr indent="0" marL="0">
+              <a:buNone/>
+            </a:pPr>
+            <a:r>
+              <a:rPr lang="en-US" sz="2000" b="1" dirty="0">
+                <a:solidFill>
+                  <a:srgbClr val="1BA97C"/>
+                </a:solidFill>
+                <a:latin typeface="Exo 2" pitchFamily="34" charset="0"/>
+                <a:ea typeface="Exo 2" pitchFamily="34" charset="-122"/>
+                <a:cs typeface="Exo 2" pitchFamily="34" charset="-120"/>
+              </a:rPr>
+              <a:t>19.9s</a:t>
+            </a:r>
+            <a:endParaRPr lang="en-US" sz="2000" dirty="0"/>
+          </a:p>
+        </p:txBody>
+      </p:sp>
+      <p:sp>
+        <p:nvSpPr>
+          <p:cNvPr id="23" name="Text 17"/>
+          <p:cNvSpPr txBox="1"/>
+          <p:nvPr/>
+        </p:nvSpPr>
+        <p:spPr>
+          <a:xfrm>
+            <a:off x="795528" y="3044952"/>
+            <a:ext cx="1920240" cy="228600"/>
+          </a:xfrm>
+          <a:prstGeom prst="rect">
+            <a:avLst/>
+          </a:prstGeom>
+          <a:noFill/>
+          <a:ln/>
+        </p:spPr>
+        <p:txBody>
+          <a:bodyPr wrap="square" lIns="0" tIns="0" rIns="0" bIns="0" rtlCol="0" anchor="t"/>
+          <a:lstStyle/>
+          <a:p>
+            <a:pPr indent="0" marL="0">
+              <a:buNone/>
+            </a:pPr>
+            <a:r>
+              <a:rPr lang="en-US" sz="900" dirty="0">
+                <a:solidFill>
+                  <a:srgbClr val="7A849C"/>
+                </a:solidFill>
+                <a:latin typeface="Exo 2" pitchFamily="34" charset="0"/>
+                <a:ea typeface="Exo 2" pitchFamily="34" charset="-122"/>
+                <a:cs typeface="Exo 2" pitchFamily="34" charset="-120"/>
+              </a:rPr>
+              <a:t>per session</a:t>
+            </a:r>
+            <a:endParaRPr lang="en-US" sz="900" dirty="0"/>
+          </a:p>
+        </p:txBody>
+      </p:sp>
+      <p:sp>
+        <p:nvSpPr>
+          <p:cNvPr id="24" name="Text 18"/>
+          <p:cNvSpPr txBox="1"/>
+          <p:nvPr/>
+        </p:nvSpPr>
+        <p:spPr>
+          <a:xfrm>
+            <a:off x="2807208" y="2715768"/>
+            <a:ext cx="1920240" cy="347472"/>
+          </a:xfrm>
+          <a:prstGeom prst="rect">
+            <a:avLst/>
+          </a:prstGeom>
+          <a:noFill/>
+          <a:ln/>
+        </p:spPr>
+        <p:txBody>
+          <a:bodyPr wrap="square" lIns="0" tIns="0" rIns="0" bIns="0" rtlCol="0" anchor="t"/>
+          <a:lstStyle/>
+          <a:p>
+            <a:pPr indent="0" marL="0">
+              <a:buNone/>
+            </a:pPr>
+            <a:r>
+              <a:rPr lang="en-US" sz="2000" b="1" dirty="0">
+                <a:solidFill>
+                  <a:srgbClr val="132257"/>
+                </a:solidFill>
+                <a:latin typeface="Exo 2" pitchFamily="34" charset="0"/>
+                <a:ea typeface="Exo 2" pitchFamily="34" charset="-122"/>
+                <a:cs typeface="Exo 2" pitchFamily="34" charset="-120"/>
+              </a:rPr>
+              <a:t>0.94</a:t>
+            </a:r>
+            <a:endParaRPr lang="en-US" sz="2000" dirty="0"/>
+          </a:p>
+        </p:txBody>
+      </p:sp>
+      <p:sp>
+        <p:nvSpPr>
+          <p:cNvPr id="25" name="Text 19"/>
+          <p:cNvSpPr txBox="1"/>
+          <p:nvPr/>
+        </p:nvSpPr>
+        <p:spPr>
+          <a:xfrm>
+            <a:off x="2807208" y="3044952"/>
+            <a:ext cx="1920240" cy="228600"/>
+          </a:xfrm>
+          <a:prstGeom prst="rect">
+            <a:avLst/>
+          </a:prstGeom>
+          <a:noFill/>
+          <a:ln/>
+        </p:spPr>
+        <p:txBody>
+          <a:bodyPr wrap="square" lIns="0" tIns="0" rIns="0" bIns="0" rtlCol="0" anchor="t"/>
+          <a:lstStyle/>
+          <a:p>
+            <a:pPr indent="0" marL="0">
+              <a:buNone/>
+            </a:pPr>
+            <a:r>
+              <a:rPr lang="en-US" sz="900" dirty="0">
+                <a:solidFill>
+                  <a:srgbClr val="7A849C"/>
+                </a:solidFill>
+                <a:latin typeface="Exo 2" pitchFamily="34" charset="0"/>
+                <a:ea typeface="Exo 2" pitchFamily="34" charset="-122"/>
+                <a:cs typeface="Exo 2" pitchFamily="34" charset="-120"/>
+              </a:rPr>
+              <a:t>key events per session</a:t>
+            </a:r>
+            <a:endParaRPr lang="en-US" sz="900" dirty="0"/>
+          </a:p>
+        </p:txBody>
+      </p:sp>
+      <p:sp>
+        <p:nvSpPr>
+          <p:cNvPr id="26" name="Shape 20"/>
+          <p:cNvSpPr/>
+          <p:nvPr/>
+        </p:nvSpPr>
+        <p:spPr>
+          <a:xfrm>
+            <a:off x="566928" y="3584448"/>
+            <a:ext cx="4206240" cy="1828800"/>
+          </a:xfrm>
+          <a:prstGeom prst="rect">
+            <a:avLst/>
+          </a:prstGeom>
+          <a:solidFill>
+            <a:srgbClr val="FFFFFF"/>
+          </a:solidFill>
+          <a:ln w="9525">
+            <a:solidFill>
+              <a:srgbClr val="D9DFEA"/>
+            </a:solidFill>
+            <a:prstDash val="solid"/>
+          </a:ln>
+        </p:spPr>
+      </p:sp>
+      <p:sp>
+        <p:nvSpPr>
+          <p:cNvPr id="27" name="Shape 21"/>
+          <p:cNvSpPr/>
+          <p:nvPr/>
+        </p:nvSpPr>
+        <p:spPr>
+          <a:xfrm>
+            <a:off x="566928" y="3584448"/>
+            <a:ext cx="4206240" cy="32004"/>
+          </a:xfrm>
+          <a:prstGeom prst="rect">
+            <a:avLst/>
+          </a:prstGeom>
+          <a:solidFill>
+            <a:srgbClr val="D4AF37"/>
+          </a:solidFill>
+          <a:ln w="12700">
+            <a:solidFill>
+              <a:srgbClr val="D4AF37"/>
+            </a:solidFill>
+            <a:prstDash val="solid"/>
+          </a:ln>
+        </p:spPr>
+      </p:sp>
+      <p:sp>
+        <p:nvSpPr>
+          <p:cNvPr id="28" name="Text 22"/>
+          <p:cNvSpPr txBox="1"/>
+          <p:nvPr/>
+        </p:nvSpPr>
+        <p:spPr>
+          <a:xfrm>
+            <a:off x="795528" y="3767328"/>
+            <a:ext cx="2743200" cy="228600"/>
+          </a:xfrm>
+          <a:prstGeom prst="rect">
+            <a:avLst/>
+          </a:prstGeom>
+          <a:noFill/>
+          <a:ln/>
+        </p:spPr>
+        <p:txBody>
+          <a:bodyPr wrap="square" lIns="0" tIns="0" rIns="0" bIns="0" rtlCol="0" anchor="t"/>
+          <a:lstStyle/>
+          <a:p>
+            <a:pPr indent="0" marL="0">
+              <a:buNone/>
+            </a:pPr>
+            <a:r>
+              <a:rPr lang="en-US" sz="900" b="1" spc="200" kern="0" dirty="0">
+                <a:solidFill>
+                  <a:srgbClr val="9A7B1F"/>
+                </a:solidFill>
+                <a:latin typeface="Exo 2" pitchFamily="34" charset="0"/>
+                <a:ea typeface="Exo 2" pitchFamily="34" charset="-122"/>
+                <a:cs typeface="Exo 2" pitchFamily="34" charset="-120"/>
+              </a:rPr>
+              <a:t>ARABIC CAMPAIGN</a:t>
+            </a:r>
+            <a:endParaRPr lang="en-US" sz="900" dirty="0"/>
+          </a:p>
+        </p:txBody>
+      </p:sp>
+      <p:sp>
+        <p:nvSpPr>
+          <p:cNvPr id="29" name="Text 23"/>
+          <p:cNvSpPr txBox="1"/>
+          <p:nvPr/>
+        </p:nvSpPr>
+        <p:spPr>
+          <a:xfrm>
+            <a:off x="795528" y="4087368"/>
+            <a:ext cx="1920240" cy="347472"/>
+          </a:xfrm>
+          <a:prstGeom prst="rect">
+            <a:avLst/>
+          </a:prstGeom>
+          <a:noFill/>
+          <a:ln/>
+        </p:spPr>
+        <p:txBody>
+          <a:bodyPr wrap="square" lIns="0" tIns="0" rIns="0" bIns="0" rtlCol="0" anchor="t"/>
+          <a:lstStyle/>
+          <a:p>
+            <a:pPr indent="0" marL="0">
+              <a:buNone/>
+            </a:pPr>
+            <a:r>
+              <a:rPr lang="en-US" sz="2000" b="1" dirty="0">
+                <a:solidFill>
+                  <a:srgbClr val="132257"/>
+                </a:solidFill>
+                <a:latin typeface="Exo 2" pitchFamily="34" charset="0"/>
+                <a:ea typeface="Exo 2" pitchFamily="34" charset="-122"/>
+                <a:cs typeface="Exo 2" pitchFamily="34" charset="-120"/>
+              </a:rPr>
+              <a:t>176</a:t>
+            </a:r>
+            <a:endParaRPr lang="en-US" sz="2000" dirty="0"/>
+          </a:p>
+        </p:txBody>
+      </p:sp>
+      <p:sp>
+        <p:nvSpPr>
+          <p:cNvPr id="30" name="Text 24"/>
+          <p:cNvSpPr txBox="1"/>
+          <p:nvPr/>
+        </p:nvSpPr>
+        <p:spPr>
+          <a:xfrm>
+            <a:off x="795528" y="4416552"/>
+            <a:ext cx="1920240" cy="228600"/>
+          </a:xfrm>
+          <a:prstGeom prst="rect">
+            <a:avLst/>
+          </a:prstGeom>
+          <a:noFill/>
+          <a:ln/>
+        </p:spPr>
+        <p:txBody>
+          <a:bodyPr wrap="square" lIns="0" tIns="0" rIns="0" bIns="0" rtlCol="0" anchor="t"/>
+          <a:lstStyle/>
+          <a:p>
+            <a:pPr indent="0" marL="0">
+              <a:buNone/>
+            </a:pPr>
+            <a:r>
+              <a:rPr lang="en-US" sz="900" dirty="0">
+                <a:solidFill>
+                  <a:srgbClr val="7A849C"/>
+                </a:solidFill>
+                <a:latin typeface="Exo 2" pitchFamily="34" charset="0"/>
+                <a:ea typeface="Exo 2" pitchFamily="34" charset="-122"/>
+                <a:cs typeface="Exo 2" pitchFamily="34" charset="-120"/>
+              </a:rPr>
+              <a:t>sessions</a:t>
+            </a:r>
+            <a:endParaRPr lang="en-US" sz="900" dirty="0"/>
+          </a:p>
+        </p:txBody>
+      </p:sp>
+      <p:sp>
+        <p:nvSpPr>
+          <p:cNvPr id="31" name="Text 25"/>
+          <p:cNvSpPr txBox="1"/>
+          <p:nvPr/>
+        </p:nvSpPr>
+        <p:spPr>
+          <a:xfrm>
+            <a:off x="2807208" y="4087368"/>
+            <a:ext cx="1920240" cy="347472"/>
+          </a:xfrm>
+          <a:prstGeom prst="rect">
+            <a:avLst/>
+          </a:prstGeom>
+          <a:noFill/>
+          <a:ln/>
+        </p:spPr>
+        <p:txBody>
+          <a:bodyPr wrap="square" lIns="0" tIns="0" rIns="0" bIns="0" rtlCol="0" anchor="t"/>
+          <a:lstStyle/>
+          <a:p>
+            <a:pPr indent="0" marL="0">
+              <a:buNone/>
+            </a:pPr>
+            <a:r>
+              <a:rPr lang="en-US" sz="2000" b="1" dirty="0">
+                <a:solidFill>
+                  <a:srgbClr val="132257"/>
+                </a:solidFill>
+                <a:latin typeface="Exo 2" pitchFamily="34" charset="0"/>
+                <a:ea typeface="Exo 2" pitchFamily="34" charset="-122"/>
+                <a:cs typeface="Exo 2" pitchFamily="34" charset="-120"/>
+              </a:rPr>
+              <a:t>86.9%</a:t>
+            </a:r>
+            <a:endParaRPr lang="en-US" sz="2000" dirty="0"/>
+          </a:p>
+        </p:txBody>
+      </p:sp>
+      <p:sp>
+        <p:nvSpPr>
+          <p:cNvPr id="32" name="Text 26"/>
+          <p:cNvSpPr txBox="1"/>
+          <p:nvPr/>
+        </p:nvSpPr>
+        <p:spPr>
+          <a:xfrm>
+            <a:off x="2807208" y="4416552"/>
+            <a:ext cx="1920240" cy="228600"/>
+          </a:xfrm>
+          <a:prstGeom prst="rect">
+            <a:avLst/>
+          </a:prstGeom>
+          <a:noFill/>
+          <a:ln/>
+        </p:spPr>
+        <p:txBody>
+          <a:bodyPr wrap="square" lIns="0" tIns="0" rIns="0" bIns="0" rtlCol="0" anchor="t"/>
+          <a:lstStyle/>
+          <a:p>
+            <a:pPr indent="0" marL="0">
+              <a:buNone/>
+            </a:pPr>
+            <a:r>
+              <a:rPr lang="en-US" sz="900" dirty="0">
+                <a:solidFill>
+                  <a:srgbClr val="7A849C"/>
+                </a:solidFill>
+                <a:latin typeface="Exo 2" pitchFamily="34" charset="0"/>
+                <a:ea typeface="Exo 2" pitchFamily="34" charset="-122"/>
+                <a:cs typeface="Exo 2" pitchFamily="34" charset="-120"/>
+              </a:rPr>
+              <a:t>engagement rate</a:t>
+            </a:r>
+            <a:endParaRPr lang="en-US" sz="900" dirty="0"/>
+          </a:p>
+        </p:txBody>
+      </p:sp>
+      <p:sp>
+        <p:nvSpPr>
+          <p:cNvPr id="33" name="Text 27"/>
+          <p:cNvSpPr txBox="1"/>
+          <p:nvPr/>
+        </p:nvSpPr>
+        <p:spPr>
+          <a:xfrm>
+            <a:off x="795528" y="4727448"/>
+            <a:ext cx="1920240" cy="347472"/>
+          </a:xfrm>
+          <a:prstGeom prst="rect">
+            <a:avLst/>
+          </a:prstGeom>
+          <a:noFill/>
+          <a:ln/>
+        </p:spPr>
+        <p:txBody>
+          <a:bodyPr wrap="square" lIns="0" tIns="0" rIns="0" bIns="0" rtlCol="0" anchor="t"/>
+          <a:lstStyle/>
+          <a:p>
+            <a:pPr indent="0" marL="0">
+              <a:buNone/>
+            </a:pPr>
+            <a:r>
+              <a:rPr lang="en-US" sz="2000" b="1" dirty="0">
+                <a:solidFill>
+                  <a:srgbClr val="132257"/>
+                </a:solidFill>
+                <a:latin typeface="Exo 2" pitchFamily="34" charset="0"/>
+                <a:ea typeface="Exo 2" pitchFamily="34" charset="-122"/>
+                <a:cs typeface="Exo 2" pitchFamily="34" charset="-120"/>
+              </a:rPr>
+              <a:t>16.0s</a:t>
+            </a:r>
+            <a:endParaRPr lang="en-US" sz="2000" dirty="0"/>
+          </a:p>
+        </p:txBody>
+      </p:sp>
+      <p:sp>
+        <p:nvSpPr>
+          <p:cNvPr id="34" name="Text 28"/>
+          <p:cNvSpPr txBox="1"/>
+          <p:nvPr/>
+        </p:nvSpPr>
+        <p:spPr>
+          <a:xfrm>
+            <a:off x="795528" y="5056632"/>
+            <a:ext cx="1920240" cy="228600"/>
+          </a:xfrm>
+          <a:prstGeom prst="rect">
+            <a:avLst/>
+          </a:prstGeom>
+          <a:noFill/>
+          <a:ln/>
+        </p:spPr>
+        <p:txBody>
+          <a:bodyPr wrap="square" lIns="0" tIns="0" rIns="0" bIns="0" rtlCol="0" anchor="t"/>
+          <a:lstStyle/>
+          <a:p>
+            <a:pPr indent="0" marL="0">
+              <a:buNone/>
+            </a:pPr>
+            <a:r>
+              <a:rPr lang="en-US" sz="900" dirty="0">
+                <a:solidFill>
+                  <a:srgbClr val="7A849C"/>
+                </a:solidFill>
+                <a:latin typeface="Exo 2" pitchFamily="34" charset="0"/>
+                <a:ea typeface="Exo 2" pitchFamily="34" charset="-122"/>
+                <a:cs typeface="Exo 2" pitchFamily="34" charset="-120"/>
+              </a:rPr>
+              <a:t>per session</a:t>
+            </a:r>
+            <a:endParaRPr lang="en-US" sz="900" dirty="0"/>
+          </a:p>
+        </p:txBody>
+      </p:sp>
+      <p:sp>
+        <p:nvSpPr>
+          <p:cNvPr id="35" name="Text 29"/>
+          <p:cNvSpPr txBox="1"/>
+          <p:nvPr/>
+        </p:nvSpPr>
+        <p:spPr>
+          <a:xfrm>
+            <a:off x="2807208" y="4727448"/>
+            <a:ext cx="1920240" cy="347472"/>
+          </a:xfrm>
+          <a:prstGeom prst="rect">
+            <a:avLst/>
+          </a:prstGeom>
+          <a:noFill/>
+          <a:ln/>
+        </p:spPr>
+        <p:txBody>
+          <a:bodyPr wrap="square" lIns="0" tIns="0" rIns="0" bIns="0" rtlCol="0" anchor="t"/>
+          <a:lstStyle/>
+          <a:p>
+            <a:pPr indent="0" marL="0">
+              <a:buNone/>
+            </a:pPr>
+            <a:r>
+              <a:rPr lang="en-US" sz="2000" b="1" dirty="0">
+                <a:solidFill>
+                  <a:srgbClr val="1BA97C"/>
+                </a:solidFill>
+                <a:latin typeface="Exo 2" pitchFamily="34" charset="0"/>
+                <a:ea typeface="Exo 2" pitchFamily="34" charset="-122"/>
+                <a:cs typeface="Exo 2" pitchFamily="34" charset="-120"/>
+              </a:rPr>
+              <a:t>1.05</a:t>
+            </a:r>
+            <a:endParaRPr lang="en-US" sz="2000" dirty="0"/>
+          </a:p>
+        </p:txBody>
+      </p:sp>
+      <p:sp>
+        <p:nvSpPr>
+          <p:cNvPr id="36" name="Text 30"/>
+          <p:cNvSpPr txBox="1"/>
+          <p:nvPr/>
+        </p:nvSpPr>
+        <p:spPr>
+          <a:xfrm>
+            <a:off x="2807208" y="5056632"/>
+            <a:ext cx="1920240" cy="228600"/>
+          </a:xfrm>
+          <a:prstGeom prst="rect">
+            <a:avLst/>
+          </a:prstGeom>
+          <a:noFill/>
+          <a:ln/>
+        </p:spPr>
+        <p:txBody>
+          <a:bodyPr wrap="square" lIns="0" tIns="0" rIns="0" bIns="0" rtlCol="0" anchor="t"/>
+          <a:lstStyle/>
+          <a:p>
+            <a:pPr indent="0" marL="0">
+              <a:buNone/>
+            </a:pPr>
+            <a:r>
+              <a:rPr lang="en-US" sz="900" dirty="0">
+                <a:solidFill>
+                  <a:srgbClr val="7A849C"/>
+                </a:solidFill>
+                <a:latin typeface="Exo 2" pitchFamily="34" charset="0"/>
+                <a:ea typeface="Exo 2" pitchFamily="34" charset="-122"/>
+                <a:cs typeface="Exo 2" pitchFamily="34" charset="-120"/>
+              </a:rPr>
+              <a:t>key events per session</a:t>
+            </a:r>
+            <a:endParaRPr lang="en-US" sz="900" dirty="0"/>
+          </a:p>
+        </p:txBody>
+      </p:sp>
+      <p:graphicFrame>
+        <p:nvGraphicFramePr>
+          <p:cNvPr id="37" name="Chart 0" descr=""/>
+          <p:cNvGraphicFramePr/>
+          <p:nvPr/>
+        </p:nvGraphicFramePr>
+        <p:xfrm>
+          <a:off x="5074920" y="1508760"/>
+          <a:ext cx="6556248" cy="4069080"/>
+        </p:xfrm>
+        <a:graphic xmlns:a="http://schemas.openxmlformats.org/drawingml/2006/main">
+          <a:graphicData uri="http://schemas.openxmlformats.org/drawingml/2006/chart">
+            <c:chart xmlns:c="http://schemas.openxmlformats.org/drawingml/2006/chart" r:id="rId4"/>
+          </a:graphicData>
+        </a:graphic>
+      </p:graphicFrame>
+    </p:spTree>
+  </p:cSld>
+  <p:clrMapOvr>
+    <a:masterClrMapping/>
+  </p:clrMapOvr>
+</p:sld>
+</file>
+
+<file path=ppt/slides/slide6.xml><?xml version="1.0" encoding="utf-8"?>
+<p:sld xmlns:a="http://schemas.openxmlformats.org/drawingml/2006/main" xmlns:r="http://schemas.openxmlformats.org/officeDocument/2006/relationships" xmlns:p="http://schemas.openxmlformats.org/presentationml/2006/main">
+  <p:cSld name="Slide 6">
+    <p:bg>
+      <p:bgPr>
+        <a:solidFill>
+          <a:srgbClr val="FFFFFF"/>
+        </a:solidFill>
+      </p:bgPr>
+    </p:bg>
+    <p:spTree>
+      <p:nvGrpSpPr>
+        <p:cNvPr id="1" name=""/>
+        <p:cNvGrpSpPr/>
+        <p:nvPr/>
+      </p:nvGrpSpPr>
+      <p:grpSpPr>
+        <a:xfrm>
+          <a:off x="0" y="0"/>
+          <a:ext cx="0" cy="0"/>
+          <a:chOff x="0" y="0"/>
+          <a:chExt cx="0" cy="0"/>
+        </a:xfrm>
+      </p:grpSpPr>
+      <p:pic>
+        <p:nvPicPr>
+          <p:cNvPr id="2" name="Image 0" descr="/home/user/HatemIsa_202508993_IT9002_NLP_Project/emyaa-ceo-deck/working/charts/board_header.png">    </p:cNvPr>
+          <p:cNvPicPr>
+            <a:picLocks noChangeAspect="1"/>
+          </p:cNvPicPr>
+          <p:nvPr/>
+        </p:nvPicPr>
+        <p:blipFill>
+          <a:blip r:embed="rId1"/>
+          <a:stretch>
+            <a:fillRect/>
+          </a:stretch>
+        </p:blipFill>
+        <p:spPr>
+          <a:xfrm>
+            <a:off x="0" y="0"/>
+            <a:ext cx="12191695" cy="1298448"/>
+          </a:xfrm>
+          <a:prstGeom prst="rect">
+            <a:avLst/>
+          </a:prstGeom>
+        </p:spPr>
+      </p:pic>
+      <p:sp>
+        <p:nvSpPr>
+          <p:cNvPr id="3" name="Shape 0"/>
+          <p:cNvSpPr/>
+          <p:nvPr/>
+        </p:nvSpPr>
+        <p:spPr>
+          <a:xfrm>
+            <a:off x="0" y="1298448"/>
+            <a:ext cx="12191695" cy="24689"/>
+          </a:xfrm>
+          <a:prstGeom prst="rect">
+            <a:avLst/>
+          </a:prstGeom>
+          <a:solidFill>
+            <a:srgbClr val="D4AF37"/>
+          </a:solidFill>
+          <a:ln w="12700">
+            <a:solidFill>
+              <a:srgbClr val="D4AF37"/>
+            </a:solidFill>
+            <a:prstDash val="solid"/>
+          </a:ln>
+        </p:spPr>
+      </p:sp>
+      <p:sp>
+        <p:nvSpPr>
+          <p:cNvPr id="4" name="Text 1"/>
+          <p:cNvSpPr txBox="1"/>
+          <p:nvPr/>
+        </p:nvSpPr>
+        <p:spPr>
+          <a:xfrm>
+            <a:off x="566928" y="274320"/>
+            <a:ext cx="9144000" cy="182880"/>
+          </a:xfrm>
+          <a:prstGeom prst="rect">
+            <a:avLst/>
+          </a:prstGeom>
+          <a:noFill/>
+          <a:ln/>
+        </p:spPr>
+        <p:txBody>
+          <a:bodyPr wrap="square" lIns="0" tIns="0" rIns="0" bIns="0" rtlCol="0" anchor="t"/>
+          <a:lstStyle/>
+          <a:p>
+            <a:pPr indent="0" marL="0">
+              <a:buNone/>
+            </a:pPr>
+            <a:r>
+              <a:rPr lang="en-US" sz="900" b="1" spc="200" kern="0" dirty="0">
+                <a:solidFill>
+                  <a:srgbClr val="D4AF37"/>
+                </a:solidFill>
+                <a:latin typeface="Exo 2" pitchFamily="34" charset="0"/>
+                <a:ea typeface="Exo 2" pitchFamily="34" charset="-122"/>
+                <a:cs typeface="Exo 2" pitchFamily="34" charset="-120"/>
+              </a:rPr>
               <a:t>DECISIONS AND OPEN ITEMS</a:t>
             </a:r>
             <a:endParaRPr lang="en-US" sz="900" dirty="0"/>
@@ -5457,7 +8826,7 @@
                 <a:ea typeface="Exo 2" pitchFamily="34" charset="-122"/>
                 <a:cs typeface="Exo 2" pitchFamily="34" charset="-120"/>
               </a:rPr>
-              <a:t>4</a:t>
+              <a:t>6</a:t>
             </a:r>
             <a:endParaRPr lang="en-US" sz="800" dirty="0"/>
           </a:p>
@@ -5489,7 +8858,7 @@
       </p:pic>
       <p:graphicFrame>
         <p:nvGraphicFramePr>
-          <p:cNvPr id="5" name="Table 0"/>
+          <p:cNvPr id="7" name="Table 0"/>
           <p:cNvGraphicFramePr>
             <a:graphicFrameLocks noGrp="1"/>
           </p:cNvGraphicFramePr>
@@ -6638,7 +10007,7 @@
       </p:graphicFrame>
       <p:graphicFrame>
         <p:nvGraphicFramePr>
-          <p:cNvPr id="9" name="Table 1"/>
+          <p:cNvPr id="13" name="Table 1"/>
           <p:cNvGraphicFramePr>
             <a:graphicFrameLocks noGrp="1"/>
           </p:cNvGraphicFramePr>

</xml_diff>

<commit_message>
Record management confirmation of $12,206 total deposits
Deposits open item closed: $12,206 is the total recorded on the platform to
date (confirmed 29 Sep), matching Board appendix pages 7 and 8. CEO slide 6,
open items, traceability and audit memo updated.

Co-Authored-By: Claude Opus 5.5 <noreply@anthropic.com>
Claude-Session: https://claude.ai/code/session_01SNf1Edf2HMYqmZpheYf6i6
</commit_message>
<xml_diff>
--- a/emyaa-ceo-deck/output/final-deck/eMYAA-Marketing-Update-01.10.2026-CEO-Redesigned.pptx
+++ b/emyaa-ceo-deck/output/final-deck/eMYAA-Marketing-Update-01.10.2026-CEO-Redesigned.pptx
@@ -956,7 +956,7 @@
           <a:p>
             <a:r>
               <a:rPr lang="en-US" dirty="0"/>
-              <a:t>Decision 2 follows from the GA4 campaign export: Arabic has a lower engagement rate (86.9% vs 97.2%) but more key events per session (1.05 vs 0.94). Decision 3 follows from the dashboards: +36 downloads but +3 onboarded in the first six days of paid testing. Open items: gross deposits of $12,206 rest on Malek's message of 29 Sep with no written export (the dashboard's $10,029.69 is assets under management, a different measure; the Board shows both); the Board figures (61 clients, $12,206) are as at 28 Sep, and Board slide 3 wrongly says 'as at 17 September', corrected in the separate Board update file; no Ignite spend, cost per key event or LinkedIn lead data, and the key event is undefined; no September social exports; the 793% active-user rise (GA card, prior week implied) and LinkedIn +118% / +155% are not traceable to an export; LinkedIn followers 531 vs 586; $5,000 campaign T&amp;Cs sent for approval on 20 Jul with no sign-off on file. Market Pulse: in-app feature in discussion (Exante data access).</a:t>
+              <a:t>Decision 2 follows from the GA4 campaign export: Arabic has a lower engagement rate (86.9% vs 97.2%) but more key events per session (1.05 vs 0.94). Decision 3 follows from the dashboards: +36 downloads but +3 onboarded in the first six days of paid testing. Gross deposits: $12,206 is the total recorded on the platform to date, confirmed by management on 29 Sep (the dashboard's $10,029.69 is assets under management, a different measure; the Board shows both). Open items: the Board figures (61 clients, $12,206) are as at 28 Sep, and Board slide 3 wrongly says 'as at 17 September', corrected in the separate Board update file; no Ignite spend, cost per key event or LinkedIn lead data, and the key event is undefined; no September social exports; the 793% active-user rise (GA card, prior week implied) and LinkedIn +118% / +155% are not traceable to an export; LinkedIn followers 531 vs 586; $5,000 campaign T&amp;Cs sent for approval on 20 Jul with no sign-off on file. Market Pulse: in-app feature in discussion (Exante data access).</a:t>
             </a:r>
             <a:endParaRPr lang="en-US" dirty="0"/>
           </a:p>
@@ -12758,7 +12758,7 @@
                           <a:ea typeface="Exo 2" pitchFamily="34" charset="-122"/>
                           <a:cs typeface="Exo 2" pitchFamily="34" charset="-120"/>
                         </a:rPr>
-                        <a:t>Deposits: $12,206 has no written export yet</a:t>
+                        <a:t>Deposits: $12,206 to date, confirmed 29 Sep</a:t>
                       </a:r>
                       <a:endParaRPr lang="en-US" sz="950" dirty="0">
                         <a:latin typeface="Exo 2" charset="0"/>
@@ -12799,13 +12799,13 @@
                       <a:r>
                         <a:rPr lang="en-US" sz="950" b="1" dirty="0">
                           <a:solidFill>
-                            <a:srgbClr val="9A7B1F"/>
+                            <a:srgbClr val="1BA97C"/>
                           </a:solidFill>
                           <a:latin typeface="Exo 2" pitchFamily="34" charset="0"/>
                           <a:ea typeface="Exo 2" pitchFamily="34" charset="-122"/>
                           <a:cs typeface="Exo 2" pitchFamily="34" charset="-120"/>
                         </a:rPr>
-                        <a:t>Open</a:t>
+                        <a:t>Confirmed</a:t>
                       </a:r>
                       <a:endParaRPr lang="en-US" sz="950" dirty="0">
                         <a:latin typeface="Exo 2" charset="0"/>

</xml_diff>

<commit_message>
Update Board appendix pages 7 and 8 and the CEO deck to the 29 Sep dashboard
Board updates file now holds pages 3, 7 and 8: downloads 490 (262/228),
55 trades (Sep 9, gap -30), 12.4% of downloads onboarded, 3.7 trades per
trading client, email queries 6 (Board showed 4), dates to 29 Sep. CEO
deck installs and onboarding extended to 29 Sep (+53 / +4). Audit files
and change notes updated.

Co-Authored-By: Claude Opus 5.5 <noreply@anthropic.com>
Claude-Session: https://claude.ai/code/session_01SNf1Edf2HMYqmZpheYf6i6
</commit_message>
<xml_diff>
--- a/emyaa-ceo-deck/output/final-deck/eMYAA-Marketing-Update-01.10.2026-CEO-Redesigned.pptx
+++ b/emyaa-ceo-deck/output/final-deck/eMYAA-Marketing-Update-01.10.2026-CEO-Redesigned.pptx
@@ -516,7 +516,7 @@
           <a:p>
             <a:r>
               <a:rPr lang="en-US" dirty="0"/>
-              <a:t>Sources: GA4 exports 1-28 Sep 2026; GA4 home card 21-27 Sep; daily performance dashboards to 27 Sep; eMYAA Board of Directors Update 17 Sep 2026 (plan, budget, segments, CAC targets); content calendars Sep and Oct 2026 (V2); Instagram profile grid screenshot; $5,000 campaign T&amp;Cs, approval checklist and 24F briefing. Anything without a source file is labelled 'reported' or 'per team'.</a:t>
+              <a:t>Sources: GA4 exports 1-28 Sep 2026; GA4 home card 21-27 Sep; daily performance dashboards to 29 Sep; eMYAA Board of Directors Update 17 Sep 2026 (plan, budget, segments, CAC targets); content calendars Sep and Oct 2026 (V2); Instagram profile grid screenshot; $5,000 campaign T&amp;Cs, approval checklist and 24F briefing. Anything without a source file is labelled 'reported' or 'per team'.</a:t>
             </a:r>
             <a:endParaRPr lang="en-US" dirty="0"/>
           </a:p>
@@ -692,7 +692,7 @@
           <a:p>
             <a:r>
               <a:rPr lang="en-US" dirty="0"/>
-              <a:t>Traffic: 587 sessions 1-28 Sep; google / cpc 409 (69.7%), direct 92, organic 39, referral 32 (incl. 7 Tag Assistant test sessions), ChatGPT 9, not available 6. 403 of 542 active users (74.4%) had Google Ads as first source. The GA home card reports 384 active users for 21-27 Sep, +793% vs the previous week; the prior week (about 43) is implied, not exported, so the figure stays 'reported'. Downloads (Android + iOS) on dashboard dates: 373, 403, 423, 437, 473; onboarded 48, 49, 52, 57, 60; funded accounts 13 on 21 Sep, 15 on 27 Sep; 54 trades. English vs Arabic Google Ads (1-28 Sep): engagement 97.2% vs 86.9%, key events per session 0.94 vs 1.05; the key event is not defined, so keep both live until it is defined and costed.</a:t>
+              <a:t>Traffic: 587 sessions 1-28 Sep; google / cpc 409 (69.7%), direct 92, organic 39, referral 32 (incl. 7 Tag Assistant test sessions), ChatGPT 9, not available 6. 403 of 542 active users (74.4%) had Google Ads as first source. The GA home card reports 384 active users for 21-27 Sep, +793% vs the previous week; the prior week (about 43) is implied, not exported, so the figure stays 'reported'. Downloads (Android + iOS) on dashboard dates 1, 8, 14, 21 and 29 Sep: 373, 403, 423, 437, 490; onboarded 48, 49, 52, 57, 61; funded accounts 13 on 21 Sep, 15 on 29 Sep; 55 trades on 29 Sep. English vs Arabic Google Ads (1-28 Sep): engagement 97.2% vs 86.9%, key events per session 0.94 vs 1.05; the key event is not defined, so keep both live until it is defined and costed.</a:t>
             </a:r>
             <a:endParaRPr lang="en-US" dirty="0"/>
           </a:p>
@@ -780,7 +780,7 @@
           <a:p>
             <a:r>
               <a:rPr lang="en-US" dirty="0"/>
-              <a:t>Installs (Android + iOS, cumulative) on dashboard report dates: 1 Sep 373, 2 Sep 389, 3 Sep 395, 8 Sep 403, 9 Sep 410, 10 Sep 414, 13 Sep 419, 14 Sep 423, 16 Sep 430, 17 Sep 432, 20 Sep 437, 21 Sep 437, 22 Sep 452, 23 Sep 454, 24 Sep 455, 27 Sep 473. Report dates are irregular, so the line is spaced by report, not by calendar day. Pace: +36 in the six days 21-27 Sep (6 a day) vs +30 in 1-8 Sep (4.3 a day, when the Ali Sabeel video and baseline sponsor ads were running) and +14 in 14-21 Sep. Split 21-27 Sep: Android +17, iOS +19. Funnel: 409 google / cpc sessions and 400 key events in GA4 (1-28 Sep); the key event is not defined in the export. Installs and onboarding come from the platform dashboard and cover all sources; there is no link yet from an ad click to an install. The app link (onelink.to/gpbwrg) already exists and can carry campaign tags. Onboarded users 57 to 60 over 21-27 Sep.</a:t>
+              <a:t>Installs (Android + iOS, cumulative) on dashboard report dates: 1 Sep 373, 2 Sep 389, 3 Sep 395, 8 Sep 403, 9 Sep 410, 10 Sep 414, 13 Sep 419, 14 Sep 423, 16 Sep 430, 17 Sep 432, 20 Sep 437, 21 Sep 437, 22 Sep 452, 23 Sep 454, 24 Sep 455, 27 Sep 473, 28 Sep 480, 29 Sep 490. Report dates are irregular, so the line is spaced by report, not by calendar day. Pace: +53 in the eight days 21-29 Sep (6.6 a day) vs +30 in 1-8 Sep (4.3 a day, when the Ali Sabeel video and baseline sponsor ads were running) and +14 in 14-21 Sep. Split 21-29 Sep: Android +20, iOS +33. Funnel: 409 google / cpc sessions and 400 key events in GA4 (1-28 Sep); the key event is not defined in the export. Installs and onboarding come from the platform dashboard and cover all sources; there is no link yet from an ad click to an install. The app link (onelink.to/gpbwrg) already exists and can carry campaign tags. Onboarded users 57 to 61 over 21-29 Sep.</a:t>
             </a:r>
             <a:endParaRPr lang="en-US" dirty="0"/>
           </a:p>
@@ -956,7 +956,7 @@
           <a:p>
             <a:r>
               <a:rPr lang="en-US" dirty="0"/>
-              <a:t>Decision 2 follows from the GA4 campaign export: Arabic has a lower engagement rate (86.9% vs 97.2%) but more key events per session (1.05 vs 0.94). Decision 3 follows from the dashboards: +36 downloads but +3 onboarded in the first six days of paid testing. Gross deposits: $12,206 is the total recorded on the platform to date, confirmed by management on 29 Sep (the dashboard's $10,029.69 is assets under management, a different measure; the Board shows both). Open items: the Board figures (61 clients, $12,206) are as at 28 Sep, and Board slide 3 wrongly says 'as at 17 September', corrected in the separate Board update file; no Ignite spend, cost per key event or LinkedIn lead data, and the key event is undefined; no September social exports; the 793% active-user rise (GA card, prior week implied) and LinkedIn +118% / +155% are not traceable to an export; LinkedIn followers 531 vs 586; $5,000 campaign T&amp;Cs sent for approval on 20 Jul with no sign-off on file. Market Pulse: in-app feature in discussion (Exante data access).</a:t>
+              <a:t>Decision 2 follows from the GA4 campaign export: Arabic has a lower engagement rate (86.9% vs 97.2%) but more key events per session (1.05 vs 0.94). Decision 3 follows from the dashboards: +53 downloads but +4 onboarded in the first six days of paid testing. Gross deposits: $12,206 is the total recorded on the platform to date, confirmed by management on 29 Sep (the dashboard's $10,029.69 is assets under management, a different measure; the Board shows both). Open items: the Board figures (61 clients, $12,206) are as at 28 Sep, and Board slide 3 wrongly says 'as at 17 September', corrected in the separate Board update file; no Ignite spend, cost per key event or LinkedIn lead data, and the key event is undefined; no September social exports; the 793% active-user rise (GA card, prior week implied) and LinkedIn +118% / +155% are not traceable to an export; LinkedIn followers 531 vs 586; $5,000 campaign T&amp;Cs sent for approval on 20 Jul with no sign-off on file. Market Pulse: in-app feature in discussion (Exante data access).</a:t>
             </a:r>
             <a:endParaRPr lang="en-US" dirty="0"/>
           </a:p>
@@ -1534,7 +1534,7 @@
                 <a:ea typeface="Exo 2" pitchFamily="34" charset="-122"/>
                 <a:cs typeface="Exo 2" pitchFamily="34" charset="-120"/>
               </a:rPr>
-              <a:t>Web: GA4, 1-28 Sep 2026  |  Platform: daily dashboard, 27 Sep 2026  |  Plan and budget: Board update, 17 Sep 2026</a:t>
+              <a:t>Web: GA4, 1-28 Sep 2026  |  Platform: daily dashboard, 29 Sep 2026  |  Plan and budget: Board update, 17 Sep 2026</a:t>
             </a:r>
             <a:endParaRPr lang="en-US" sz="1000" dirty="0"/>
           </a:p>
@@ -4239,7 +4239,7 @@
                 <a:ea typeface="Exo 2" pitchFamily="34" charset="-122"/>
                 <a:cs typeface="Exo 2" pitchFamily="34" charset="-120"/>
               </a:rPr>
-              <a:t>Source: GA4 exports 1-28 Sep 2026; eMYAA Daily Performance Dashboards, cumulative figures on report dates 1, 8, 14, 21 and 27 Sep 2026 (periods of 6 to 7 days).</a:t>
+              <a:t>Source: GA4 exports 1-28 Sep 2026; eMYAA Daily Performance Dashboards, cumulative figures on report dates 1, 8, 14, 21 and 29 Sep 2026 (periods of 6 to 8 days).</a:t>
             </a:r>
             <a:endParaRPr lang="en-US" sz="800" dirty="0"/>
           </a:p>
@@ -4597,7 +4597,7 @@
                 <a:ea typeface="Exo 2" pitchFamily="34" charset="-122"/>
                 <a:cs typeface="Exo 2" pitchFamily="34" charset="-120"/>
               </a:rPr>
-              <a:t>+36</a:t>
+              <a:t>+53</a:t>
             </a:r>
             <a:endParaRPr lang="en-US" sz="3400" dirty="0"/>
           </a:p>
@@ -4636,7 +4636,7 @@
                 <a:ea typeface="Exo 2" pitchFamily="34" charset="-122"/>
                 <a:cs typeface="Exo 2" pitchFamily="34" charset="-120"/>
               </a:rPr>
-              <a:t>app downloads in the six days after launch</a:t>
+              <a:t>app downloads in the eight days after launch</a:t>
             </a:r>
             <a:endParaRPr lang="en-US" sz="1150" dirty="0"/>
           </a:p>
@@ -4764,7 +4764,7 @@
                 <a:ea typeface="Exo 2" pitchFamily="34" charset="-122"/>
                 <a:cs typeface="Exo 2" pitchFamily="34" charset="-120"/>
               </a:rPr>
-              <a:t>+3</a:t>
+              <a:t>+4</a:t>
             </a:r>
             <a:endParaRPr lang="en-US" sz="3400" dirty="0"/>
           </a:p>
@@ -4803,7 +4803,7 @@
                 <a:ea typeface="Exo 2" pitchFamily="34" charset="-122"/>
                 <a:cs typeface="Exo 2" pitchFamily="34" charset="-120"/>
               </a:rPr>
-              <a:t>users onboarded in the same six days</a:t>
+              <a:t>users onboarded in the same eight days</a:t>
             </a:r>
             <a:endParaRPr lang="en-US" sz="1150" dirty="0"/>
           </a:p>
@@ -4842,7 +4842,7 @@
                 <a:ea typeface="Exo 2" pitchFamily="34" charset="-122"/>
                 <a:cs typeface="Exo 2" pitchFamily="34" charset="-120"/>
               </a:rPr>
-              <a:t>60 onboarded, 15 funded, as of 27 Sep</a:t>
+              <a:t>61 onboarded, 15 funded, as of 29 Sep</a:t>
             </a:r>
             <a:endParaRPr lang="en-US" sz="950" dirty="0"/>
           </a:p>
@@ -4918,8 +4918,8 @@
         </p:nvSpPr>
         <p:spPr>
           <a:xfrm>
-            <a:off x="4794954" y="2731770"/>
-            <a:ext cx="521139" cy="2160270"/>
+            <a:off x="4794954" y="3402199"/>
+            <a:ext cx="521139" cy="1489841"/>
           </a:xfrm>
           <a:prstGeom prst="rect">
             <a:avLst/>
@@ -4943,7 +4943,7 @@
         </p:nvSpPr>
         <p:spPr>
           <a:xfrm>
-            <a:off x="4685226" y="2457450"/>
+            <a:off x="4685226" y="3127879"/>
             <a:ext cx="740595" cy="256032"/>
           </a:xfrm>
           <a:prstGeom prst="rect">
@@ -4982,8 +4982,8 @@
         </p:nvSpPr>
         <p:spPr>
           <a:xfrm>
-            <a:off x="5352669" y="4820031"/>
-            <a:ext cx="521139" cy="72009"/>
+            <a:off x="5352669" y="4842379"/>
+            <a:ext cx="521139" cy="49661"/>
           </a:xfrm>
           <a:prstGeom prst="rect">
             <a:avLst/>
@@ -5007,7 +5007,7 @@
         </p:nvSpPr>
         <p:spPr>
           <a:xfrm>
-            <a:off x="5242941" y="4545711"/>
+            <a:off x="5242941" y="4568059"/>
             <a:ext cx="740595" cy="256032"/>
           </a:xfrm>
           <a:prstGeom prst="rect">
@@ -5085,8 +5085,8 @@
         </p:nvSpPr>
         <p:spPr>
           <a:xfrm>
-            <a:off x="6594036" y="3451860"/>
-            <a:ext cx="521139" cy="1440180"/>
+            <a:off x="6594036" y="3898812"/>
+            <a:ext cx="521139" cy="993228"/>
           </a:xfrm>
           <a:prstGeom prst="rect">
             <a:avLst/>
@@ -5110,7 +5110,7 @@
         </p:nvSpPr>
         <p:spPr>
           <a:xfrm>
-            <a:off x="6484308" y="3177540"/>
+            <a:off x="6484308" y="3624492"/>
             <a:ext cx="740595" cy="256032"/>
           </a:xfrm>
           <a:prstGeom prst="rect">
@@ -5149,8 +5149,8 @@
         </p:nvSpPr>
         <p:spPr>
           <a:xfrm>
-            <a:off x="7151751" y="4676013"/>
-            <a:ext cx="521139" cy="216027"/>
+            <a:off x="7151751" y="4743056"/>
+            <a:ext cx="521139" cy="148984"/>
           </a:xfrm>
           <a:prstGeom prst="rect">
             <a:avLst/>
@@ -5174,7 +5174,7 @@
         </p:nvSpPr>
         <p:spPr>
           <a:xfrm>
-            <a:off x="7042023" y="4401693"/>
+            <a:off x="7042023" y="4468736"/>
             <a:ext cx="740595" cy="256032"/>
           </a:xfrm>
           <a:prstGeom prst="rect">
@@ -5252,8 +5252,8 @@
         </p:nvSpPr>
         <p:spPr>
           <a:xfrm>
-            <a:off x="8393118" y="3883914"/>
-            <a:ext cx="521139" cy="1008126"/>
+            <a:off x="8393118" y="4196781"/>
+            <a:ext cx="521139" cy="695259"/>
           </a:xfrm>
           <a:prstGeom prst="rect">
             <a:avLst/>
@@ -5277,7 +5277,7 @@
         </p:nvSpPr>
         <p:spPr>
           <a:xfrm>
-            <a:off x="8283390" y="3609594"/>
+            <a:off x="8283390" y="3922461"/>
             <a:ext cx="740595" cy="256032"/>
           </a:xfrm>
           <a:prstGeom prst="rect">
@@ -5316,8 +5316,8 @@
         </p:nvSpPr>
         <p:spPr>
           <a:xfrm>
-            <a:off x="8950833" y="4531995"/>
-            <a:ext cx="521139" cy="360045"/>
+            <a:off x="8950833" y="4643733"/>
+            <a:ext cx="521139" cy="248307"/>
           </a:xfrm>
           <a:prstGeom prst="rect">
             <a:avLst/>
@@ -5341,7 +5341,7 @@
         </p:nvSpPr>
         <p:spPr>
           <a:xfrm>
-            <a:off x="8841105" y="4257675"/>
+            <a:off x="8841105" y="4369413"/>
             <a:ext cx="740595" cy="256032"/>
           </a:xfrm>
           <a:prstGeom prst="rect">
@@ -5419,8 +5419,8 @@
         </p:nvSpPr>
         <p:spPr>
           <a:xfrm>
-            <a:off x="10192200" y="2299716"/>
-            <a:ext cx="521139" cy="2592324"/>
+            <a:off x="10192200" y="2259987"/>
+            <a:ext cx="521139" cy="2632053"/>
           </a:xfrm>
           <a:prstGeom prst="rect">
             <a:avLst/>
@@ -5444,7 +5444,7 @@
         </p:nvSpPr>
         <p:spPr>
           <a:xfrm>
-            <a:off x="10082472" y="2025396"/>
+            <a:off x="10082472" y="1985667"/>
             <a:ext cx="740595" cy="256032"/>
           </a:xfrm>
           <a:prstGeom prst="rect">
@@ -5469,7 +5469,7 @@
                 <a:ea typeface="Exo 2" pitchFamily="34" charset="-122"/>
                 <a:cs typeface="Exo 2" pitchFamily="34" charset="-120"/>
               </a:rPr>
-              <a:t>36</a:t>
+              <a:t>53</a:t>
             </a:r>
             <a:endParaRPr lang="en-US" sz="1100" dirty="0"/>
           </a:p>
@@ -5483,8 +5483,8 @@
         </p:nvSpPr>
         <p:spPr>
           <a:xfrm>
-            <a:off x="10749915" y="4676013"/>
-            <a:ext cx="521139" cy="216027"/>
+            <a:off x="10749915" y="4693394"/>
+            <a:ext cx="521139" cy="198646"/>
           </a:xfrm>
           <a:prstGeom prst="rect">
             <a:avLst/>
@@ -5508,7 +5508,7 @@
         </p:nvSpPr>
         <p:spPr>
           <a:xfrm>
-            <a:off x="10640187" y="4401693"/>
+            <a:off x="10640187" y="4419074"/>
             <a:ext cx="740595" cy="256032"/>
           </a:xfrm>
           <a:prstGeom prst="rect">
@@ -5533,7 +5533,7 @@
                 <a:ea typeface="Exo 2" pitchFamily="34" charset="-122"/>
                 <a:cs typeface="Exo 2" pitchFamily="34" charset="-120"/>
               </a:rPr>
-              <a:t>3</a:t>
+              <a:t>4</a:t>
             </a:r>
             <a:endParaRPr lang="en-US" sz="1100" dirty="0"/>
           </a:p>
@@ -5572,7 +5572,7 @@
                 <a:ea typeface="Exo 2" pitchFamily="34" charset="-122"/>
                 <a:cs typeface="Exo 2" pitchFamily="34" charset="-120"/>
               </a:rPr>
-              <a:t>21-27 Sep (paid live)</a:t>
+              <a:t>21-29 Sep (paid live)</a:t>
             </a:r>
             <a:endParaRPr lang="en-US" sz="1050" dirty="0"/>
           </a:p>
@@ -6025,7 +6025,7 @@
                 <a:ea typeface="Exo 2" pitchFamily="34" charset="-122"/>
                 <a:cs typeface="Exo 2" pitchFamily="34" charset="-120"/>
               </a:rPr>
-              <a:t>Source: App installs: eMYAA Daily Performance Dashboards (Android + iOS, cumulative, on report dates 1-27 Sep 2026). Ads: GA4 Reports snapshot and Google Ads campaigns exports, 1-28 Sep 2026.</a:t>
+              <a:t>Source: App installs: eMYAA Daily Performance Dashboards (Android + iOS, cumulative, on report dates 1-29 Sep 2026). Ads: GA4 Reports snapshot and Google Ads campaigns exports, 1-28 Sep 2026.</a:t>
             </a:r>
             <a:endParaRPr lang="en-US" sz="800" dirty="0"/>
           </a:p>
@@ -6242,7 +6242,7 @@
         </p:nvSpPr>
         <p:spPr>
           <a:xfrm>
-            <a:off x="1024128" y="4263390"/>
+            <a:off x="1024128" y="4416552"/>
             <a:ext cx="6172200" cy="0"/>
           </a:xfrm>
           <a:prstGeom prst="line">
@@ -6265,7 +6265,7 @@
         </p:nvSpPr>
         <p:spPr>
           <a:xfrm>
-            <a:off x="566928" y="4153662"/>
+            <a:off x="566928" y="4306824"/>
             <a:ext cx="384048" cy="219456"/>
           </a:xfrm>
           <a:prstGeom prst="rect">
@@ -6304,7 +6304,7 @@
         </p:nvSpPr>
         <p:spPr>
           <a:xfrm>
-            <a:off x="1024128" y="3497580"/>
+            <a:off x="1024128" y="3803904"/>
             <a:ext cx="6172200" cy="0"/>
           </a:xfrm>
           <a:prstGeom prst="line">
@@ -6327,7 +6327,7 @@
         </p:nvSpPr>
         <p:spPr>
           <a:xfrm>
-            <a:off x="566928" y="3387852"/>
+            <a:off x="566928" y="3694176"/>
             <a:ext cx="384048" cy="219456"/>
           </a:xfrm>
           <a:prstGeom prst="rect">
@@ -6366,7 +6366,7 @@
         </p:nvSpPr>
         <p:spPr>
           <a:xfrm>
-            <a:off x="1024128" y="2731770"/>
+            <a:off x="1024128" y="3191256"/>
             <a:ext cx="6172200" cy="0"/>
           </a:xfrm>
           <a:prstGeom prst="line">
@@ -6389,7 +6389,7 @@
         </p:nvSpPr>
         <p:spPr>
           <a:xfrm>
-            <a:off x="566928" y="2622042"/>
+            <a:off x="566928" y="3081528"/>
             <a:ext cx="384048" cy="219456"/>
           </a:xfrm>
           <a:prstGeom prst="rect">
@@ -6428,7 +6428,7 @@
         </p:nvSpPr>
         <p:spPr>
           <a:xfrm>
-            <a:off x="1024128" y="1965960"/>
+            <a:off x="1024128" y="2578608"/>
             <a:ext cx="6172200" cy="0"/>
           </a:xfrm>
           <a:prstGeom prst="line">
@@ -6451,6 +6451,68 @@
         </p:nvSpPr>
         <p:spPr>
           <a:xfrm>
+            <a:off x="566928" y="2468880"/>
+            <a:ext cx="384048" cy="219456"/>
+          </a:xfrm>
+          <a:prstGeom prst="rect">
+            <a:avLst/>
+          </a:prstGeom>
+          <a:noFill/>
+          <a:ln/>
+        </p:spPr>
+        <p:txBody>
+          <a:bodyPr wrap="square" lIns="0" tIns="0" rIns="0" bIns="0" rtlCol="0" anchor="ctr"/>
+          <a:lstStyle/>
+          <a:p>
+            <a:pPr algn="r" indent="0" marL="0">
+              <a:buNone/>
+            </a:pPr>
+            <a:r>
+              <a:rPr lang="en-US" sz="900" dirty="0">
+                <a:solidFill>
+                  <a:srgbClr val="7A849C"/>
+                </a:solidFill>
+                <a:latin typeface="Exo 2" pitchFamily="34" charset="0"/>
+                <a:ea typeface="Exo 2" pitchFamily="34" charset="-122"/>
+                <a:cs typeface="Exo 2" pitchFamily="34" charset="-120"/>
+              </a:rPr>
+              <a:t>480</a:t>
+            </a:r>
+            <a:endParaRPr lang="en-US" sz="900" dirty="0"/>
+          </a:p>
+        </p:txBody>
+      </p:sp>
+      <p:sp>
+        <p:nvSpPr>
+          <p:cNvPr id="26" name="Shape 20"/>
+          <p:cNvSpPr/>
+          <p:nvPr/>
+        </p:nvSpPr>
+        <p:spPr>
+          <a:xfrm>
+            <a:off x="1024128" y="1965960"/>
+            <a:ext cx="6172200" cy="0"/>
+          </a:xfrm>
+          <a:prstGeom prst="line">
+            <a:avLst/>
+          </a:prstGeom>
+          <a:noFill/>
+          <a:ln w="9525">
+            <a:solidFill>
+              <a:srgbClr val="E6EAF2"/>
+            </a:solidFill>
+            <a:prstDash val="solid"/>
+          </a:ln>
+        </p:spPr>
+      </p:sp>
+      <p:sp>
+        <p:nvSpPr>
+          <p:cNvPr id="27" name="Text 21"/>
+          <p:cNvSpPr txBox="1"/>
+          <p:nvPr/>
+        </p:nvSpPr>
+        <p:spPr>
+          <a:xfrm>
             <a:off x="566928" y="1856232"/>
             <a:ext cx="384048" cy="219456"/>
           </a:xfrm>
@@ -6476,7 +6538,7 @@
                 <a:ea typeface="Exo 2" pitchFamily="34" charset="-122"/>
                 <a:cs typeface="Exo 2" pitchFamily="34" charset="-120"/>
               </a:rPr>
-              <a:t>480</a:t>
+              <a:t>510</a:t>
             </a:r>
             <a:endParaRPr lang="en-US" sz="900" dirty="0"/>
           </a:p>
@@ -6484,13 +6546,13 @@
       </p:sp>
       <p:sp>
         <p:nvSpPr>
-          <p:cNvPr id="26" name="Shape 20"/>
+          <p:cNvPr id="28" name="Shape 22"/>
           <p:cNvSpPr/>
           <p:nvPr/>
         </p:nvSpPr>
         <p:spPr>
           <a:xfrm>
-            <a:off x="5879592" y="1920240"/>
+            <a:off x="5324497" y="1920240"/>
             <a:ext cx="0" cy="3108960"/>
           </a:xfrm>
           <a:prstGeom prst="line">
@@ -6507,14 +6569,14 @@
       </p:sp>
       <p:sp>
         <p:nvSpPr>
-          <p:cNvPr id="27" name="Shape 21"/>
+          <p:cNvPr id="29" name="Shape 23"/>
           <p:cNvSpPr/>
           <p:nvPr/>
         </p:nvSpPr>
         <p:spPr>
           <a:xfrm flipV="1">
-            <a:off x="1161288" y="4288917"/>
-            <a:ext cx="393192" cy="408432"/>
+            <a:off x="1161288" y="4436974"/>
+            <a:ext cx="346934" cy="326746"/>
           </a:xfrm>
           <a:prstGeom prst="line">
             <a:avLst/>
@@ -6530,14 +6592,14 @@
       </p:sp>
       <p:sp>
         <p:nvSpPr>
-          <p:cNvPr id="28" name="Shape 22"/>
+          <p:cNvPr id="30" name="Shape 24"/>
           <p:cNvSpPr/>
           <p:nvPr/>
         </p:nvSpPr>
         <p:spPr>
           <a:xfrm flipV="1">
-            <a:off x="1554480" y="4135755"/>
-            <a:ext cx="393192" cy="153162"/>
+            <a:off x="1508222" y="4314444"/>
+            <a:ext cx="346934" cy="122530"/>
           </a:xfrm>
           <a:prstGeom prst="line">
             <a:avLst/>
@@ -6553,14 +6615,14 @@
       </p:sp>
       <p:sp>
         <p:nvSpPr>
-          <p:cNvPr id="29" name="Shape 23"/>
+          <p:cNvPr id="31" name="Shape 25"/>
           <p:cNvSpPr/>
           <p:nvPr/>
         </p:nvSpPr>
         <p:spPr>
           <a:xfrm flipV="1">
-            <a:off x="1947672" y="3931539"/>
-            <a:ext cx="393192" cy="204216"/>
+            <a:off x="1855156" y="4151071"/>
+            <a:ext cx="346934" cy="163373"/>
           </a:xfrm>
           <a:prstGeom prst="line">
             <a:avLst/>
@@ -6576,14 +6638,14 @@
       </p:sp>
       <p:sp>
         <p:nvSpPr>
-          <p:cNvPr id="30" name="Shape 24"/>
+          <p:cNvPr id="32" name="Shape 26"/>
           <p:cNvSpPr/>
           <p:nvPr/>
         </p:nvSpPr>
         <p:spPr>
           <a:xfrm flipV="1">
-            <a:off x="2340864" y="3752850"/>
-            <a:ext cx="393192" cy="178689"/>
+            <a:off x="2202090" y="4008120"/>
+            <a:ext cx="346934" cy="142951"/>
           </a:xfrm>
           <a:prstGeom prst="line">
             <a:avLst/>
@@ -6599,14 +6661,14 @@
       </p:sp>
       <p:sp>
         <p:nvSpPr>
-          <p:cNvPr id="31" name="Shape 25"/>
+          <p:cNvPr id="33" name="Shape 27"/>
           <p:cNvSpPr/>
           <p:nvPr/>
         </p:nvSpPr>
         <p:spPr>
           <a:xfrm flipV="1">
-            <a:off x="2734056" y="3650742"/>
-            <a:ext cx="393192" cy="102108"/>
+            <a:off x="2549024" y="3926434"/>
+            <a:ext cx="346934" cy="81686"/>
           </a:xfrm>
           <a:prstGeom prst="line">
             <a:avLst/>
@@ -6622,14 +6684,14 @@
       </p:sp>
       <p:sp>
         <p:nvSpPr>
-          <p:cNvPr id="32" name="Shape 26"/>
+          <p:cNvPr id="34" name="Shape 28"/>
           <p:cNvSpPr/>
           <p:nvPr/>
         </p:nvSpPr>
         <p:spPr>
           <a:xfrm flipV="1">
-            <a:off x="3127248" y="3523107"/>
-            <a:ext cx="393192" cy="127635"/>
+            <a:off x="2895959" y="3824326"/>
+            <a:ext cx="346934" cy="102108"/>
           </a:xfrm>
           <a:prstGeom prst="line">
             <a:avLst/>
@@ -6645,14 +6707,14 @@
       </p:sp>
       <p:sp>
         <p:nvSpPr>
-          <p:cNvPr id="33" name="Shape 27"/>
+          <p:cNvPr id="35" name="Shape 29"/>
           <p:cNvSpPr/>
           <p:nvPr/>
         </p:nvSpPr>
         <p:spPr>
           <a:xfrm flipV="1">
-            <a:off x="3520440" y="3420999"/>
-            <a:ext cx="393192" cy="102108"/>
+            <a:off x="3242893" y="3742639"/>
+            <a:ext cx="346934" cy="81686"/>
           </a:xfrm>
           <a:prstGeom prst="line">
             <a:avLst/>
@@ -6668,14 +6730,14 @@
       </p:sp>
       <p:sp>
         <p:nvSpPr>
-          <p:cNvPr id="34" name="Shape 28"/>
+          <p:cNvPr id="36" name="Shape 30"/>
           <p:cNvSpPr/>
           <p:nvPr/>
         </p:nvSpPr>
         <p:spPr>
           <a:xfrm flipV="1">
-            <a:off x="3913632" y="3242310"/>
-            <a:ext cx="393192" cy="178689"/>
+            <a:off x="3589827" y="3599688"/>
+            <a:ext cx="346934" cy="142951"/>
           </a:xfrm>
           <a:prstGeom prst="line">
             <a:avLst/>
@@ -6691,14 +6753,14 @@
       </p:sp>
       <p:sp>
         <p:nvSpPr>
-          <p:cNvPr id="35" name="Shape 29"/>
+          <p:cNvPr id="37" name="Shape 31"/>
           <p:cNvSpPr/>
           <p:nvPr/>
         </p:nvSpPr>
         <p:spPr>
           <a:xfrm flipV="1">
-            <a:off x="4306824" y="3191256"/>
-            <a:ext cx="393192" cy="51054"/>
+            <a:off x="3936761" y="3558845"/>
+            <a:ext cx="346934" cy="40843"/>
           </a:xfrm>
           <a:prstGeom prst="line">
             <a:avLst/>
@@ -6714,14 +6776,14 @@
       </p:sp>
       <p:sp>
         <p:nvSpPr>
-          <p:cNvPr id="36" name="Shape 30"/>
+          <p:cNvPr id="38" name="Shape 32"/>
           <p:cNvSpPr/>
           <p:nvPr/>
         </p:nvSpPr>
         <p:spPr>
           <a:xfrm flipV="1">
-            <a:off x="4700016" y="3063621"/>
-            <a:ext cx="393192" cy="127635"/>
+            <a:off x="4283695" y="3456737"/>
+            <a:ext cx="346934" cy="102108"/>
           </a:xfrm>
           <a:prstGeom prst="line">
             <a:avLst/>
@@ -6737,14 +6799,14 @@
       </p:sp>
       <p:sp>
         <p:nvSpPr>
-          <p:cNvPr id="37" name="Shape 31"/>
+          <p:cNvPr id="39" name="Shape 33"/>
           <p:cNvSpPr/>
           <p:nvPr/>
         </p:nvSpPr>
         <p:spPr>
           <a:xfrm>
-            <a:off x="5093208" y="3063621"/>
-            <a:ext cx="393192" cy="0"/>
+            <a:off x="4630629" y="3456737"/>
+            <a:ext cx="346934" cy="0"/>
           </a:xfrm>
           <a:prstGeom prst="line">
             <a:avLst/>
@@ -6760,14 +6822,14 @@
       </p:sp>
       <p:sp>
         <p:nvSpPr>
-          <p:cNvPr id="38" name="Shape 32"/>
+          <p:cNvPr id="40" name="Shape 34"/>
           <p:cNvSpPr/>
           <p:nvPr/>
         </p:nvSpPr>
         <p:spPr>
           <a:xfrm flipV="1">
-            <a:off x="5486400" y="2680716"/>
-            <a:ext cx="393192" cy="382905"/>
+            <a:off x="4977563" y="3150413"/>
+            <a:ext cx="346934" cy="306324"/>
           </a:xfrm>
           <a:prstGeom prst="line">
             <a:avLst/>
@@ -6783,14 +6845,14 @@
       </p:sp>
       <p:sp>
         <p:nvSpPr>
-          <p:cNvPr id="39" name="Shape 33"/>
+          <p:cNvPr id="41" name="Shape 35"/>
           <p:cNvSpPr/>
           <p:nvPr/>
         </p:nvSpPr>
         <p:spPr>
           <a:xfrm flipV="1">
-            <a:off x="5879592" y="2629662"/>
-            <a:ext cx="393192" cy="51054"/>
+            <a:off x="5324497" y="3109570"/>
+            <a:ext cx="346934" cy="40843"/>
           </a:xfrm>
           <a:prstGeom prst="line">
             <a:avLst/>
@@ -6806,14 +6868,14 @@
       </p:sp>
       <p:sp>
         <p:nvSpPr>
-          <p:cNvPr id="40" name="Shape 34"/>
+          <p:cNvPr id="42" name="Shape 36"/>
           <p:cNvSpPr/>
           <p:nvPr/>
         </p:nvSpPr>
         <p:spPr>
           <a:xfrm flipV="1">
-            <a:off x="6272784" y="2604135"/>
-            <a:ext cx="393192" cy="25527"/>
+            <a:off x="5671432" y="3089148"/>
+            <a:ext cx="346934" cy="20422"/>
           </a:xfrm>
           <a:prstGeom prst="line">
             <a:avLst/>
@@ -6829,14 +6891,14 @@
       </p:sp>
       <p:sp>
         <p:nvSpPr>
-          <p:cNvPr id="41" name="Shape 35"/>
+          <p:cNvPr id="43" name="Shape 37"/>
           <p:cNvSpPr/>
           <p:nvPr/>
         </p:nvSpPr>
         <p:spPr>
           <a:xfrm flipV="1">
-            <a:off x="6665976" y="2144649"/>
-            <a:ext cx="393192" cy="459486"/>
+            <a:off x="6018366" y="2721559"/>
+            <a:ext cx="346934" cy="367589"/>
           </a:xfrm>
           <a:prstGeom prst="line">
             <a:avLst/>
@@ -6852,13 +6914,59 @@
       </p:sp>
       <p:sp>
         <p:nvSpPr>
-          <p:cNvPr id="42" name="Shape 36"/>
+          <p:cNvPr id="44" name="Shape 38"/>
           <p:cNvSpPr/>
           <p:nvPr/>
         </p:nvSpPr>
         <p:spPr>
-          <a:xfrm>
-            <a:off x="1115568" y="4651629"/>
+          <a:xfrm flipV="1">
+            <a:off x="6365300" y="2578608"/>
+            <a:ext cx="346934" cy="142951"/>
+          </a:xfrm>
+          <a:prstGeom prst="line">
+            <a:avLst/>
+          </a:prstGeom>
+          <a:noFill/>
+          <a:ln w="31750">
+            <a:solidFill>
+              <a:srgbClr val="132257"/>
+            </a:solidFill>
+            <a:prstDash val="solid"/>
+          </a:ln>
+        </p:spPr>
+      </p:sp>
+      <p:sp>
+        <p:nvSpPr>
+          <p:cNvPr id="45" name="Shape 39"/>
+          <p:cNvSpPr/>
+          <p:nvPr/>
+        </p:nvSpPr>
+        <p:spPr>
+          <a:xfrm flipV="1">
+            <a:off x="6712234" y="2374392"/>
+            <a:ext cx="346934" cy="204216"/>
+          </a:xfrm>
+          <a:prstGeom prst="line">
+            <a:avLst/>
+          </a:prstGeom>
+          <a:noFill/>
+          <a:ln w="31750">
+            <a:solidFill>
+              <a:srgbClr val="132257"/>
+            </a:solidFill>
+            <a:prstDash val="solid"/>
+          </a:ln>
+        </p:spPr>
+      </p:sp>
+      <p:sp>
+        <p:nvSpPr>
+          <p:cNvPr id="46" name="Shape 40"/>
+          <p:cNvSpPr/>
+          <p:nvPr/>
+        </p:nvSpPr>
+        <p:spPr>
+          <a:xfrm>
+            <a:off x="1115568" y="4717999"/>
             <a:ext cx="91440" cy="91440"/>
           </a:xfrm>
           <a:prstGeom prst="ellipse">
@@ -6877,7 +6985,7 @@
       </p:sp>
       <p:sp>
         <p:nvSpPr>
-          <p:cNvPr id="43" name="Text 37"/>
+          <p:cNvPr id="47" name="Text 41"/>
           <p:cNvSpPr txBox="1"/>
           <p:nvPr/>
         </p:nvSpPr>
@@ -6916,13 +7024,13 @@
       </p:sp>
       <p:sp>
         <p:nvSpPr>
-          <p:cNvPr id="44" name="Shape 38"/>
+          <p:cNvPr id="48" name="Shape 42"/>
           <p:cNvSpPr/>
           <p:nvPr/>
         </p:nvSpPr>
         <p:spPr>
           <a:xfrm>
-            <a:off x="1508760" y="4243197"/>
+            <a:off x="1462502" y="4391254"/>
             <a:ext cx="91440" cy="91440"/>
           </a:xfrm>
           <a:prstGeom prst="ellipse">
@@ -6941,13 +7049,13 @@
       </p:sp>
       <p:sp>
         <p:nvSpPr>
-          <p:cNvPr id="45" name="Text 39"/>
+          <p:cNvPr id="49" name="Text 43"/>
           <p:cNvSpPr txBox="1"/>
           <p:nvPr/>
         </p:nvSpPr>
         <p:spPr>
           <a:xfrm>
-            <a:off x="1280160" y="5084064"/>
+            <a:off x="1233902" y="5084064"/>
             <a:ext cx="548640" cy="219456"/>
           </a:xfrm>
           <a:prstGeom prst="rect">
@@ -6980,13 +7088,13 @@
       </p:sp>
       <p:sp>
         <p:nvSpPr>
-          <p:cNvPr id="46" name="Shape 40"/>
+          <p:cNvPr id="50" name="Shape 44"/>
           <p:cNvSpPr/>
           <p:nvPr/>
         </p:nvSpPr>
         <p:spPr>
           <a:xfrm>
-            <a:off x="1901952" y="4090035"/>
+            <a:off x="1809436" y="4268724"/>
             <a:ext cx="91440" cy="91440"/>
           </a:xfrm>
           <a:prstGeom prst="ellipse">
@@ -7005,13 +7113,13 @@
       </p:sp>
       <p:sp>
         <p:nvSpPr>
-          <p:cNvPr id="47" name="Text 41"/>
+          <p:cNvPr id="51" name="Text 45"/>
           <p:cNvSpPr txBox="1"/>
           <p:nvPr/>
         </p:nvSpPr>
         <p:spPr>
           <a:xfrm>
-            <a:off x="1673352" y="5084064"/>
+            <a:off x="1580836" y="5084064"/>
             <a:ext cx="548640" cy="219456"/>
           </a:xfrm>
           <a:prstGeom prst="rect">
@@ -7044,13 +7152,13 @@
       </p:sp>
       <p:sp>
         <p:nvSpPr>
-          <p:cNvPr id="48" name="Shape 42"/>
+          <p:cNvPr id="52" name="Shape 46"/>
           <p:cNvSpPr/>
           <p:nvPr/>
         </p:nvSpPr>
         <p:spPr>
           <a:xfrm>
-            <a:off x="2295144" y="3885819"/>
+            <a:off x="2156370" y="4105351"/>
             <a:ext cx="91440" cy="91440"/>
           </a:xfrm>
           <a:prstGeom prst="ellipse">
@@ -7069,13 +7177,13 @@
       </p:sp>
       <p:sp>
         <p:nvSpPr>
-          <p:cNvPr id="49" name="Text 43"/>
+          <p:cNvPr id="53" name="Text 47"/>
           <p:cNvSpPr txBox="1"/>
           <p:nvPr/>
         </p:nvSpPr>
         <p:spPr>
           <a:xfrm>
-            <a:off x="2066544" y="5084064"/>
+            <a:off x="1927770" y="5084064"/>
             <a:ext cx="548640" cy="219456"/>
           </a:xfrm>
           <a:prstGeom prst="rect">
@@ -7108,13 +7216,13 @@
       </p:sp>
       <p:sp>
         <p:nvSpPr>
-          <p:cNvPr id="50" name="Shape 44"/>
+          <p:cNvPr id="54" name="Shape 48"/>
           <p:cNvSpPr/>
           <p:nvPr/>
         </p:nvSpPr>
         <p:spPr>
           <a:xfrm>
-            <a:off x="2688336" y="3707130"/>
+            <a:off x="2503304" y="3962400"/>
             <a:ext cx="91440" cy="91440"/>
           </a:xfrm>
           <a:prstGeom prst="ellipse">
@@ -7133,13 +7241,13 @@
       </p:sp>
       <p:sp>
         <p:nvSpPr>
-          <p:cNvPr id="51" name="Text 45"/>
+          <p:cNvPr id="55" name="Text 49"/>
           <p:cNvSpPr txBox="1"/>
           <p:nvPr/>
         </p:nvSpPr>
         <p:spPr>
           <a:xfrm>
-            <a:off x="2459736" y="5084064"/>
+            <a:off x="2274704" y="5084064"/>
             <a:ext cx="548640" cy="219456"/>
           </a:xfrm>
           <a:prstGeom prst="rect">
@@ -7172,13 +7280,13 @@
       </p:sp>
       <p:sp>
         <p:nvSpPr>
-          <p:cNvPr id="52" name="Shape 46"/>
+          <p:cNvPr id="56" name="Shape 50"/>
           <p:cNvSpPr/>
           <p:nvPr/>
         </p:nvSpPr>
         <p:spPr>
           <a:xfrm>
-            <a:off x="3081528" y="3605022"/>
+            <a:off x="2850239" y="3880714"/>
             <a:ext cx="91440" cy="91440"/>
           </a:xfrm>
           <a:prstGeom prst="ellipse">
@@ -7197,13 +7305,13 @@
       </p:sp>
       <p:sp>
         <p:nvSpPr>
-          <p:cNvPr id="53" name="Text 47"/>
+          <p:cNvPr id="57" name="Text 51"/>
           <p:cNvSpPr txBox="1"/>
           <p:nvPr/>
         </p:nvSpPr>
         <p:spPr>
           <a:xfrm>
-            <a:off x="2852928" y="5084064"/>
+            <a:off x="2621639" y="5084064"/>
             <a:ext cx="548640" cy="219456"/>
           </a:xfrm>
           <a:prstGeom prst="rect">
@@ -7236,13 +7344,13 @@
       </p:sp>
       <p:sp>
         <p:nvSpPr>
-          <p:cNvPr id="54" name="Shape 48"/>
+          <p:cNvPr id="58" name="Shape 52"/>
           <p:cNvSpPr/>
           <p:nvPr/>
         </p:nvSpPr>
         <p:spPr>
           <a:xfrm>
-            <a:off x="3474720" y="3477387"/>
+            <a:off x="3197173" y="3778606"/>
             <a:ext cx="91440" cy="91440"/>
           </a:xfrm>
           <a:prstGeom prst="ellipse">
@@ -7261,13 +7369,13 @@
       </p:sp>
       <p:sp>
         <p:nvSpPr>
-          <p:cNvPr id="55" name="Text 49"/>
+          <p:cNvPr id="59" name="Text 53"/>
           <p:cNvSpPr txBox="1"/>
           <p:nvPr/>
         </p:nvSpPr>
         <p:spPr>
           <a:xfrm>
-            <a:off x="3246120" y="5084064"/>
+            <a:off x="2968573" y="5084064"/>
             <a:ext cx="548640" cy="219456"/>
           </a:xfrm>
           <a:prstGeom prst="rect">
@@ -7300,13 +7408,13 @@
       </p:sp>
       <p:sp>
         <p:nvSpPr>
-          <p:cNvPr id="56" name="Shape 50"/>
+          <p:cNvPr id="60" name="Shape 54"/>
           <p:cNvSpPr/>
           <p:nvPr/>
         </p:nvSpPr>
         <p:spPr>
           <a:xfrm>
-            <a:off x="3867912" y="3375279"/>
+            <a:off x="3544107" y="3696919"/>
             <a:ext cx="91440" cy="91440"/>
           </a:xfrm>
           <a:prstGeom prst="ellipse">
@@ -7325,13 +7433,13 @@
       </p:sp>
       <p:sp>
         <p:nvSpPr>
-          <p:cNvPr id="57" name="Text 51"/>
+          <p:cNvPr id="61" name="Text 55"/>
           <p:cNvSpPr txBox="1"/>
           <p:nvPr/>
         </p:nvSpPr>
         <p:spPr>
           <a:xfrm>
-            <a:off x="3639312" y="5084064"/>
+            <a:off x="3315507" y="5084064"/>
             <a:ext cx="548640" cy="219456"/>
           </a:xfrm>
           <a:prstGeom prst="rect">
@@ -7364,13 +7472,13 @@
       </p:sp>
       <p:sp>
         <p:nvSpPr>
-          <p:cNvPr id="58" name="Shape 52"/>
+          <p:cNvPr id="62" name="Shape 56"/>
           <p:cNvSpPr/>
           <p:nvPr/>
         </p:nvSpPr>
         <p:spPr>
           <a:xfrm>
-            <a:off x="4261104" y="3196590"/>
+            <a:off x="3891041" y="3553968"/>
             <a:ext cx="91440" cy="91440"/>
           </a:xfrm>
           <a:prstGeom prst="ellipse">
@@ -7389,13 +7497,13 @@
       </p:sp>
       <p:sp>
         <p:nvSpPr>
-          <p:cNvPr id="59" name="Text 53"/>
+          <p:cNvPr id="63" name="Text 57"/>
           <p:cNvSpPr txBox="1"/>
           <p:nvPr/>
         </p:nvSpPr>
         <p:spPr>
           <a:xfrm>
-            <a:off x="4032504" y="5084064"/>
+            <a:off x="3662441" y="5084064"/>
             <a:ext cx="548640" cy="219456"/>
           </a:xfrm>
           <a:prstGeom prst="rect">
@@ -7428,13 +7536,13 @@
       </p:sp>
       <p:sp>
         <p:nvSpPr>
-          <p:cNvPr id="60" name="Shape 54"/>
+          <p:cNvPr id="64" name="Shape 58"/>
           <p:cNvSpPr/>
           <p:nvPr/>
         </p:nvSpPr>
         <p:spPr>
           <a:xfrm>
-            <a:off x="4654296" y="3145536"/>
+            <a:off x="4237975" y="3513125"/>
             <a:ext cx="91440" cy="91440"/>
           </a:xfrm>
           <a:prstGeom prst="ellipse">
@@ -7453,13 +7561,13 @@
       </p:sp>
       <p:sp>
         <p:nvSpPr>
-          <p:cNvPr id="61" name="Text 55"/>
+          <p:cNvPr id="65" name="Text 59"/>
           <p:cNvSpPr txBox="1"/>
           <p:nvPr/>
         </p:nvSpPr>
         <p:spPr>
           <a:xfrm>
-            <a:off x="4425696" y="5084064"/>
+            <a:off x="4009375" y="5084064"/>
             <a:ext cx="548640" cy="219456"/>
           </a:xfrm>
           <a:prstGeom prst="rect">
@@ -7492,13 +7600,13 @@
       </p:sp>
       <p:sp>
         <p:nvSpPr>
-          <p:cNvPr id="62" name="Shape 56"/>
+          <p:cNvPr id="66" name="Shape 60"/>
           <p:cNvSpPr/>
           <p:nvPr/>
         </p:nvSpPr>
         <p:spPr>
           <a:xfrm>
-            <a:off x="5047488" y="3017901"/>
+            <a:off x="4584909" y="3411017"/>
             <a:ext cx="91440" cy="91440"/>
           </a:xfrm>
           <a:prstGeom prst="ellipse">
@@ -7517,13 +7625,13 @@
       </p:sp>
       <p:sp>
         <p:nvSpPr>
-          <p:cNvPr id="63" name="Text 57"/>
+          <p:cNvPr id="67" name="Text 61"/>
           <p:cNvSpPr txBox="1"/>
           <p:nvPr/>
         </p:nvSpPr>
         <p:spPr>
           <a:xfrm>
-            <a:off x="4818888" y="5084064"/>
+            <a:off x="4356309" y="5084064"/>
             <a:ext cx="548640" cy="219456"/>
           </a:xfrm>
           <a:prstGeom prst="rect">
@@ -7556,13 +7664,13 @@
       </p:sp>
       <p:sp>
         <p:nvSpPr>
-          <p:cNvPr id="64" name="Shape 58"/>
+          <p:cNvPr id="68" name="Shape 62"/>
           <p:cNvSpPr/>
           <p:nvPr/>
         </p:nvSpPr>
         <p:spPr>
           <a:xfrm>
-            <a:off x="5440680" y="3017901"/>
+            <a:off x="4931843" y="3411017"/>
             <a:ext cx="91440" cy="91440"/>
           </a:xfrm>
           <a:prstGeom prst="ellipse">
@@ -7581,13 +7689,13 @@
       </p:sp>
       <p:sp>
         <p:nvSpPr>
-          <p:cNvPr id="65" name="Text 59"/>
+          <p:cNvPr id="69" name="Text 63"/>
           <p:cNvSpPr txBox="1"/>
           <p:nvPr/>
         </p:nvSpPr>
         <p:spPr>
           <a:xfrm>
-            <a:off x="5212080" y="5084064"/>
+            <a:off x="4703243" y="5084064"/>
             <a:ext cx="548640" cy="219456"/>
           </a:xfrm>
           <a:prstGeom prst="rect">
@@ -7620,13 +7728,13 @@
       </p:sp>
       <p:sp>
         <p:nvSpPr>
-          <p:cNvPr id="66" name="Shape 60"/>
+          <p:cNvPr id="70" name="Shape 64"/>
           <p:cNvSpPr/>
           <p:nvPr/>
         </p:nvSpPr>
         <p:spPr>
           <a:xfrm>
-            <a:off x="5833872" y="2634996"/>
+            <a:off x="5278777" y="3104693"/>
             <a:ext cx="91440" cy="91440"/>
           </a:xfrm>
           <a:prstGeom prst="ellipse">
@@ -7645,13 +7753,13 @@
       </p:sp>
       <p:sp>
         <p:nvSpPr>
-          <p:cNvPr id="67" name="Text 61"/>
+          <p:cNvPr id="71" name="Text 65"/>
           <p:cNvSpPr txBox="1"/>
           <p:nvPr/>
         </p:nvSpPr>
         <p:spPr>
           <a:xfrm>
-            <a:off x="5605272" y="5084064"/>
+            <a:off x="5050177" y="5084064"/>
             <a:ext cx="548640" cy="219456"/>
           </a:xfrm>
           <a:prstGeom prst="rect">
@@ -7684,13 +7792,13 @@
       </p:sp>
       <p:sp>
         <p:nvSpPr>
-          <p:cNvPr id="68" name="Shape 62"/>
+          <p:cNvPr id="72" name="Shape 66"/>
           <p:cNvSpPr/>
           <p:nvPr/>
         </p:nvSpPr>
         <p:spPr>
           <a:xfrm>
-            <a:off x="6227064" y="2583942"/>
+            <a:off x="5625712" y="3063850"/>
             <a:ext cx="91440" cy="91440"/>
           </a:xfrm>
           <a:prstGeom prst="ellipse">
@@ -7709,13 +7817,13 @@
       </p:sp>
       <p:sp>
         <p:nvSpPr>
-          <p:cNvPr id="69" name="Text 63"/>
+          <p:cNvPr id="73" name="Text 67"/>
           <p:cNvSpPr txBox="1"/>
           <p:nvPr/>
         </p:nvSpPr>
         <p:spPr>
           <a:xfrm>
-            <a:off x="5998464" y="5084064"/>
+            <a:off x="5397112" y="5084064"/>
             <a:ext cx="548640" cy="219456"/>
           </a:xfrm>
           <a:prstGeom prst="rect">
@@ -7748,13 +7856,13 @@
       </p:sp>
       <p:sp>
         <p:nvSpPr>
-          <p:cNvPr id="70" name="Shape 64"/>
+          <p:cNvPr id="74" name="Shape 68"/>
           <p:cNvSpPr/>
           <p:nvPr/>
         </p:nvSpPr>
         <p:spPr>
           <a:xfrm>
-            <a:off x="6620256" y="2558415"/>
+            <a:off x="5972646" y="3043428"/>
             <a:ext cx="91440" cy="91440"/>
           </a:xfrm>
           <a:prstGeom prst="ellipse">
@@ -7773,13 +7881,13 @@
       </p:sp>
       <p:sp>
         <p:nvSpPr>
-          <p:cNvPr id="71" name="Text 65"/>
+          <p:cNvPr id="75" name="Text 69"/>
           <p:cNvSpPr txBox="1"/>
           <p:nvPr/>
         </p:nvSpPr>
         <p:spPr>
           <a:xfrm>
-            <a:off x="6391656" y="5084064"/>
+            <a:off x="5744046" y="5084064"/>
             <a:ext cx="548640" cy="219456"/>
           </a:xfrm>
           <a:prstGeom prst="rect">
@@ -7812,13 +7920,13 @@
       </p:sp>
       <p:sp>
         <p:nvSpPr>
-          <p:cNvPr id="72" name="Shape 66"/>
+          <p:cNvPr id="76" name="Shape 70"/>
           <p:cNvSpPr/>
           <p:nvPr/>
         </p:nvSpPr>
         <p:spPr>
           <a:xfrm>
-            <a:off x="7013448" y="2098929"/>
+            <a:off x="6319580" y="2675839"/>
             <a:ext cx="91440" cy="91440"/>
           </a:xfrm>
           <a:prstGeom prst="ellipse">
@@ -7837,7 +7945,135 @@
       </p:sp>
       <p:sp>
         <p:nvSpPr>
-          <p:cNvPr id="73" name="Text 67"/>
+          <p:cNvPr id="77" name="Text 71"/>
+          <p:cNvSpPr txBox="1"/>
+          <p:nvPr/>
+        </p:nvSpPr>
+        <p:spPr>
+          <a:xfrm>
+            <a:off x="6090980" y="5084064"/>
+            <a:ext cx="548640" cy="219456"/>
+          </a:xfrm>
+          <a:prstGeom prst="rect">
+            <a:avLst/>
+          </a:prstGeom>
+          <a:noFill/>
+          <a:ln/>
+        </p:spPr>
+        <p:txBody>
+          <a:bodyPr wrap="square" lIns="0" tIns="0" rIns="0" bIns="0" rtlCol="0" anchor="t"/>
+          <a:lstStyle/>
+          <a:p>
+            <a:pPr algn="ctr" indent="0" marL="0">
+              <a:buNone/>
+            </a:pPr>
+            <a:r>
+              <a:rPr lang="en-US" sz="850" dirty="0">
+                <a:solidFill>
+                  <a:srgbClr val="7A849C"/>
+                </a:solidFill>
+                <a:latin typeface="Exo 2" pitchFamily="34" charset="0"/>
+                <a:ea typeface="Exo 2" pitchFamily="34" charset="-122"/>
+                <a:cs typeface="Exo 2" pitchFamily="34" charset="-120"/>
+              </a:rPr>
+              <a:t>27</a:t>
+            </a:r>
+            <a:endParaRPr lang="en-US" sz="850" dirty="0"/>
+          </a:p>
+        </p:txBody>
+      </p:sp>
+      <p:sp>
+        <p:nvSpPr>
+          <p:cNvPr id="78" name="Shape 72"/>
+          <p:cNvSpPr/>
+          <p:nvPr/>
+        </p:nvSpPr>
+        <p:spPr>
+          <a:xfrm>
+            <a:off x="6666514" y="2532888"/>
+            <a:ext cx="91440" cy="91440"/>
+          </a:xfrm>
+          <a:prstGeom prst="ellipse">
+            <a:avLst/>
+          </a:prstGeom>
+          <a:solidFill>
+            <a:srgbClr val="132257"/>
+          </a:solidFill>
+          <a:ln w="12700">
+            <a:solidFill>
+              <a:srgbClr val="132257"/>
+            </a:solidFill>
+            <a:prstDash val="solid"/>
+          </a:ln>
+        </p:spPr>
+      </p:sp>
+      <p:sp>
+        <p:nvSpPr>
+          <p:cNvPr id="79" name="Text 73"/>
+          <p:cNvSpPr txBox="1"/>
+          <p:nvPr/>
+        </p:nvSpPr>
+        <p:spPr>
+          <a:xfrm>
+            <a:off x="6437914" y="5084064"/>
+            <a:ext cx="548640" cy="219456"/>
+          </a:xfrm>
+          <a:prstGeom prst="rect">
+            <a:avLst/>
+          </a:prstGeom>
+          <a:noFill/>
+          <a:ln/>
+        </p:spPr>
+        <p:txBody>
+          <a:bodyPr wrap="square" lIns="0" tIns="0" rIns="0" bIns="0" rtlCol="0" anchor="t"/>
+          <a:lstStyle/>
+          <a:p>
+            <a:pPr algn="ctr" indent="0" marL="0">
+              <a:buNone/>
+            </a:pPr>
+            <a:r>
+              <a:rPr lang="en-US" sz="850" dirty="0">
+                <a:solidFill>
+                  <a:srgbClr val="7A849C"/>
+                </a:solidFill>
+                <a:latin typeface="Exo 2" pitchFamily="34" charset="0"/>
+                <a:ea typeface="Exo 2" pitchFamily="34" charset="-122"/>
+                <a:cs typeface="Exo 2" pitchFamily="34" charset="-120"/>
+              </a:rPr>
+              <a:t>28</a:t>
+            </a:r>
+            <a:endParaRPr lang="en-US" sz="850" dirty="0"/>
+          </a:p>
+        </p:txBody>
+      </p:sp>
+      <p:sp>
+        <p:nvSpPr>
+          <p:cNvPr id="80" name="Shape 74"/>
+          <p:cNvSpPr/>
+          <p:nvPr/>
+        </p:nvSpPr>
+        <p:spPr>
+          <a:xfrm>
+            <a:off x="7013448" y="2328672"/>
+            <a:ext cx="91440" cy="91440"/>
+          </a:xfrm>
+          <a:prstGeom prst="ellipse">
+            <a:avLst/>
+          </a:prstGeom>
+          <a:solidFill>
+            <a:srgbClr val="132257"/>
+          </a:solidFill>
+          <a:ln w="12700">
+            <a:solidFill>
+              <a:srgbClr val="132257"/>
+            </a:solidFill>
+            <a:prstDash val="solid"/>
+          </a:ln>
+        </p:spPr>
+      </p:sp>
+      <p:sp>
+        <p:nvSpPr>
+          <p:cNvPr id="81" name="Text 75"/>
           <p:cNvSpPr txBox="1"/>
           <p:nvPr/>
         </p:nvSpPr>
@@ -7868,7 +8104,7 @@
                 <a:ea typeface="Exo 2" pitchFamily="34" charset="-122"/>
                 <a:cs typeface="Exo 2" pitchFamily="34" charset="-120"/>
               </a:rPr>
-              <a:t>27 Sep</a:t>
+              <a:t>29 Sep</a:t>
             </a:r>
             <a:endParaRPr lang="en-US" sz="850" dirty="0"/>
           </a:p>
@@ -7876,13 +8112,13 @@
       </p:sp>
       <p:sp>
         <p:nvSpPr>
-          <p:cNvPr id="74" name="Text 68"/>
+          <p:cNvPr id="82" name="Text 76"/>
           <p:cNvSpPr txBox="1"/>
           <p:nvPr/>
         </p:nvSpPr>
         <p:spPr>
           <a:xfrm>
-            <a:off x="5422392" y="5285232"/>
+            <a:off x="4867297" y="5285232"/>
             <a:ext cx="914400" cy="201168"/>
           </a:xfrm>
           <a:prstGeom prst="rect">
@@ -7915,7 +8151,7 @@
       </p:sp>
       <p:sp>
         <p:nvSpPr>
-          <p:cNvPr id="75" name="Text 69"/>
+          <p:cNvPr id="83" name="Text 77"/>
           <p:cNvSpPr txBox="1"/>
           <p:nvPr/>
         </p:nvSpPr>
@@ -7946,7 +8182,7 @@
                 <a:ea typeface="Exo 2" pitchFamily="34" charset="-122"/>
                 <a:cs typeface="Exo 2" pitchFamily="34" charset="-120"/>
               </a:rPr>
-              <a:t>+36 in 6 days</a:t>
+              <a:t>+53 in 8 days</a:t>
             </a:r>
             <a:endParaRPr lang="en-US" sz="1050" dirty="0"/>
           </a:p>
@@ -7963,7 +8199,7 @@
                 <a:ea typeface="Exo 2" pitchFamily="34" charset="-122"/>
                 <a:cs typeface="Exo 2" pitchFamily="34" charset="-120"/>
               </a:rPr>
-              <a:t>21-27 Sep, after launch</a:t>
+              <a:t>21-29 Sep, after launch</a:t>
             </a:r>
             <a:endParaRPr lang="en-US" sz="1050" dirty="0"/>
           </a:p>
@@ -7971,7 +8207,7 @@
       </p:sp>
       <p:sp>
         <p:nvSpPr>
-          <p:cNvPr id="76" name="Text 70"/>
+          <p:cNvPr id="84" name="Text 78"/>
           <p:cNvSpPr txBox="1"/>
           <p:nvPr/>
         </p:nvSpPr>
@@ -8027,7 +8263,7 @@
       </p:sp>
       <p:sp>
         <p:nvSpPr>
-          <p:cNvPr id="77" name="Text 71"/>
+          <p:cNvPr id="85" name="Text 79"/>
           <p:cNvSpPr txBox="1"/>
           <p:nvPr/>
         </p:nvSpPr>
@@ -8066,7 +8302,7 @@
       </p:sp>
       <p:sp>
         <p:nvSpPr>
-          <p:cNvPr id="78" name="Shape 72"/>
+          <p:cNvPr id="86" name="Shape 80"/>
           <p:cNvSpPr/>
           <p:nvPr/>
         </p:nvSpPr>
@@ -8091,7 +8327,7 @@
       </p:sp>
       <p:sp>
         <p:nvSpPr>
-          <p:cNvPr id="79" name="Text 73"/>
+          <p:cNvPr id="87" name="Text 81"/>
           <p:cNvSpPr txBox="1"/>
           <p:nvPr/>
         </p:nvSpPr>
@@ -8130,7 +8366,7 @@
       </p:sp>
       <p:sp>
         <p:nvSpPr>
-          <p:cNvPr id="80" name="Text 74"/>
+          <p:cNvPr id="88" name="Text 82"/>
           <p:cNvSpPr txBox="1"/>
           <p:nvPr/>
         </p:nvSpPr>
@@ -8186,7 +8422,7 @@
       </p:sp>
       <p:sp>
         <p:nvSpPr>
-          <p:cNvPr id="81" name="Shape 75"/>
+          <p:cNvPr id="89" name="Shape 83"/>
           <p:cNvSpPr/>
           <p:nvPr/>
         </p:nvSpPr>
@@ -8211,7 +8447,7 @@
       </p:sp>
       <p:sp>
         <p:nvSpPr>
-          <p:cNvPr id="82" name="Text 76"/>
+          <p:cNvPr id="90" name="Text 84"/>
           <p:cNvSpPr txBox="1"/>
           <p:nvPr/>
         </p:nvSpPr>
@@ -8250,7 +8486,7 @@
       </p:sp>
       <p:sp>
         <p:nvSpPr>
-          <p:cNvPr id="83" name="Text 77"/>
+          <p:cNvPr id="91" name="Text 85"/>
           <p:cNvSpPr txBox="1"/>
           <p:nvPr/>
         </p:nvSpPr>
@@ -8306,7 +8542,7 @@
       </p:sp>
       <p:sp>
         <p:nvSpPr>
-          <p:cNvPr id="84" name="Shape 78"/>
+          <p:cNvPr id="92" name="Shape 86"/>
           <p:cNvSpPr/>
           <p:nvPr/>
         </p:nvSpPr>
@@ -8331,7 +8567,7 @@
       </p:sp>
       <p:sp>
         <p:nvSpPr>
-          <p:cNvPr id="85" name="Text 79"/>
+          <p:cNvPr id="93" name="Text 87"/>
           <p:cNvSpPr txBox="1"/>
           <p:nvPr/>
         </p:nvSpPr>
@@ -8362,7 +8598,7 @@
                 <a:ea typeface="Exo 2" pitchFamily="34" charset="-122"/>
                 <a:cs typeface="Exo 2" pitchFamily="34" charset="-120"/>
               </a:rPr>
-              <a:t>+36</a:t>
+              <a:t>+53</a:t>
             </a:r>
             <a:endParaRPr lang="en-US" sz="2200" dirty="0"/>
           </a:p>
@@ -8370,7 +8606,7 @@
       </p:sp>
       <p:sp>
         <p:nvSpPr>
-          <p:cNvPr id="86" name="Text 80"/>
+          <p:cNvPr id="94" name="Text 88"/>
           <p:cNvSpPr txBox="1"/>
           <p:nvPr/>
         </p:nvSpPr>
@@ -8401,7 +8637,7 @@
                 <a:ea typeface="Exo 2" pitchFamily="34" charset="-122"/>
                 <a:cs typeface="Exo 2" pitchFamily="34" charset="-120"/>
               </a:rPr>
-              <a:t>app installs, 21-27 Sep</a:t>
+              <a:t>app installs, 21-29 Sep</a:t>
             </a:r>
             <a:endParaRPr lang="en-US" sz="1000" dirty="0"/>
           </a:p>
@@ -8426,7 +8662,7 @@
       </p:sp>
       <p:sp>
         <p:nvSpPr>
-          <p:cNvPr id="87" name="Shape 81"/>
+          <p:cNvPr id="95" name="Shape 89"/>
           <p:cNvSpPr/>
           <p:nvPr/>
         </p:nvSpPr>
@@ -8451,7 +8687,7 @@
       </p:sp>
       <p:sp>
         <p:nvSpPr>
-          <p:cNvPr id="88" name="Text 82"/>
+          <p:cNvPr id="96" name="Text 90"/>
           <p:cNvSpPr txBox="1"/>
           <p:nvPr/>
         </p:nvSpPr>
@@ -8482,7 +8718,7 @@
                 <a:ea typeface="Exo 2" pitchFamily="34" charset="-122"/>
                 <a:cs typeface="Exo 2" pitchFamily="34" charset="-120"/>
               </a:rPr>
-              <a:t>+3</a:t>
+              <a:t>+4</a:t>
             </a:r>
             <a:endParaRPr lang="en-US" sz="2200" dirty="0"/>
           </a:p>
@@ -8490,7 +8726,7 @@
       </p:sp>
       <p:sp>
         <p:nvSpPr>
-          <p:cNvPr id="89" name="Text 83"/>
+          <p:cNvPr id="97" name="Text 91"/>
           <p:cNvSpPr txBox="1"/>
           <p:nvPr/>
         </p:nvSpPr>
@@ -8521,7 +8757,7 @@
                 <a:ea typeface="Exo 2" pitchFamily="34" charset="-122"/>
                 <a:cs typeface="Exo 2" pitchFamily="34" charset="-120"/>
               </a:rPr>
-              <a:t>onboarded, 21-27 Sep</a:t>
+              <a:t>onboarded, 21-29 Sep</a:t>
             </a:r>
             <a:endParaRPr lang="en-US" sz="1000" dirty="0"/>
           </a:p>
@@ -8546,7 +8782,7 @@
       </p:sp>
       <p:sp>
         <p:nvSpPr>
-          <p:cNvPr id="90" name="Shape 84"/>
+          <p:cNvPr id="98" name="Shape 92"/>
           <p:cNvSpPr/>
           <p:nvPr/>
         </p:nvSpPr>
@@ -8569,7 +8805,7 @@
       </p:sp>
       <p:sp>
         <p:nvSpPr>
-          <p:cNvPr id="91" name="Text 85"/>
+          <p:cNvPr id="99" name="Text 93"/>
           <p:cNvSpPr txBox="1"/>
           <p:nvPr/>
         </p:nvSpPr>

</xml_diff>